<commit_message>
Apply final edit list to Followmont deck
- title slide carries student identification and unit/assignment detail
- client slide quotes the provocation verbatim with attribution
- Prompt 2 output names the six interventions
- Prompt 3 CRAAP swaps Currency for Purpose (vendor naming)
- validation slide completed: all four claims checked, with the price
  range unsupported by either Australian supplier and the 55+ block
  contradicted by the 55-64 / 65+ participation split
- final CRAAP leads Relevance with the unverified depot assumptions
- recommendation names the two trial measures
- references slide expanded, including GenAI acknowledgement

Co-Authored-By: Claude Opus 5 <noreply@anthropic.com>
Claude-Session: https://claude.ai/code/session_01QGa9ZiBbTVxLmBFpqCsLHX
</commit_message>
<xml_diff>
--- a/Followmont-Prompt-Chain.pptx
+++ b/Followmont-Prompt-Chain.pptx
@@ -602,7 +602,7 @@
           <a:p>
             <a:r>
               <a:rPr lang="en-US" dirty="0"/>
-              <a:t>This is the validation slide — the difference between reporting what the AI said and checking whether it is true. Say out loud which links resolved and which did not.</a:t>
+              <a:t>This is the validation slide. Land row 3 and row 4 hardest — the price range is not supported by either Australian supplier, and the 55+ block collapses two very different participation rates.</a:t>
             </a:r>
             <a:endParaRPr lang="en-US" dirty="0"/>
           </a:p>
@@ -1042,7 +1042,7 @@
           <a:p>
             <a:r>
               <a:rPr lang="en-US" dirty="0"/>
-              <a:t>Set up the client quickly. The 55+ card is the whole reason the project exists.</a:t>
+              <a:t>Read the provocation aloud, word for word. It is the client's wording, not mine — note that it says participation, which is broader than retention.</a:t>
             </a:r>
             <a:endParaRPr lang="en-US" dirty="0"/>
           </a:p>
@@ -2091,32 +2091,71 @@
         </p:nvSpPr>
         <p:spPr>
           <a:xfrm>
-            <a:off x="640080" y="5532120"/>
-            <a:ext cx="6400800" cy="320040"/>
-          </a:xfrm>
-          <a:prstGeom prst="rect">
-            <a:avLst/>
-          </a:prstGeom>
-          <a:noFill/>
-          <a:ln/>
-        </p:spPr>
-        <p:txBody>
-          <a:bodyPr wrap="square" lIns="0" tIns="0" rIns="0" bIns="0" rtlCol="0" anchor="ctr"/>
-          <a:lstStyle/>
-          <a:p>
-            <a:pPr indent="0" marL="0">
-              <a:buNone/>
-            </a:pPr>
-            <a:r>
-              <a:rPr lang="en-US" sz="1300" dirty="0">
-                <a:solidFill>
-                  <a:srgbClr val="9A928C"/>
+            <a:off x="640080" y="5349240"/>
+            <a:ext cx="7315200" cy="320040"/>
+          </a:xfrm>
+          <a:prstGeom prst="rect">
+            <a:avLst/>
+          </a:prstGeom>
+          <a:noFill/>
+          <a:ln/>
+        </p:spPr>
+        <p:txBody>
+          <a:bodyPr wrap="square" lIns="0" tIns="0" rIns="0" bIns="0" rtlCol="0" anchor="ctr"/>
+          <a:lstStyle/>
+          <a:p>
+            <a:pPr indent="0" marL="0">
+              <a:buNone/>
+            </a:pPr>
+            <a:r>
+              <a:rPr lang="en-US" sz="1400" b="1" dirty="0">
+                <a:solidFill>
+                  <a:srgbClr val="C6BEB8"/>
                 </a:solidFill>
                 <a:latin typeface="Calibri" pitchFamily="34" charset="0"/>
                 <a:ea typeface="Calibri" pitchFamily="34" charset="-122"/>
                 <a:cs typeface="Calibri" pitchFamily="34" charset="-120"/>
               </a:rPr>
-              <a:t>[Your name]  ·  [Unit code]  ·  [Date]</a:t>
+              <a:t>Daniel Franco Gomez  ·  [Student number]</a:t>
+            </a:r>
+            <a:endParaRPr lang="en-US" sz="1400" dirty="0"/>
+          </a:p>
+        </p:txBody>
+      </p:sp>
+      <p:sp>
+        <p:nvSpPr>
+          <p:cNvPr id="6" name="Text 4"/>
+          <p:cNvSpPr/>
+          <p:nvPr/>
+        </p:nvSpPr>
+        <p:spPr>
+          <a:xfrm>
+            <a:off x="640080" y="5715000"/>
+            <a:ext cx="9601200" cy="320040"/>
+          </a:xfrm>
+          <a:prstGeom prst="rect">
+            <a:avLst/>
+          </a:prstGeom>
+          <a:noFill/>
+          <a:ln/>
+        </p:spPr>
+        <p:txBody>
+          <a:bodyPr wrap="square" lIns="0" tIns="0" rIns="0" bIns="0" rtlCol="0" anchor="ctr"/>
+          <a:lstStyle/>
+          <a:p>
+            <a:pPr indent="0" marL="0">
+              <a:buNone/>
+            </a:pPr>
+            <a:r>
+              <a:rPr lang="en-US" sz="1300" dirty="0">
+                <a:solidFill>
+                  <a:srgbClr val="9A928C"/>
+                </a:solidFill>
+                <a:latin typeface="Calibri" pitchFamily="34" charset="0"/>
+                <a:ea typeface="Calibri" pitchFamily="34" charset="-122"/>
+                <a:cs typeface="Calibri" pitchFamily="34" charset="-120"/>
+              </a:rPr>
+              <a:t>BSB105 The Future Enterprise  ·  Assignment 1: Oral Critique of AI-generated Content</a:t>
             </a:r>
             <a:endParaRPr lang="en-US" sz="1300" dirty="0"/>
           </a:p>
@@ -2412,7 +2451,7 @@
                 <a:ea typeface="Calibri" pitchFamily="34" charset="-122"/>
                 <a:cs typeface="Calibri" pitchFamily="34" charset="-120"/>
               </a:rPr>
-              <a:t>Manual handling is the dominant injury burden in this industry</a:t>
+              <a:t>Manual handling is the dominant injury burden across Australian workplaces</a:t>
             </a:r>
             <a:endParaRPr lang="en-US" sz="1300" dirty="0"/>
           </a:p>
@@ -2441,12 +2480,12 @@
           <a:p>
             <a:pPr indent="0" marL="0">
               <a:lnSpc>
-                <a:spcPts val="1700"/>
+                <a:spcPts val="1600"/>
               </a:lnSpc>
               <a:buNone/>
             </a:pPr>
             <a:r>
-              <a:rPr lang="en-US" sz="1250" dirty="0">
+              <a:rPr lang="en-US" sz="1200" dirty="0">
                 <a:solidFill>
                   <a:srgbClr val="7A736E"/>
                 </a:solidFill>
@@ -2454,9 +2493,9 @@
                 <a:ea typeface="Calibri" pitchFamily="34" charset="-122"/>
                 <a:cs typeface="Calibri" pitchFamily="34" charset="-120"/>
               </a:rPr>
-              <a:t>Safe Work Australia, Key WHS Statistics</a:t>
-            </a:r>
-            <a:endParaRPr lang="en-US" sz="1250" dirty="0"/>
+              <a:t>Safe Work Australia, Key WHS Statistics (2025 release)</a:t>
+            </a:r>
+            <a:endParaRPr lang="en-US" sz="1200" dirty="0"/>
           </a:p>
         </p:txBody>
       </p:sp>
@@ -2483,12 +2522,12 @@
           <a:p>
             <a:pPr indent="0" marL="0">
               <a:lnSpc>
-                <a:spcPts val="1700"/>
+                <a:spcPts val="1600"/>
               </a:lnSpc>
               <a:buNone/>
             </a:pPr>
             <a:r>
-              <a:rPr lang="en-US" sz="1250" b="1" dirty="0">
+              <a:rPr lang="en-US" sz="1200" b="1" dirty="0">
                 <a:solidFill>
                   <a:srgbClr val="4A6B4A"/>
                 </a:solidFill>
@@ -2498,7 +2537,7 @@
               </a:rPr>
               <a:t>Supported — body stressing was 34.5% of serious claims in 2023–24</a:t>
             </a:r>
-            <a:endParaRPr lang="en-US" sz="1250" dirty="0"/>
+            <a:endParaRPr lang="en-US" sz="1200" dirty="0"/>
           </a:p>
         </p:txBody>
       </p:sp>
@@ -2594,22 +2633,22 @@
           <a:p>
             <a:pPr indent="0" marL="0">
               <a:lnSpc>
-                <a:spcPts val="1700"/>
+                <a:spcPts val="1600"/>
               </a:lnSpc>
               <a:buNone/>
             </a:pPr>
             <a:r>
-              <a:rPr lang="en-US" sz="1250" i="1" dirty="0">
-                <a:solidFill>
-                  <a:srgbClr val="9A5F58"/>
+              <a:rPr lang="en-US" sz="1200" dirty="0">
+                <a:solidFill>
+                  <a:srgbClr val="7A736E"/>
                 </a:solidFill>
                 <a:latin typeface="Calibri" pitchFamily="34" charset="0"/>
                 <a:ea typeface="Calibri" pitchFamily="34" charset="-122"/>
                 <a:cs typeface="Calibri" pitchFamily="34" charset="-120"/>
               </a:rPr>
-              <a:t>[The study the AI named — does it exist?]</a:t>
-            </a:r>
-            <a:endParaRPr lang="en-US" sz="1250" dirty="0"/>
+              <a:t>Peer-reviewed EMG studies, 2021–2025 (Europe, US)</a:t>
+            </a:r>
+            <a:endParaRPr lang="en-US" sz="1200" dirty="0"/>
           </a:p>
         </p:txBody>
       </p:sp>
@@ -2636,22 +2675,22 @@
           <a:p>
             <a:pPr indent="0" marL="0">
               <a:lnSpc>
-                <a:spcPts val="1700"/>
+                <a:spcPts val="1600"/>
               </a:lnSpc>
               <a:buNone/>
             </a:pPr>
             <a:r>
-              <a:rPr lang="en-US" sz="1250" i="1" dirty="0">
-                <a:solidFill>
-                  <a:srgbClr val="9A5F58"/>
+              <a:rPr lang="en-US" sz="1200" b="1" dirty="0">
+                <a:solidFill>
+                  <a:srgbClr val="7A6A2B"/>
                 </a:solidFill>
                 <a:latin typeface="Calibri" pitchFamily="34" charset="0"/>
                 <a:ea typeface="Calibri" pitchFamily="34" charset="-122"/>
                 <a:cs typeface="Calibri" pitchFamily="34" charset="-120"/>
               </a:rPr>
-              <a:t>[Your verdict: lab or field? Australian or overseas?]</a:t>
-            </a:r>
-            <a:endParaRPr lang="en-US" sz="1250" dirty="0"/>
+              <a:t>Qualified — the range holds, but every trial is laboratory-based, none Australian, and individual results vary widely</a:t>
+            </a:r>
+            <a:endParaRPr lang="en-US" sz="1200" dirty="0"/>
           </a:p>
         </p:txBody>
       </p:sp>
@@ -2747,22 +2786,22 @@
           <a:p>
             <a:pPr indent="0" marL="0">
               <a:lnSpc>
-                <a:spcPts val="1700"/>
+                <a:spcPts val="1600"/>
               </a:lnSpc>
               <a:buNone/>
             </a:pPr>
             <a:r>
-              <a:rPr lang="en-US" sz="1250" i="1" dirty="0">
-                <a:solidFill>
-                  <a:srgbClr val="9A5F58"/>
+              <a:rPr lang="en-US" sz="1200" dirty="0">
+                <a:solidFill>
+                  <a:srgbClr val="7A736E"/>
                 </a:solidFill>
                 <a:latin typeface="Calibri" pitchFamily="34" charset="0"/>
                 <a:ea typeface="Calibri" pitchFamily="34" charset="-122"/>
                 <a:cs typeface="Calibri" pitchFamily="34" charset="-120"/>
               </a:rPr>
-              <a:t>[Vendor pricing pages]</a:t>
-            </a:r>
-            <a:endParaRPr lang="en-US" sz="1250" dirty="0"/>
+              <a:t>SpanSet Australia; Exxovantage — the AU suppliers</a:t>
+            </a:r>
+            <a:endParaRPr lang="en-US" sz="1200" dirty="0"/>
           </a:p>
         </p:txBody>
       </p:sp>
@@ -2789,22 +2828,22 @@
           <a:p>
             <a:pPr indent="0" marL="0">
               <a:lnSpc>
-                <a:spcPts val="1700"/>
+                <a:spcPts val="1600"/>
               </a:lnSpc>
               <a:buNone/>
             </a:pPr>
             <a:r>
-              <a:rPr lang="en-US" sz="1250" i="1" dirty="0">
-                <a:solidFill>
-                  <a:srgbClr val="9A5F58"/>
+              <a:rPr lang="en-US" sz="1200" b="1" dirty="0">
+                <a:solidFill>
+                  <a:srgbClr val="9A3F33"/>
                 </a:solidFill>
                 <a:latin typeface="Calibri" pitchFamily="34" charset="0"/>
                 <a:ea typeface="Calibri" pitchFamily="34" charset="-122"/>
                 <a:cs typeface="Calibri" pitchFamily="34" charset="-120"/>
               </a:rPr>
-              <a:t>[Your verdict — did any vendor confirm this range?]</a:t>
-            </a:r>
-            <a:endParaRPr lang="en-US" sz="1250" dirty="0"/>
+              <a:t>Not supported — neither publishes a price, and secondary sources put passive units well above A$5,000</a:t>
+            </a:r>
+            <a:endParaRPr lang="en-US" sz="1200" dirty="0"/>
           </a:p>
         </p:txBody>
       </p:sp>
@@ -2871,7 +2910,7 @@
                 <a:ea typeface="Calibri" pitchFamily="34" charset="-122"/>
                 <a:cs typeface="Calibri" pitchFamily="34" charset="-120"/>
               </a:rPr>
-              <a:t>Older workers' participation in transport is falling</a:t>
+              <a:t>“55+” is a single workforce group</a:t>
             </a:r>
             <a:endParaRPr lang="en-US" sz="1300" dirty="0"/>
           </a:p>
@@ -2900,22 +2939,22 @@
           <a:p>
             <a:pPr indent="0" marL="0">
               <a:lnSpc>
-                <a:spcPts val="1700"/>
+                <a:spcPts val="1600"/>
               </a:lnSpc>
               <a:buNone/>
             </a:pPr>
             <a:r>
-              <a:rPr lang="en-US" sz="1250" i="1" dirty="0">
-                <a:solidFill>
-                  <a:srgbClr val="9A5F58"/>
+              <a:rPr lang="en-US" sz="1200" dirty="0">
+                <a:solidFill>
+                  <a:srgbClr val="7A736E"/>
                 </a:solidFill>
                 <a:latin typeface="Calibri" pitchFamily="34" charset="0"/>
                 <a:ea typeface="Calibri" pitchFamily="34" charset="-122"/>
                 <a:cs typeface="Calibri" pitchFamily="34" charset="-120"/>
               </a:rPr>
-              <a:t>[ABS / Jobs and Skills Australia]</a:t>
-            </a:r>
-            <a:endParaRPr lang="en-US" sz="1250" dirty="0"/>
+              <a:t>Jobs and Skills Australia; ABS (Lecture 4)</a:t>
+            </a:r>
+            <a:endParaRPr lang="en-US" sz="1200" dirty="0"/>
           </a:p>
         </p:txBody>
       </p:sp>
@@ -2942,22 +2981,22 @@
           <a:p>
             <a:pPr indent="0" marL="0">
               <a:lnSpc>
-                <a:spcPts val="1700"/>
+                <a:spcPts val="1600"/>
               </a:lnSpc>
               <a:buNone/>
             </a:pPr>
             <a:r>
-              <a:rPr lang="en-US" sz="1250" i="1" dirty="0">
-                <a:solidFill>
-                  <a:srgbClr val="9A5F58"/>
+              <a:rPr lang="en-US" sz="1200" b="1" dirty="0">
+                <a:solidFill>
+                  <a:srgbClr val="9A3F33"/>
                 </a:solidFill>
                 <a:latin typeface="Calibri" pitchFamily="34" charset="0"/>
                 <a:ea typeface="Calibri" pitchFamily="34" charset="-122"/>
                 <a:cs typeface="Calibri" pitchFamily="34" charset="-120"/>
               </a:rPr>
-              <a:t>[Your verdict against the Lecture 4 data]</a:t>
-            </a:r>
-            <a:endParaRPr lang="en-US" sz="1250" dirty="0"/>
+              <a:t>Contradicted — participation is 69.6% at 55–64 but 16.3% at 65+: one label, two different problems</a:t>
+            </a:r>
+            <a:endParaRPr lang="en-US" sz="1200" dirty="0"/>
           </a:p>
         </p:txBody>
       </p:sp>
@@ -2994,7 +3033,7 @@
                 <a:ea typeface="Calibri" pitchFamily="34" charset="-122"/>
                 <a:cs typeface="Calibri" pitchFamily="34" charset="-120"/>
               </a:rPr>
-              <a:t>Source: Safe Work Australia, Key Work Health and Safety Statistics Australia (2025 release, 2023–24 data). Remaining rows to be completed with your own checks.</a:t>
+              <a:t>Sources: Safe Work Australia (2025); Jobs and Skills Australia and ABS via BSB105 Lecture 4; SpanSet Australia and Exxovantage product pages; peer-reviewed EMG studies 2021–2025. Full details on the references slide.</a:t>
             </a:r>
             <a:endParaRPr lang="en-US" sz="1050" dirty="0"/>
           </a:p>
@@ -3212,7 +3251,7 @@
                 <a:ea typeface="Calibri" pitchFamily="34" charset="-122"/>
                 <a:cs typeface="Calibri" pitchFamily="34" charset="-120"/>
               </a:rPr>
-              <a:t>The briefing is undated. Its evidence is post-2022 only where I forced the year to be stated — and one study was older than the instruction allowed.</a:t>
+              <a:t>The briefing carries no date of its own, and years appeared only where I forced them. The exoskeleton studies I could trace run 2021–2025, straddling the post-2022 line I set.</a:t>
             </a:r>
             <a:endParaRPr lang="en-US" sz="1350" dirty="0"/>
           </a:p>
@@ -3320,7 +3359,7 @@
                 <a:ea typeface="Calibri" pitchFamily="34" charset="-122"/>
                 <a:cs typeface="Calibri" pitchFamily="34" charset="-120"/>
               </a:rPr>
-              <a:t>Directly answers the decision in front of the leadership team, at the length they would read. It assumes the depot conditions I supplied; it verified none of them.</a:t>
+              <a:t>It assumes the depot conditions I supplied; it verified none of them. It does answer the decision in front of the leadership team, at the length they would read.</a:t>
             </a:r>
             <a:endParaRPr lang="en-US" sz="1350" dirty="0"/>
           </a:p>
@@ -3536,7 +3575,7 @@
                 <a:ea typeface="Calibri" pitchFamily="34" charset="-122"/>
                 <a:cs typeface="Calibri" pitchFamily="34" charset="-120"/>
               </a:rPr>
-              <a:t>Roughly half the figures survived the Prompt 4 challenge. The unsupported ones remain, labelled as unsupported, rather than removed.</a:t>
+              <a:t>Checked independently, the muscle-activity range broadly holds but the costing does not — no Australian supplier publishes a price in that band. Unsupported figures stayed in, labelled.</a:t>
             </a:r>
             <a:endParaRPr lang="en-US" sz="1350" dirty="0"/>
           </a:p>
@@ -3830,7 +3869,7 @@
         </p:nvSpPr>
         <p:spPr>
           <a:xfrm>
-            <a:off x="640080" y="2788920"/>
+            <a:off x="640080" y="2697480"/>
             <a:ext cx="502920" cy="22860"/>
           </a:xfrm>
           <a:prstGeom prst="rect">
@@ -3850,7 +3889,7 @@
         </p:nvSpPr>
         <p:spPr>
           <a:xfrm>
-            <a:off x="640080" y="3017520"/>
+            <a:off x="640080" y="2907792"/>
             <a:ext cx="3383280" cy="320040"/>
           </a:xfrm>
           <a:prstGeom prst="rect">
@@ -3889,7 +3928,7 @@
         </p:nvSpPr>
         <p:spPr>
           <a:xfrm>
-            <a:off x="640080" y="3364992"/>
+            <a:off x="640080" y="3255264"/>
             <a:ext cx="3383280" cy="640080"/>
           </a:xfrm>
           <a:prstGeom prst="rect">
@@ -3931,7 +3970,7 @@
         </p:nvSpPr>
         <p:spPr>
           <a:xfrm>
-            <a:off x="4361688" y="2788920"/>
+            <a:off x="4361688" y="2697480"/>
             <a:ext cx="502920" cy="22860"/>
           </a:xfrm>
           <a:prstGeom prst="rect">
@@ -3951,7 +3990,7 @@
         </p:nvSpPr>
         <p:spPr>
           <a:xfrm>
-            <a:off x="4361688" y="3017520"/>
+            <a:off x="4361688" y="2907792"/>
             <a:ext cx="3383280" cy="320040"/>
           </a:xfrm>
           <a:prstGeom prst="rect">
@@ -3990,7 +4029,7 @@
         </p:nvSpPr>
         <p:spPr>
           <a:xfrm>
-            <a:off x="4361688" y="3364992"/>
+            <a:off x="4361688" y="3255264"/>
             <a:ext cx="3383280" cy="640080"/>
           </a:xfrm>
           <a:prstGeom prst="rect">
@@ -4032,7 +4071,7 @@
         </p:nvSpPr>
         <p:spPr>
           <a:xfrm>
-            <a:off x="8083296" y="2788920"/>
+            <a:off x="8083296" y="2697480"/>
             <a:ext cx="502920" cy="22860"/>
           </a:xfrm>
           <a:prstGeom prst="rect">
@@ -4052,7 +4091,7 @@
         </p:nvSpPr>
         <p:spPr>
           <a:xfrm>
-            <a:off x="8083296" y="3017520"/>
+            <a:off x="8083296" y="2907792"/>
             <a:ext cx="3383280" cy="320040"/>
           </a:xfrm>
           <a:prstGeom prst="rect">
@@ -4091,7 +4130,7 @@
         </p:nvSpPr>
         <p:spPr>
           <a:xfrm>
-            <a:off x="8083296" y="3364992"/>
+            <a:off x="8083296" y="3255264"/>
             <a:ext cx="3383280" cy="640080"/>
           </a:xfrm>
           <a:prstGeom prst="rect">
@@ -4133,12 +4172,12 @@
         </p:nvSpPr>
         <p:spPr>
           <a:xfrm>
-            <a:off x="640080" y="4206240"/>
-            <a:ext cx="10881360" cy="1965960"/>
+            <a:off x="640080" y="4069080"/>
+            <a:ext cx="10881360" cy="2194560"/>
           </a:xfrm>
           <a:prstGeom prst="roundRect">
             <a:avLst>
-              <a:gd name="adj" fmla="val 3721"/>
+              <a:gd name="adj" fmla="val 3333"/>
             </a:avLst>
           </a:prstGeom>
           <a:solidFill>
@@ -4155,7 +4194,7 @@
         </p:nvSpPr>
         <p:spPr>
           <a:xfrm>
-            <a:off x="1051560" y="4407408"/>
+            <a:off x="1051560" y="4279392"/>
             <a:ext cx="10058400" cy="274320"/>
           </a:xfrm>
           <a:prstGeom prst="rect">
@@ -4194,7 +4233,7 @@
         </p:nvSpPr>
         <p:spPr>
           <a:xfrm>
-            <a:off x="1051560" y="4718304"/>
+            <a:off x="1051560" y="4590288"/>
             <a:ext cx="10058400" cy="411480"/>
           </a:xfrm>
           <a:prstGeom prst="rect">
@@ -4233,8 +4272,8 @@
         </p:nvSpPr>
         <p:spPr>
           <a:xfrm>
-            <a:off x="1051560" y="5193792"/>
-            <a:ext cx="10058400" cy="868680"/>
+            <a:off x="1051560" y="5084064"/>
+            <a:ext cx="10058400" cy="1097280"/>
           </a:xfrm>
           <a:prstGeom prst="rect">
             <a:avLst/>
@@ -4248,12 +4287,12 @@
           <a:p>
             <a:pPr indent="0" marL="0">
               <a:lnSpc>
-                <a:spcPts val="2000"/>
+                <a:spcPts val="1900"/>
               </a:lnSpc>
               <a:buNone/>
             </a:pPr>
             <a:r>
-              <a:rPr lang="en-US" sz="1400" dirty="0">
+              <a:rPr lang="en-US" sz="1350" dirty="0">
                 <a:solidFill>
                   <a:srgbClr val="FCEFEC"/>
                 </a:solidFill>
@@ -4261,9 +4300,9 @@
                 <a:ea typeface="Calibri" pitchFamily="34" charset="-122"/>
                 <a:cs typeface="Calibri" pitchFamily="34" charset="-120"/>
               </a:rPr>
-              <a:t>The barrier the AI identified is real and independently confirmed. The technology it recommended is not yet proven for Australian road freight — the evidence is thin, largely from overseas laboratories, and partly unsourced. One depot, measures agreed before the start, and a go/no-go decision at six months turns an unproven recommendation into something Followmont can actually test.</a:t>
-            </a:r>
-            <a:endParaRPr lang="en-US" sz="1400" dirty="0"/>
+              <a:t>The barrier is real and independently confirmed. The technology is not yet proven for Australian road freight — laboratory evidence from overseas, and a price range no Australian supplier supports. Trial it at one depot for six months against two measures baselined before the start: body-stressing claims and time-loss days. That turns an unproven recommendation into something Followmont can actually test.</a:t>
+            </a:r>
+            <a:endParaRPr lang="en-US" sz="1350" dirty="0"/>
           </a:p>
         </p:txBody>
       </p:sp>
@@ -4346,8 +4385,8 @@
         </p:nvSpPr>
         <p:spPr>
           <a:xfrm>
-            <a:off x="640080" y="1691640"/>
-            <a:ext cx="3566160" cy="365760"/>
+            <a:off x="640080" y="1572768"/>
+            <a:ext cx="3108960" cy="320040"/>
           </a:xfrm>
           <a:prstGeom prst="rect">
             <a:avLst/>
@@ -4363,7 +4402,7 @@
               <a:buNone/>
             </a:pPr>
             <a:r>
-              <a:rPr lang="en-US" sz="1600" b="1" dirty="0">
+              <a:rPr lang="en-US" sz="1450" b="1" dirty="0">
                 <a:solidFill>
                   <a:srgbClr val="B85042"/>
                 </a:solidFill>
@@ -4371,9 +4410,9 @@
                 <a:ea typeface="Cambria" pitchFamily="34" charset="-122"/>
                 <a:cs typeface="Cambria" pitchFamily="34" charset="-120"/>
               </a:rPr>
-              <a:t>CRAAP test framework</a:t>
-            </a:r>
-            <a:endParaRPr lang="en-US" sz="1600" dirty="0"/>
+              <a:t>CRAAP test</a:t>
+            </a:r>
+            <a:endParaRPr lang="en-US" sz="1450" dirty="0"/>
           </a:p>
         </p:txBody>
       </p:sp>
@@ -4385,8 +4424,8 @@
         </p:nvSpPr>
         <p:spPr>
           <a:xfrm>
-            <a:off x="4297680" y="1691640"/>
-            <a:ext cx="7223760" cy="685800"/>
+            <a:off x="3840480" y="1572768"/>
+            <a:ext cx="7680960" cy="566928"/>
           </a:xfrm>
           <a:prstGeom prst="rect">
             <a:avLst/>
@@ -4400,12 +4439,12 @@
           <a:p>
             <a:pPr indent="0" marL="0">
               <a:lnSpc>
-                <a:spcPts val="1900"/>
+                <a:spcPts val="1700"/>
               </a:lnSpc>
               <a:buNone/>
             </a:pPr>
             <a:r>
-              <a:rPr lang="en-US" sz="1400" dirty="0">
+              <a:rPr lang="en-US" sz="1250" dirty="0">
                 <a:solidFill>
                   <a:srgbClr val="2E2A28"/>
                 </a:solidFill>
@@ -4413,9 +4452,9 @@
                 <a:ea typeface="Calibri" pitchFamily="34" charset="-122"/>
                 <a:cs typeface="Calibri" pitchFamily="34" charset="-120"/>
               </a:rPr>
-              <a:t>EdResearch (2022). [Complete reference — Tutorial 3 reading.]</a:t>
-            </a:r>
-            <a:endParaRPr lang="en-US" sz="1400" dirty="0"/>
+              <a:t>EdResearch (2022). [Complete reference — BSB105 Tutorial 3 reading.]</a:t>
+            </a:r>
+            <a:endParaRPr lang="en-US" sz="1250" dirty="0"/>
           </a:p>
         </p:txBody>
       </p:sp>
@@ -4427,8 +4466,8 @@
         </p:nvSpPr>
         <p:spPr>
           <a:xfrm>
-            <a:off x="640080" y="2560320"/>
-            <a:ext cx="3566160" cy="365760"/>
+            <a:off x="640080" y="2267712"/>
+            <a:ext cx="3108960" cy="320040"/>
           </a:xfrm>
           <a:prstGeom prst="rect">
             <a:avLst/>
@@ -4444,7 +4483,7 @@
               <a:buNone/>
             </a:pPr>
             <a:r>
-              <a:rPr lang="en-US" sz="1600" b="1" dirty="0">
+              <a:rPr lang="en-US" sz="1450" b="1" dirty="0">
                 <a:solidFill>
                   <a:srgbClr val="B85042"/>
                 </a:solidFill>
@@ -4454,7 +4493,7 @@
               </a:rPr>
               <a:t>Injury and claims data</a:t>
             </a:r>
-            <a:endParaRPr lang="en-US" sz="1600" dirty="0"/>
+            <a:endParaRPr lang="en-US" sz="1450" dirty="0"/>
           </a:p>
         </p:txBody>
       </p:sp>
@@ -4466,8 +4505,8 @@
         </p:nvSpPr>
         <p:spPr>
           <a:xfrm>
-            <a:off x="4297680" y="2560320"/>
-            <a:ext cx="7223760" cy="685800"/>
+            <a:off x="3840480" y="2267712"/>
+            <a:ext cx="7680960" cy="566928"/>
           </a:xfrm>
           <a:prstGeom prst="rect">
             <a:avLst/>
@@ -4481,12 +4520,12 @@
           <a:p>
             <a:pPr indent="0" marL="0">
               <a:lnSpc>
-                <a:spcPts val="1900"/>
+                <a:spcPts val="1700"/>
               </a:lnSpc>
               <a:buNone/>
             </a:pPr>
             <a:r>
-              <a:rPr lang="en-US" sz="1400" dirty="0">
+              <a:rPr lang="en-US" sz="1250" dirty="0">
                 <a:solidFill>
                   <a:srgbClr val="2E2A28"/>
                 </a:solidFill>
@@ -4494,9 +4533,9 @@
                 <a:ea typeface="Calibri" pitchFamily="34" charset="-122"/>
                 <a:cs typeface="Calibri" pitchFamily="34" charset="-120"/>
               </a:rPr>
-              <a:t>Safe Work Australia. Key Work Health and Safety Statistics Australia. [Year, URL.]</a:t>
-            </a:r>
-            <a:endParaRPr lang="en-US" sz="1400" dirty="0"/>
+              <a:t>Safe Work Australia (2025). Key Work Health and Safety Statistics Australia. [URL, accessed date.]</a:t>
+            </a:r>
+            <a:endParaRPr lang="en-US" sz="1250" dirty="0"/>
           </a:p>
         </p:txBody>
       </p:sp>
@@ -4508,8 +4547,8 @@
         </p:nvSpPr>
         <p:spPr>
           <a:xfrm>
-            <a:off x="640080" y="3429000"/>
-            <a:ext cx="3566160" cy="365760"/>
+            <a:off x="640080" y="2962656"/>
+            <a:ext cx="3108960" cy="320040"/>
           </a:xfrm>
           <a:prstGeom prst="rect">
             <a:avLst/>
@@ -4525,7 +4564,7 @@
               <a:buNone/>
             </a:pPr>
             <a:r>
-              <a:rPr lang="en-US" sz="1600" b="1" dirty="0">
+              <a:rPr lang="en-US" sz="1450" b="1" dirty="0">
                 <a:solidFill>
                   <a:srgbClr val="B85042"/>
                 </a:solidFill>
@@ -4533,9 +4572,9 @@
                 <a:ea typeface="Cambria" pitchFamily="34" charset="-122"/>
                 <a:cs typeface="Cambria" pitchFamily="34" charset="-120"/>
               </a:rPr>
-              <a:t>Workforce and participation data</a:t>
-            </a:r>
-            <a:endParaRPr lang="en-US" sz="1600" dirty="0"/>
+              <a:t>Workforce participation</a:t>
+            </a:r>
+            <a:endParaRPr lang="en-US" sz="1450" dirty="0"/>
           </a:p>
         </p:txBody>
       </p:sp>
@@ -4547,8 +4586,8 @@
         </p:nvSpPr>
         <p:spPr>
           <a:xfrm>
-            <a:off x="4297680" y="3429000"/>
-            <a:ext cx="7223760" cy="685800"/>
+            <a:off x="3840480" y="2962656"/>
+            <a:ext cx="7680960" cy="566928"/>
           </a:xfrm>
           <a:prstGeom prst="rect">
             <a:avLst/>
@@ -4562,12 +4601,12 @@
           <a:p>
             <a:pPr indent="0" marL="0">
               <a:lnSpc>
-                <a:spcPts val="1900"/>
+                <a:spcPts val="1700"/>
               </a:lnSpc>
               <a:buNone/>
             </a:pPr>
             <a:r>
-              <a:rPr lang="en-US" sz="1400" dirty="0">
+              <a:rPr lang="en-US" sz="1250" dirty="0">
                 <a:solidFill>
                   <a:srgbClr val="2E2A28"/>
                 </a:solidFill>
@@ -4575,9 +4614,9 @@
                 <a:ea typeface="Calibri" pitchFamily="34" charset="-122"/>
                 <a:cs typeface="Calibri" pitchFamily="34" charset="-120"/>
               </a:rPr>
-              <a:t>[ABS / Jobs and Skills Australia — dataset, year, URL.]</a:t>
-            </a:r>
-            <a:endParaRPr lang="en-US" sz="1400" dirty="0"/>
+              <a:t>Jobs and Skills Australia; Australian Bureau of Statistics. [Dataset, year, URL — as cited in Lecture 4.]</a:t>
+            </a:r>
+            <a:endParaRPr lang="en-US" sz="1250" dirty="0"/>
           </a:p>
         </p:txBody>
       </p:sp>
@@ -4589,8 +4628,8 @@
         </p:nvSpPr>
         <p:spPr>
           <a:xfrm>
-            <a:off x="640080" y="4297680"/>
-            <a:ext cx="3566160" cy="365760"/>
+            <a:off x="640080" y="3657600"/>
+            <a:ext cx="3108960" cy="320040"/>
           </a:xfrm>
           <a:prstGeom prst="rect">
             <a:avLst/>
@@ -4606,7 +4645,7 @@
               <a:buNone/>
             </a:pPr>
             <a:r>
-              <a:rPr lang="en-US" sz="1600" b="1" dirty="0">
+              <a:rPr lang="en-US" sz="1450" b="1" dirty="0">
                 <a:solidFill>
                   <a:srgbClr val="B85042"/>
                 </a:solidFill>
@@ -4614,9 +4653,9 @@
                 <a:ea typeface="Cambria" pitchFamily="34" charset="-122"/>
                 <a:cs typeface="Cambria" pitchFamily="34" charset="-120"/>
               </a:rPr>
-              <a:t>Sources returned by the AI</a:t>
-            </a:r>
-            <a:endParaRPr lang="en-US" sz="1600" dirty="0"/>
+              <a:t>Client provocation</a:t>
+            </a:r>
+            <a:endParaRPr lang="en-US" sz="1450" dirty="0"/>
           </a:p>
         </p:txBody>
       </p:sp>
@@ -4628,8 +4667,8 @@
         </p:nvSpPr>
         <p:spPr>
           <a:xfrm>
-            <a:off x="4297680" y="4297680"/>
-            <a:ext cx="7223760" cy="685800"/>
+            <a:off x="3840480" y="3657600"/>
+            <a:ext cx="7680960" cy="566928"/>
           </a:xfrm>
           <a:prstGeom prst="rect">
             <a:avLst/>
@@ -4643,12 +4682,12 @@
           <a:p>
             <a:pPr indent="0" marL="0">
               <a:lnSpc>
-                <a:spcPts val="1900"/>
+                <a:spcPts val="1700"/>
               </a:lnSpc>
               <a:buNone/>
             </a:pPr>
             <a:r>
-              <a:rPr lang="en-US" sz="1400" dirty="0">
+              <a:rPr lang="en-US" sz="1250" dirty="0">
                 <a:solidFill>
                   <a:srgbClr val="2E2A28"/>
                 </a:solidFill>
@@ -4656,9 +4695,9 @@
                 <a:ea typeface="Calibri" pitchFamily="34" charset="-122"/>
                 <a:cs typeface="Calibri" pitchFamily="34" charset="-120"/>
               </a:rPr>
-              <a:t>[Studies and vendor pages cited in Prompt 4 — author, year, URL, and whether the link resolved.]</a:t>
-            </a:r>
-            <a:endParaRPr lang="en-US" sz="1400" dirty="0"/>
+              <a:t>Followmont Transport (July 2026). Presentation to Queensland University of Technology.</a:t>
+            </a:r>
+            <a:endParaRPr lang="en-US" sz="1250" dirty="0"/>
           </a:p>
         </p:txBody>
       </p:sp>
@@ -4670,8 +4709,8 @@
         </p:nvSpPr>
         <p:spPr>
           <a:xfrm>
-            <a:off x="640080" y="5166360"/>
-            <a:ext cx="3566160" cy="365760"/>
+            <a:off x="640080" y="4352544"/>
+            <a:ext cx="3108960" cy="320040"/>
           </a:xfrm>
           <a:prstGeom prst="rect">
             <a:avLst/>
@@ -4687,7 +4726,7 @@
               <a:buNone/>
             </a:pPr>
             <a:r>
-              <a:rPr lang="en-US" sz="1600" b="1" dirty="0">
+              <a:rPr lang="en-US" sz="1450" b="1" dirty="0">
                 <a:solidFill>
                   <a:srgbClr val="B85042"/>
                 </a:solidFill>
@@ -4695,9 +4734,9 @@
                 <a:ea typeface="Cambria" pitchFamily="34" charset="-122"/>
                 <a:cs typeface="Cambria" pitchFamily="34" charset="-120"/>
               </a:rPr>
-              <a:t>Prompt-design guidance</a:t>
-            </a:r>
-            <a:endParaRPr lang="en-US" sz="1600" dirty="0"/>
+              <a:t>Vendor sources</a:t>
+            </a:r>
+            <a:endParaRPr lang="en-US" sz="1450" dirty="0"/>
           </a:p>
         </p:txBody>
       </p:sp>
@@ -4709,8 +4748,8 @@
         </p:nvSpPr>
         <p:spPr>
           <a:xfrm>
-            <a:off x="4297680" y="5166360"/>
-            <a:ext cx="7223760" cy="685800"/>
+            <a:off x="3840480" y="4352544"/>
+            <a:ext cx="7680960" cy="566928"/>
           </a:xfrm>
           <a:prstGeom prst="rect">
             <a:avLst/>
@@ -4724,12 +4763,12 @@
           <a:p>
             <a:pPr indent="0" marL="0">
               <a:lnSpc>
-                <a:spcPts val="1900"/>
+                <a:spcPts val="1700"/>
               </a:lnSpc>
               <a:buNone/>
             </a:pPr>
             <a:r>
-              <a:rPr lang="en-US" sz="1400" dirty="0">
+              <a:rPr lang="en-US" sz="1250" dirty="0">
                 <a:solidFill>
                   <a:srgbClr val="2E2A28"/>
                 </a:solidFill>
@@ -4737,9 +4776,9 @@
                 <a:ea typeface="Calibri" pitchFamily="34" charset="-122"/>
                 <a:cs typeface="Calibri" pitchFamily="34" charset="-120"/>
               </a:rPr>
-              <a:t>[Vendor documentation the AI relied on in Prompt 1.]</a:t>
-            </a:r>
-            <a:endParaRPr lang="en-US" sz="1400" dirty="0"/>
+              <a:t>SpanSet Australia, OmniSuit; Exxovantage, back exoskeletons. [URLs, accessed date.]</a:t>
+            </a:r>
+            <a:endParaRPr lang="en-US" sz="1250" dirty="0"/>
           </a:p>
         </p:txBody>
       </p:sp>
@@ -4751,34 +4790,196 @@
         </p:nvSpPr>
         <p:spPr>
           <a:xfrm>
-            <a:off x="640080" y="6172200"/>
-            <a:ext cx="10881360" cy="320040"/>
-          </a:xfrm>
-          <a:prstGeom prst="rect">
-            <a:avLst/>
-          </a:prstGeom>
-          <a:noFill/>
-          <a:ln/>
-        </p:spPr>
-        <p:txBody>
-          <a:bodyPr wrap="square" lIns="0" tIns="0" rIns="0" bIns="0" rtlCol="0" anchor="ctr"/>
-          <a:lstStyle/>
-          <a:p>
-            <a:pPr indent="0" marL="0">
-              <a:buNone/>
-            </a:pPr>
-            <a:r>
-              <a:rPr lang="en-US" sz="1150" i="1" dirty="0">
-                <a:solidFill>
-                  <a:srgbClr val="7A736E"/>
+            <a:off x="640080" y="5047488"/>
+            <a:ext cx="3108960" cy="320040"/>
+          </a:xfrm>
+          <a:prstGeom prst="rect">
+            <a:avLst/>
+          </a:prstGeom>
+          <a:noFill/>
+          <a:ln/>
+        </p:spPr>
+        <p:txBody>
+          <a:bodyPr wrap="square" lIns="0" tIns="0" rIns="0" bIns="0" rtlCol="0" anchor="t"/>
+          <a:lstStyle/>
+          <a:p>
+            <a:pPr indent="0" marL="0">
+              <a:buNone/>
+            </a:pPr>
+            <a:r>
+              <a:rPr lang="en-US" sz="1450" b="1" dirty="0">
+                <a:solidFill>
+                  <a:srgbClr val="B85042"/>
+                </a:solidFill>
+                <a:latin typeface="Cambria" pitchFamily="34" charset="0"/>
+                <a:ea typeface="Cambria" pitchFamily="34" charset="-122"/>
+                <a:cs typeface="Cambria" pitchFamily="34" charset="-120"/>
+              </a:rPr>
+              <a:t>Exoskeleton evidence</a:t>
+            </a:r>
+            <a:endParaRPr lang="en-US" sz="1450" dirty="0"/>
+          </a:p>
+        </p:txBody>
+      </p:sp>
+      <p:sp>
+        <p:nvSpPr>
+          <p:cNvPr id="14" name="Text 12"/>
+          <p:cNvSpPr/>
+          <p:nvPr/>
+        </p:nvSpPr>
+        <p:spPr>
+          <a:xfrm>
+            <a:off x="3840480" y="5047488"/>
+            <a:ext cx="7680960" cy="566928"/>
+          </a:xfrm>
+          <a:prstGeom prst="rect">
+            <a:avLst/>
+          </a:prstGeom>
+          <a:noFill/>
+          <a:ln/>
+        </p:spPr>
+        <p:txBody>
+          <a:bodyPr wrap="square" lIns="0" tIns="0" rIns="0" bIns="0" rtlCol="0" anchor="t"/>
+          <a:lstStyle/>
+          <a:p>
+            <a:pPr indent="0" marL="0">
+              <a:lnSpc>
+                <a:spcPts val="1700"/>
+              </a:lnSpc>
+              <a:buNone/>
+            </a:pPr>
+            <a:r>
+              <a:rPr lang="en-US" sz="1250" dirty="0">
+                <a:solidFill>
+                  <a:srgbClr val="2E2A28"/>
                 </a:solidFill>
                 <a:latin typeface="Calibri" pitchFamily="34" charset="0"/>
                 <a:ea typeface="Calibri" pitchFamily="34" charset="-122"/>
                 <a:cs typeface="Calibri" pitchFamily="34" charset="-120"/>
               </a:rPr>
-              <a:t>All AI-generated content was produced in a single conversation and is quoted or summarised on the prompt slides above.</a:t>
-            </a:r>
-            <a:endParaRPr lang="en-US" sz="1150" dirty="0"/>
+              <a:t>[EMG studies traced from the Prompt 4 output — author, year, journal, URL, and whether the link resolved.]</a:t>
+            </a:r>
+            <a:endParaRPr lang="en-US" sz="1250" dirty="0"/>
+          </a:p>
+        </p:txBody>
+      </p:sp>
+      <p:sp>
+        <p:nvSpPr>
+          <p:cNvPr id="15" name="Text 13"/>
+          <p:cNvSpPr/>
+          <p:nvPr/>
+        </p:nvSpPr>
+        <p:spPr>
+          <a:xfrm>
+            <a:off x="640080" y="5742432"/>
+            <a:ext cx="3108960" cy="320040"/>
+          </a:xfrm>
+          <a:prstGeom prst="rect">
+            <a:avLst/>
+          </a:prstGeom>
+          <a:noFill/>
+          <a:ln/>
+        </p:spPr>
+        <p:txBody>
+          <a:bodyPr wrap="square" lIns="0" tIns="0" rIns="0" bIns="0" rtlCol="0" anchor="t"/>
+          <a:lstStyle/>
+          <a:p>
+            <a:pPr indent="0" marL="0">
+              <a:buNone/>
+            </a:pPr>
+            <a:r>
+              <a:rPr lang="en-US" sz="1450" b="1" dirty="0">
+                <a:solidFill>
+                  <a:srgbClr val="B85042"/>
+                </a:solidFill>
+                <a:latin typeface="Cambria" pitchFamily="34" charset="0"/>
+                <a:ea typeface="Cambria" pitchFamily="34" charset="-122"/>
+                <a:cs typeface="Cambria" pitchFamily="34" charset="-120"/>
+              </a:rPr>
+              <a:t>GenAI acknowledgement</a:t>
+            </a:r>
+            <a:endParaRPr lang="en-US" sz="1450" dirty="0"/>
+          </a:p>
+        </p:txBody>
+      </p:sp>
+      <p:sp>
+        <p:nvSpPr>
+          <p:cNvPr id="16" name="Text 14"/>
+          <p:cNvSpPr/>
+          <p:nvPr/>
+        </p:nvSpPr>
+        <p:spPr>
+          <a:xfrm>
+            <a:off x="3840480" y="5742432"/>
+            <a:ext cx="7680960" cy="566928"/>
+          </a:xfrm>
+          <a:prstGeom prst="rect">
+            <a:avLst/>
+          </a:prstGeom>
+          <a:noFill/>
+          <a:ln/>
+        </p:spPr>
+        <p:txBody>
+          <a:bodyPr wrap="square" lIns="0" tIns="0" rIns="0" bIns="0" rtlCol="0" anchor="t"/>
+          <a:lstStyle/>
+          <a:p>
+            <a:pPr indent="0" marL="0">
+              <a:lnSpc>
+                <a:spcPts val="1700"/>
+              </a:lnSpc>
+              <a:buNone/>
+            </a:pPr>
+            <a:r>
+              <a:rPr lang="en-US" sz="1250" dirty="0">
+                <a:solidFill>
+                  <a:srgbClr val="2E2A28"/>
+                </a:solidFill>
+                <a:latin typeface="Calibri" pitchFamily="34" charset="0"/>
+                <a:ea typeface="Calibri" pitchFamily="34" charset="-122"/>
+                <a:cs typeface="Calibri" pitchFamily="34" charset="-120"/>
+              </a:rPr>
+              <a:t>[Tool and version] used to generate all AI content in a single conversation, [date]. Full transcript submitted with this assessment.</a:t>
+            </a:r>
+            <a:endParaRPr lang="en-US" sz="1250" dirty="0"/>
+          </a:p>
+        </p:txBody>
+      </p:sp>
+      <p:sp>
+        <p:nvSpPr>
+          <p:cNvPr id="17" name="Text 15"/>
+          <p:cNvSpPr/>
+          <p:nvPr/>
+        </p:nvSpPr>
+        <p:spPr>
+          <a:xfrm>
+            <a:off x="640080" y="6419088"/>
+            <a:ext cx="10881360" cy="274320"/>
+          </a:xfrm>
+          <a:prstGeom prst="rect">
+            <a:avLst/>
+          </a:prstGeom>
+          <a:noFill/>
+          <a:ln/>
+        </p:spPr>
+        <p:txBody>
+          <a:bodyPr wrap="square" lIns="0" tIns="0" rIns="0" bIns="0" rtlCol="0" anchor="ctr"/>
+          <a:lstStyle/>
+          <a:p>
+            <a:pPr indent="0" marL="0">
+              <a:buNone/>
+            </a:pPr>
+            <a:r>
+              <a:rPr lang="en-US" sz="1100" i="1" dirty="0">
+                <a:solidFill>
+                  <a:srgbClr val="7A736E"/>
+                </a:solidFill>
+                <a:latin typeface="Calibri" pitchFamily="34" charset="0"/>
+                <a:ea typeface="Calibri" pitchFamily="34" charset="-122"/>
+                <a:cs typeface="Calibri" pitchFamily="34" charset="-120"/>
+              </a:rPr>
+              <a:t>Square brackets mark the details to complete before recording.</a:t>
+            </a:r>
+            <a:endParaRPr lang="en-US" sz="1100" dirty="0"/>
           </a:p>
         </p:txBody>
       </p:sp>
@@ -5583,7 +5784,7 @@
         </p:nvSpPr>
         <p:spPr>
           <a:xfrm>
-            <a:off x="6720840" y="1783080"/>
+            <a:off x="6720840" y="1691640"/>
             <a:ext cx="4800600" cy="1024128"/>
           </a:xfrm>
           <a:prstGeom prst="roundRect">
@@ -5617,7 +5818,7 @@
         </p:nvSpPr>
         <p:spPr>
           <a:xfrm>
-            <a:off x="6995160" y="1929384"/>
+            <a:off x="6995160" y="1837944"/>
             <a:ext cx="2011680" cy="731520"/>
           </a:xfrm>
           <a:prstGeom prst="rect">
@@ -5656,7 +5857,7 @@
         </p:nvSpPr>
         <p:spPr>
           <a:xfrm>
-            <a:off x="9006840" y="1929384"/>
+            <a:off x="9006840" y="1837944"/>
             <a:ext cx="2286000" cy="731520"/>
           </a:xfrm>
           <a:prstGeom prst="rect">
@@ -5695,7 +5896,7 @@
         </p:nvSpPr>
         <p:spPr>
           <a:xfrm>
-            <a:off x="6720840" y="3081528"/>
+            <a:off x="6720840" y="2862072"/>
             <a:ext cx="4800600" cy="1024128"/>
           </a:xfrm>
           <a:prstGeom prst="roundRect">
@@ -5729,7 +5930,7 @@
         </p:nvSpPr>
         <p:spPr>
           <a:xfrm>
-            <a:off x="6995160" y="3227832"/>
+            <a:off x="6995160" y="3008376"/>
             <a:ext cx="2011680" cy="731520"/>
           </a:xfrm>
           <a:prstGeom prst="rect">
@@ -5768,7 +5969,7 @@
         </p:nvSpPr>
         <p:spPr>
           <a:xfrm>
-            <a:off x="9006840" y="3227832"/>
+            <a:off x="9006840" y="3008376"/>
             <a:ext cx="2286000" cy="731520"/>
           </a:xfrm>
           <a:prstGeom prst="rect">
@@ -5807,7 +6008,7 @@
         </p:nvSpPr>
         <p:spPr>
           <a:xfrm>
-            <a:off x="6720840" y="4379976"/>
+            <a:off x="6720840" y="4032504"/>
             <a:ext cx="4800600" cy="1024128"/>
           </a:xfrm>
           <a:prstGeom prst="roundRect">
@@ -5841,7 +6042,7 @@
         </p:nvSpPr>
         <p:spPr>
           <a:xfrm>
-            <a:off x="6995160" y="4526280"/>
+            <a:off x="6995160" y="4178808"/>
             <a:ext cx="2011680" cy="731520"/>
           </a:xfrm>
           <a:prstGeom prst="rect">
@@ -5880,7 +6081,7 @@
         </p:nvSpPr>
         <p:spPr>
           <a:xfrm>
-            <a:off x="9006840" y="4526280"/>
+            <a:off x="9006840" y="4178808"/>
             <a:ext cx="2286000" cy="731520"/>
           </a:xfrm>
           <a:prstGeom prst="rect">
@@ -5913,40 +6114,104 @@
       </p:sp>
       <p:sp>
         <p:nvSpPr>
-          <p:cNvPr id="13" name="Text 11"/>
-          <p:cNvSpPr/>
-          <p:nvPr/>
-        </p:nvSpPr>
-        <p:spPr>
-          <a:xfrm>
-            <a:off x="640080" y="5623560"/>
-            <a:ext cx="10881360" cy="411480"/>
-          </a:xfrm>
-          <a:prstGeom prst="rect">
-            <a:avLst/>
-          </a:prstGeom>
-          <a:noFill/>
-          <a:ln/>
-        </p:spPr>
-        <p:txBody>
-          <a:bodyPr wrap="square" lIns="0" tIns="0" rIns="0" bIns="0" rtlCol="0" anchor="ctr"/>
-          <a:lstStyle/>
-          <a:p>
-            <a:pPr indent="0" marL="0">
-              <a:buNone/>
-            </a:pPr>
-            <a:r>
-              <a:rPr lang="en-US" sz="1600" i="1" dirty="0">
-                <a:solidFill>
-                  <a:srgbClr val="B85042"/>
+          <p:cNvPr id="13" name="Shape 11"/>
+          <p:cNvSpPr/>
+          <p:nvPr/>
+        </p:nvSpPr>
+        <p:spPr>
+          <a:xfrm>
+            <a:off x="640080" y="5230368"/>
+            <a:ext cx="10881360" cy="1115568"/>
+          </a:xfrm>
+          <a:prstGeom prst="roundRect">
+            <a:avLst>
+              <a:gd name="adj" fmla="val 6557"/>
+            </a:avLst>
+          </a:prstGeom>
+          <a:solidFill>
+            <a:srgbClr val="E7E8D1"/>
+          </a:solidFill>
+          <a:ln/>
+        </p:spPr>
+      </p:sp>
+      <p:sp>
+        <p:nvSpPr>
+          <p:cNvPr id="14" name="Text 12"/>
+          <p:cNvSpPr/>
+          <p:nvPr/>
+        </p:nvSpPr>
+        <p:spPr>
+          <a:xfrm>
+            <a:off x="1005840" y="5394960"/>
+            <a:ext cx="10149840" cy="621792"/>
+          </a:xfrm>
+          <a:prstGeom prst="rect">
+            <a:avLst/>
+          </a:prstGeom>
+          <a:noFill/>
+          <a:ln/>
+        </p:spPr>
+        <p:txBody>
+          <a:bodyPr wrap="square" lIns="0" tIns="0" rIns="0" bIns="0" rtlCol="0" anchor="t"/>
+          <a:lstStyle/>
+          <a:p>
+            <a:pPr indent="0" marL="0">
+              <a:lnSpc>
+                <a:spcPts val="2200"/>
+              </a:lnSpc>
+              <a:buNone/>
+            </a:pPr>
+            <a:r>
+              <a:rPr lang="en-US" sz="1600" b="1" i="1" dirty="0">
+                <a:solidFill>
+                  <a:srgbClr val="5C4A2E"/>
                 </a:solidFill>
                 <a:latin typeface="Calibri" pitchFamily="34" charset="0"/>
                 <a:ea typeface="Calibri" pitchFamily="34" charset="-122"/>
                 <a:cs typeface="Calibri" pitchFamily="34" charset="-120"/>
               </a:rPr>
-              <a:t>The question: how do data and technology keep these workers in the job longer?</a:t>
+              <a:t>“How might we harness data and technology to improve the workforce participation of transport and logistics workers aged 55 and over?”</a:t>
             </a:r>
             <a:endParaRPr lang="en-US" sz="1600" dirty="0"/>
+          </a:p>
+        </p:txBody>
+      </p:sp>
+      <p:sp>
+        <p:nvSpPr>
+          <p:cNvPr id="15" name="Text 13"/>
+          <p:cNvSpPr/>
+          <p:nvPr/>
+        </p:nvSpPr>
+        <p:spPr>
+          <a:xfrm>
+            <a:off x="1005840" y="5989320"/>
+            <a:ext cx="10149840" cy="274320"/>
+          </a:xfrm>
+          <a:prstGeom prst="rect">
+            <a:avLst/>
+          </a:prstGeom>
+          <a:noFill/>
+          <a:ln/>
+        </p:spPr>
+        <p:txBody>
+          <a:bodyPr wrap="square" lIns="0" tIns="0" rIns="0" bIns="0" rtlCol="0" anchor="ctr"/>
+          <a:lstStyle/>
+          <a:p>
+            <a:pPr indent="0" marL="0">
+              <a:buNone/>
+            </a:pPr>
+            <a:r>
+              <a:rPr lang="en-US" sz="1150" dirty="0">
+                <a:solidFill>
+                  <a:srgbClr val="7C7460"/>
+                </a:solidFill>
+                <a:latin typeface="Calibri" pitchFamily="34" charset="0"/>
+                <a:ea typeface="Calibri" pitchFamily="34" charset="-122"/>
+                <a:cs typeface="Calibri" pitchFamily="34" charset="-120"/>
+              </a:rPr>
+              <a:t>Followmont Transport, presentation to QUT, July 2026</a:t>
+            </a:r>
+            <a:endParaRPr lang="en-US" sz="1150" dirty="0"/>
           </a:p>
         </p:txBody>
       </p:sp>
@@ -8047,7 +8312,7 @@
                 <a:ea typeface="Calibri" pitchFamily="34" charset="-122"/>
                 <a:cs typeface="Calibri" pitchFamily="34" charset="-120"/>
               </a:rPr>
-              <a:t>Six broad interventions, none tied to a country, an employer or a product. Nothing carried a figure, a date or a source, so there was nothing to check. [Name your six here.]</a:t>
+              <a:t>Six interventions: ergonomic wearables, predictive fatigue management, workforce analytics, knowledge capture, adaptive interfaces and phased retirement. None tied to a country, an employer or a product, and not one figure, date or source to check.</a:t>
             </a:r>
             <a:endParaRPr lang="en-US" sz="1450" dirty="0"/>
           </a:p>
@@ -8792,7 +9057,7 @@
                 <a:ea typeface="Calibri" pitchFamily="34" charset="-122"/>
                 <a:cs typeface="Calibri" pitchFamily="34" charset="-120"/>
               </a:rPr>
-              <a:t>Exoskeletons for manual freight handling — named, costed and argued across evidence, barriers, enablers and business case. Still not one source, and still no Australian regulation.</a:t>
+              <a:t>Exoskeletons for manual freight handling — five commercial vendors named, a price range attached, and the case argued across evidence, barriers, enablers and business case. Still not one source, and still no Australian regulation.</a:t>
             </a:r>
             <a:endParaRPr lang="en-US" sz="1450" dirty="0"/>
           </a:p>
@@ -9113,7 +9378,7 @@
                 <a:ea typeface="Cambria" pitchFamily="34" charset="-122"/>
                 <a:cs typeface="Cambria" pitchFamily="34" charset="-120"/>
               </a:rPr>
-              <a:t>Currency</a:t>
+              <a:t>Purpose</a:t>
             </a:r>
             <a:endParaRPr lang="en-US" sz="1500" dirty="0"/>
           </a:p>
@@ -9155,7 +9420,7 @@
                 <a:ea typeface="Calibri" pitchFamily="34" charset="-122"/>
                 <a:cs typeface="Calibri" pitchFamily="34" charset="-120"/>
               </a:rPr>
-              <a:t>No publication years offered, despite a post-2022 instruction.</a:t>
+              <a:t>Five commercial vendors named and none independently verified — it reads like a product recommendation.</a:t>
             </a:r>
             <a:endParaRPr lang="en-US" sz="1250" dirty="0"/>
           </a:p>

</xml_diff>

<commit_message>
Complete references and tighten validation verdicts
- student number added to title slide
- every reference completed: AERO (2022) CRAAP guide, Safe Work Australia
  2025 release, JSA/ABS via Lecture 4, Followmont provocation, both AU
  vendor pages, and Schwartz et al. (2023) with DOI
- GenAI acknowledgement names the tool and states the transcript is
  retained and available on request rather than submitted
- validation row 2 now cites the specific study and its 12-27% finding
- validation row 3 trimmed to what was verified: no published unit price

Co-Authored-By: Claude Opus 5 <noreply@anthropic.com>
Claude-Session: https://claude.ai/code/session_01QGa9ZiBbTVxLmBFpqCsLHX
</commit_message>
<xml_diff>
--- a/Followmont-Prompt-Chain.pptx
+++ b/Followmont-Prompt-Chain.pptx
@@ -866,7 +866,7 @@
           <a:p>
             <a:r>
               <a:rPr lang="en-US" dirty="0"/>
-              <a:t>Do not read this slide aloud. Leave it on screen while you close.</a:t>
+              <a:t>Do not read this slide aloud. Leave it on screen while you close. If asked, the AI transcript is retained and can be provided.</a:t>
             </a:r>
             <a:endParaRPr lang="en-US" dirty="0"/>
           </a:p>
@@ -2116,7 +2116,7 @@
                 <a:ea typeface="Calibri" pitchFamily="34" charset="-122"/>
                 <a:cs typeface="Calibri" pitchFamily="34" charset="-120"/>
               </a:rPr>
-              <a:t>Daniel Franco Gomez  ·  [Student number]</a:t>
+              <a:t>Daniel Franco Gomez  ·  n12854468</a:t>
             </a:r>
             <a:endParaRPr lang="en-US" sz="1400" dirty="0"/>
           </a:p>
@@ -2646,7 +2646,7 @@
                 <a:ea typeface="Calibri" pitchFamily="34" charset="-122"/>
                 <a:cs typeface="Calibri" pitchFamily="34" charset="-120"/>
               </a:rPr>
-              <a:t>Peer-reviewed EMG studies, 2021–2025 (Europe, US)</a:t>
+              <a:t>Schwartz et al. (2023), Int. J. Environ. Res. Public Health</a:t>
             </a:r>
             <a:endParaRPr lang="en-US" sz="1200" dirty="0"/>
           </a:p>
@@ -2688,7 +2688,7 @@
                 <a:ea typeface="Calibri" pitchFamily="34" charset="-122"/>
                 <a:cs typeface="Calibri" pitchFamily="34" charset="-120"/>
               </a:rPr>
-              <a:t>Qualified — the range holds, but every trial is laboratory-based, none Australian, and individual results vary widely</a:t>
+              <a:t>Qualified — passive devices cut muscle activity 12–27%, but in a French laboratory, not a depot, and results varied widely between individuals</a:t>
             </a:r>
             <a:endParaRPr lang="en-US" sz="1200" dirty="0"/>
           </a:p>
@@ -2841,7 +2841,7 @@
                 <a:ea typeface="Calibri" pitchFamily="34" charset="-122"/>
                 <a:cs typeface="Calibri" pitchFamily="34" charset="-120"/>
               </a:rPr>
-              <a:t>Not supported — neither publishes a price, and secondary sources put passive units well above A$5,000</a:t>
+              <a:t>Not supported — neither publishes a unit price; SpanSet quotes only through a rental credited to purchase</a:t>
             </a:r>
             <a:endParaRPr lang="en-US" sz="1200" dirty="0"/>
           </a:p>
@@ -3033,7 +3033,7 @@
                 <a:ea typeface="Calibri" pitchFamily="34" charset="-122"/>
                 <a:cs typeface="Calibri" pitchFamily="34" charset="-120"/>
               </a:rPr>
-              <a:t>Sources: Safe Work Australia (2025); Jobs and Skills Australia and ABS via BSB105 Lecture 4; SpanSet Australia and Exxovantage product pages; peer-reviewed EMG studies 2021–2025. Full details on the references slide.</a:t>
+              <a:t>Sources: Safe Work Australia (2025); Jobs and Skills Australia and ABS via BSB105 Lecture 4; SpanSet Australia and Exxovantage product pages; Schwartz et al. (2023). Full details on the references slide.</a:t>
             </a:r>
             <a:endParaRPr lang="en-US" sz="1050" dirty="0"/>
           </a:p>
@@ -4386,7 +4386,7 @@
         <p:spPr>
           <a:xfrm>
             <a:off x="640080" y="1572768"/>
-            <a:ext cx="3108960" cy="320040"/>
+            <a:ext cx="10881360" cy="502920"/>
           </a:xfrm>
           <a:prstGeom prst="rect">
             <a:avLst/>
@@ -4399,20 +4399,40 @@
           <a:lstStyle/>
           <a:p>
             <a:pPr indent="0" marL="0">
-              <a:buNone/>
-            </a:pPr>
-            <a:r>
-              <a:rPr lang="en-US" sz="1450" b="1" dirty="0">
+              <a:lnSpc>
+                <a:spcPts val="1600"/>
+              </a:lnSpc>
+              <a:buNone/>
+            </a:pPr>
+            <a:r>
+              <a:rPr lang="en-US" sz="1150" b="1" dirty="0">
                 <a:solidFill>
                   <a:srgbClr val="B85042"/>
                 </a:solidFill>
-                <a:latin typeface="Cambria" pitchFamily="34" charset="0"/>
-                <a:ea typeface="Cambria" pitchFamily="34" charset="-122"/>
-                <a:cs typeface="Cambria" pitchFamily="34" charset="-120"/>
-              </a:rPr>
-              <a:t>CRAAP test</a:t>
-            </a:r>
-            <a:endParaRPr lang="en-US" sz="1450" dirty="0"/>
+                <a:latin typeface="Calibri" pitchFamily="34" charset="0"/>
+                <a:ea typeface="Calibri" pitchFamily="34" charset="-122"/>
+                <a:cs typeface="Calibri" pitchFamily="34" charset="-120"/>
+              </a:rPr>
+              <a:t>CRAAP test — </a:t>
+            </a:r>
+            <a:pPr indent="0" marL="0">
+              <a:lnSpc>
+                <a:spcPts val="1600"/>
+              </a:lnSpc>
+              <a:buNone/>
+            </a:pPr>
+            <a:r>
+              <a:rPr lang="en-US" sz="1150" dirty="0">
+                <a:solidFill>
+                  <a:srgbClr val="2E2A28"/>
+                </a:solidFill>
+                <a:latin typeface="Calibri" pitchFamily="34" charset="0"/>
+                <a:ea typeface="Calibri" pitchFamily="34" charset="-122"/>
+                <a:cs typeface="Calibri" pitchFamily="34" charset="-120"/>
+              </a:rPr>
+              <a:t>Australian Education Research Organisation. (2022). Evaluating non-academic sources: The CRAAP test. https://www.edresearch.edu.au/guides-resources/practice-resources/evaluating-non-academic-sources-craap-test</a:t>
+            </a:r>
+            <a:endParaRPr lang="en-US" sz="1150" dirty="0"/>
           </a:p>
         </p:txBody>
       </p:sp>
@@ -4424,8 +4444,8 @@
         </p:nvSpPr>
         <p:spPr>
           <a:xfrm>
-            <a:off x="3840480" y="1572768"/>
-            <a:ext cx="7680960" cy="566928"/>
+            <a:off x="640080" y="2258568"/>
+            <a:ext cx="10881360" cy="502920"/>
           </a:xfrm>
           <a:prstGeom prst="rect">
             <a:avLst/>
@@ -4439,12 +4459,29 @@
           <a:p>
             <a:pPr indent="0" marL="0">
               <a:lnSpc>
-                <a:spcPts val="1700"/>
+                <a:spcPts val="1600"/>
               </a:lnSpc>
               <a:buNone/>
             </a:pPr>
             <a:r>
-              <a:rPr lang="en-US" sz="1250" dirty="0">
+              <a:rPr lang="en-US" sz="1150" b="1" dirty="0">
+                <a:solidFill>
+                  <a:srgbClr val="B85042"/>
+                </a:solidFill>
+                <a:latin typeface="Calibri" pitchFamily="34" charset="0"/>
+                <a:ea typeface="Calibri" pitchFamily="34" charset="-122"/>
+                <a:cs typeface="Calibri" pitchFamily="34" charset="-120"/>
+              </a:rPr>
+              <a:t>Injury and claims data — </a:t>
+            </a:r>
+            <a:pPr indent="0" marL="0">
+              <a:lnSpc>
+                <a:spcPts val="1600"/>
+              </a:lnSpc>
+              <a:buNone/>
+            </a:pPr>
+            <a:r>
+              <a:rPr lang="en-US" sz="1150" dirty="0">
                 <a:solidFill>
                   <a:srgbClr val="2E2A28"/>
                 </a:solidFill>
@@ -4452,9 +4489,9 @@
                 <a:ea typeface="Calibri" pitchFamily="34" charset="-122"/>
                 <a:cs typeface="Calibri" pitchFamily="34" charset="-120"/>
               </a:rPr>
-              <a:t>EdResearch (2022). [Complete reference — BSB105 Tutorial 3 reading.]</a:t>
-            </a:r>
-            <a:endParaRPr lang="en-US" sz="1250" dirty="0"/>
+              <a:t>Safe Work Australia. (2025). Key work health and safety statistics Australia. https://data.safeworkaustralia.gov.au/insights/key-whs-statistics-australia/latest-release</a:t>
+            </a:r>
+            <a:endParaRPr lang="en-US" sz="1150" dirty="0"/>
           </a:p>
         </p:txBody>
       </p:sp>
@@ -4466,8 +4503,8 @@
         </p:nvSpPr>
         <p:spPr>
           <a:xfrm>
-            <a:off x="640080" y="2267712"/>
-            <a:ext cx="3108960" cy="320040"/>
+            <a:off x="640080" y="2944368"/>
+            <a:ext cx="10881360" cy="502920"/>
           </a:xfrm>
           <a:prstGeom prst="rect">
             <a:avLst/>
@@ -4480,20 +4517,40 @@
           <a:lstStyle/>
           <a:p>
             <a:pPr indent="0" marL="0">
-              <a:buNone/>
-            </a:pPr>
-            <a:r>
-              <a:rPr lang="en-US" sz="1450" b="1" dirty="0">
+              <a:lnSpc>
+                <a:spcPts val="1600"/>
+              </a:lnSpc>
+              <a:buNone/>
+            </a:pPr>
+            <a:r>
+              <a:rPr lang="en-US" sz="1150" b="1" dirty="0">
                 <a:solidFill>
                   <a:srgbClr val="B85042"/>
                 </a:solidFill>
-                <a:latin typeface="Cambria" pitchFamily="34" charset="0"/>
-                <a:ea typeface="Cambria" pitchFamily="34" charset="-122"/>
-                <a:cs typeface="Cambria" pitchFamily="34" charset="-120"/>
-              </a:rPr>
-              <a:t>Injury and claims data</a:t>
-            </a:r>
-            <a:endParaRPr lang="en-US" sz="1450" dirty="0"/>
+                <a:latin typeface="Calibri" pitchFamily="34" charset="0"/>
+                <a:ea typeface="Calibri" pitchFamily="34" charset="-122"/>
+                <a:cs typeface="Calibri" pitchFamily="34" charset="-120"/>
+              </a:rPr>
+              <a:t>Workforce participation — </a:t>
+            </a:r>
+            <a:pPr indent="0" marL="0">
+              <a:lnSpc>
+                <a:spcPts val="1600"/>
+              </a:lnSpc>
+              <a:buNone/>
+            </a:pPr>
+            <a:r>
+              <a:rPr lang="en-US" sz="1150" dirty="0">
+                <a:solidFill>
+                  <a:srgbClr val="2E2A28"/>
+                </a:solidFill>
+                <a:latin typeface="Calibri" pitchFamily="34" charset="0"/>
+                <a:ea typeface="Calibri" pitchFamily="34" charset="-122"/>
+                <a:cs typeface="Calibri" pitchFamily="34" charset="-120"/>
+              </a:rPr>
+              <a:t>Jobs and Skills Australia &amp; Australian Bureau of Statistics, as cited in BSB105 The Future Enterprise, Lecture 4 (2026). Participation rate 69.6% (55–64); 16.3% (65+).</a:t>
+            </a:r>
+            <a:endParaRPr lang="en-US" sz="1150" dirty="0"/>
           </a:p>
         </p:txBody>
       </p:sp>
@@ -4505,8 +4562,8 @@
         </p:nvSpPr>
         <p:spPr>
           <a:xfrm>
-            <a:off x="3840480" y="2267712"/>
-            <a:ext cx="7680960" cy="566928"/>
+            <a:off x="640080" y="3630168"/>
+            <a:ext cx="10881360" cy="278892"/>
           </a:xfrm>
           <a:prstGeom prst="rect">
             <a:avLst/>
@@ -4520,12 +4577,29 @@
           <a:p>
             <a:pPr indent="0" marL="0">
               <a:lnSpc>
-                <a:spcPts val="1700"/>
+                <a:spcPts val="1600"/>
               </a:lnSpc>
               <a:buNone/>
             </a:pPr>
             <a:r>
-              <a:rPr lang="en-US" sz="1250" dirty="0">
+              <a:rPr lang="en-US" sz="1150" b="1" dirty="0">
+                <a:solidFill>
+                  <a:srgbClr val="B85042"/>
+                </a:solidFill>
+                <a:latin typeface="Calibri" pitchFamily="34" charset="0"/>
+                <a:ea typeface="Calibri" pitchFamily="34" charset="-122"/>
+                <a:cs typeface="Calibri" pitchFamily="34" charset="-120"/>
+              </a:rPr>
+              <a:t>Client provocation — </a:t>
+            </a:r>
+            <a:pPr indent="0" marL="0">
+              <a:lnSpc>
+                <a:spcPts val="1600"/>
+              </a:lnSpc>
+              <a:buNone/>
+            </a:pPr>
+            <a:r>
+              <a:rPr lang="en-US" sz="1150" dirty="0">
                 <a:solidFill>
                   <a:srgbClr val="2E2A28"/>
                 </a:solidFill>
@@ -4533,9 +4607,9 @@
                 <a:ea typeface="Calibri" pitchFamily="34" charset="-122"/>
                 <a:cs typeface="Calibri" pitchFamily="34" charset="-120"/>
               </a:rPr>
-              <a:t>Safe Work Australia (2025). Key Work Health and Safety Statistics Australia. [URL, accessed date.]</a:t>
-            </a:r>
-            <a:endParaRPr lang="en-US" sz="1250" dirty="0"/>
+              <a:t>Followmont Transport. (2026, July). Presentation to Queensland University of Technology.</a:t>
+            </a:r>
+            <a:endParaRPr lang="en-US" sz="1150" dirty="0"/>
           </a:p>
         </p:txBody>
       </p:sp>
@@ -4547,8 +4621,8 @@
         </p:nvSpPr>
         <p:spPr>
           <a:xfrm>
-            <a:off x="640080" y="2962656"/>
-            <a:ext cx="3108960" cy="320040"/>
+            <a:off x="640080" y="4091940"/>
+            <a:ext cx="10881360" cy="502920"/>
           </a:xfrm>
           <a:prstGeom prst="rect">
             <a:avLst/>
@@ -4561,20 +4635,40 @@
           <a:lstStyle/>
           <a:p>
             <a:pPr indent="0" marL="0">
-              <a:buNone/>
-            </a:pPr>
-            <a:r>
-              <a:rPr lang="en-US" sz="1450" b="1" dirty="0">
+              <a:lnSpc>
+                <a:spcPts val="1600"/>
+              </a:lnSpc>
+              <a:buNone/>
+            </a:pPr>
+            <a:r>
+              <a:rPr lang="en-US" sz="1150" b="1" dirty="0">
                 <a:solidFill>
                   <a:srgbClr val="B85042"/>
                 </a:solidFill>
-                <a:latin typeface="Cambria" pitchFamily="34" charset="0"/>
-                <a:ea typeface="Cambria" pitchFamily="34" charset="-122"/>
-                <a:cs typeface="Cambria" pitchFamily="34" charset="-120"/>
-              </a:rPr>
-              <a:t>Workforce participation</a:t>
-            </a:r>
-            <a:endParaRPr lang="en-US" sz="1450" dirty="0"/>
+                <a:latin typeface="Calibri" pitchFamily="34" charset="0"/>
+                <a:ea typeface="Calibri" pitchFamily="34" charset="-122"/>
+                <a:cs typeface="Calibri" pitchFamily="34" charset="-120"/>
+              </a:rPr>
+              <a:t>Vendor sources — </a:t>
+            </a:r>
+            <a:pPr indent="0" marL="0">
+              <a:lnSpc>
+                <a:spcPts val="1600"/>
+              </a:lnSpc>
+              <a:buNone/>
+            </a:pPr>
+            <a:r>
+              <a:rPr lang="en-US" sz="1150" dirty="0">
+                <a:solidFill>
+                  <a:srgbClr val="2E2A28"/>
+                </a:solidFill>
+                <a:latin typeface="Calibri" pitchFamily="34" charset="0"/>
+                <a:ea typeface="Calibri" pitchFamily="34" charset="-122"/>
+                <a:cs typeface="Calibri" pitchFamily="34" charset="-120"/>
+              </a:rPr>
+              <a:t>SpanSet Australia. OmniSuit exoskeleton. https://www.spanset.com/au-en/products/omnisuit-33654 · Exxovantage. Back exoskeletons. https://www.exxovantage.com/back-exoskeletons</a:t>
+            </a:r>
+            <a:endParaRPr lang="en-US" sz="1150" dirty="0"/>
           </a:p>
         </p:txBody>
       </p:sp>
@@ -4586,8 +4680,8 @@
         </p:nvSpPr>
         <p:spPr>
           <a:xfrm>
-            <a:off x="3840480" y="2962656"/>
-            <a:ext cx="7680960" cy="566928"/>
+            <a:off x="640080" y="4777740"/>
+            <a:ext cx="10881360" cy="726948"/>
           </a:xfrm>
           <a:prstGeom prst="rect">
             <a:avLst/>
@@ -4601,12 +4695,29 @@
           <a:p>
             <a:pPr indent="0" marL="0">
               <a:lnSpc>
-                <a:spcPts val="1700"/>
+                <a:spcPts val="1600"/>
               </a:lnSpc>
               <a:buNone/>
             </a:pPr>
             <a:r>
-              <a:rPr lang="en-US" sz="1250" dirty="0">
+              <a:rPr lang="en-US" sz="1150" b="1" dirty="0">
+                <a:solidFill>
+                  <a:srgbClr val="B85042"/>
+                </a:solidFill>
+                <a:latin typeface="Calibri" pitchFamily="34" charset="0"/>
+                <a:ea typeface="Calibri" pitchFamily="34" charset="-122"/>
+                <a:cs typeface="Calibri" pitchFamily="34" charset="-120"/>
+              </a:rPr>
+              <a:t>Exoskeleton evidence — </a:t>
+            </a:r>
+            <a:pPr indent="0" marL="0">
+              <a:lnSpc>
+                <a:spcPts val="1600"/>
+              </a:lnSpc>
+              <a:buNone/>
+            </a:pPr>
+            <a:r>
+              <a:rPr lang="en-US" sz="1150" dirty="0">
                 <a:solidFill>
                   <a:srgbClr val="2E2A28"/>
                 </a:solidFill>
@@ -4614,9 +4725,9 @@
                 <a:ea typeface="Calibri" pitchFamily="34" charset="-122"/>
                 <a:cs typeface="Calibri" pitchFamily="34" charset="-120"/>
               </a:rPr>
-              <a:t>Jobs and Skills Australia; Australian Bureau of Statistics. [Dataset, year, URL — as cited in Lecture 4.]</a:t>
-            </a:r>
-            <a:endParaRPr lang="en-US" sz="1250" dirty="0"/>
+              <a:t>Schwartz, M., Desbrosses, K., Theurel, J., &amp; Mornieux, G. (2023). Biomechanical consequences of using passive and active back-support exoskeletons during different manual handling tasks. International Journal of Environmental Research and Public Health, 20(15), 6468. https://doi.org/10.3390/ijerph20156468</a:t>
+            </a:r>
+            <a:endParaRPr lang="en-US" sz="1150" dirty="0"/>
           </a:p>
         </p:txBody>
       </p:sp>
@@ -4628,8 +4739,8 @@
         </p:nvSpPr>
         <p:spPr>
           <a:xfrm>
-            <a:off x="640080" y="3657600"/>
-            <a:ext cx="3108960" cy="320040"/>
+            <a:off x="640080" y="5687568"/>
+            <a:ext cx="10881360" cy="502920"/>
           </a:xfrm>
           <a:prstGeom prst="rect">
             <a:avLst/>
@@ -4642,20 +4753,40 @@
           <a:lstStyle/>
           <a:p>
             <a:pPr indent="0" marL="0">
-              <a:buNone/>
-            </a:pPr>
-            <a:r>
-              <a:rPr lang="en-US" sz="1450" b="1" dirty="0">
+              <a:lnSpc>
+                <a:spcPts val="1600"/>
+              </a:lnSpc>
+              <a:buNone/>
+            </a:pPr>
+            <a:r>
+              <a:rPr lang="en-US" sz="1150" b="1" dirty="0">
                 <a:solidFill>
                   <a:srgbClr val="B85042"/>
                 </a:solidFill>
-                <a:latin typeface="Cambria" pitchFamily="34" charset="0"/>
-                <a:ea typeface="Cambria" pitchFamily="34" charset="-122"/>
-                <a:cs typeface="Cambria" pitchFamily="34" charset="-120"/>
-              </a:rPr>
-              <a:t>Client provocation</a:t>
-            </a:r>
-            <a:endParaRPr lang="en-US" sz="1450" dirty="0"/>
+                <a:latin typeface="Calibri" pitchFamily="34" charset="0"/>
+                <a:ea typeface="Calibri" pitchFamily="34" charset="-122"/>
+                <a:cs typeface="Calibri" pitchFamily="34" charset="-120"/>
+              </a:rPr>
+              <a:t>GenAI acknowledgement — </a:t>
+            </a:r>
+            <a:pPr indent="0" marL="0">
+              <a:lnSpc>
+                <a:spcPts val="1600"/>
+              </a:lnSpc>
+              <a:buNone/>
+            </a:pPr>
+            <a:r>
+              <a:rPr lang="en-US" sz="1150" dirty="0">
+                <a:solidFill>
+                  <a:srgbClr val="2E2A28"/>
+                </a:solidFill>
+                <a:latin typeface="Calibri" pitchFamily="34" charset="0"/>
+                <a:ea typeface="Calibri" pitchFamily="34" charset="-122"/>
+                <a:cs typeface="Calibri" pitchFamily="34" charset="-120"/>
+              </a:rPr>
+              <a:t>Claude (Anthropic) was used to generate all AI content analysed here, in a single conversation, August 2026. Full transcript retained and available on request.</a:t>
+            </a:r>
+            <a:endParaRPr lang="en-US" sz="1150" dirty="0"/>
           </a:p>
         </p:txBody>
       </p:sp>
@@ -4667,292 +4798,7 @@
         </p:nvSpPr>
         <p:spPr>
           <a:xfrm>
-            <a:off x="3840480" y="3657600"/>
-            <a:ext cx="7680960" cy="566928"/>
-          </a:xfrm>
-          <a:prstGeom prst="rect">
-            <a:avLst/>
-          </a:prstGeom>
-          <a:noFill/>
-          <a:ln/>
-        </p:spPr>
-        <p:txBody>
-          <a:bodyPr wrap="square" lIns="0" tIns="0" rIns="0" bIns="0" rtlCol="0" anchor="t"/>
-          <a:lstStyle/>
-          <a:p>
-            <a:pPr indent="0" marL="0">
-              <a:lnSpc>
-                <a:spcPts val="1700"/>
-              </a:lnSpc>
-              <a:buNone/>
-            </a:pPr>
-            <a:r>
-              <a:rPr lang="en-US" sz="1250" dirty="0">
-                <a:solidFill>
-                  <a:srgbClr val="2E2A28"/>
-                </a:solidFill>
-                <a:latin typeface="Calibri" pitchFamily="34" charset="0"/>
-                <a:ea typeface="Calibri" pitchFamily="34" charset="-122"/>
-                <a:cs typeface="Calibri" pitchFamily="34" charset="-120"/>
-              </a:rPr>
-              <a:t>Followmont Transport (July 2026). Presentation to Queensland University of Technology.</a:t>
-            </a:r>
-            <a:endParaRPr lang="en-US" sz="1250" dirty="0"/>
-          </a:p>
-        </p:txBody>
-      </p:sp>
-      <p:sp>
-        <p:nvSpPr>
-          <p:cNvPr id="11" name="Text 9"/>
-          <p:cNvSpPr/>
-          <p:nvPr/>
-        </p:nvSpPr>
-        <p:spPr>
-          <a:xfrm>
-            <a:off x="640080" y="4352544"/>
-            <a:ext cx="3108960" cy="320040"/>
-          </a:xfrm>
-          <a:prstGeom prst="rect">
-            <a:avLst/>
-          </a:prstGeom>
-          <a:noFill/>
-          <a:ln/>
-        </p:spPr>
-        <p:txBody>
-          <a:bodyPr wrap="square" lIns="0" tIns="0" rIns="0" bIns="0" rtlCol="0" anchor="t"/>
-          <a:lstStyle/>
-          <a:p>
-            <a:pPr indent="0" marL="0">
-              <a:buNone/>
-            </a:pPr>
-            <a:r>
-              <a:rPr lang="en-US" sz="1450" b="1" dirty="0">
-                <a:solidFill>
-                  <a:srgbClr val="B85042"/>
-                </a:solidFill>
-                <a:latin typeface="Cambria" pitchFamily="34" charset="0"/>
-                <a:ea typeface="Cambria" pitchFamily="34" charset="-122"/>
-                <a:cs typeface="Cambria" pitchFamily="34" charset="-120"/>
-              </a:rPr>
-              <a:t>Vendor sources</a:t>
-            </a:r>
-            <a:endParaRPr lang="en-US" sz="1450" dirty="0"/>
-          </a:p>
-        </p:txBody>
-      </p:sp>
-      <p:sp>
-        <p:nvSpPr>
-          <p:cNvPr id="12" name="Text 10"/>
-          <p:cNvSpPr/>
-          <p:nvPr/>
-        </p:nvSpPr>
-        <p:spPr>
-          <a:xfrm>
-            <a:off x="3840480" y="4352544"/>
-            <a:ext cx="7680960" cy="566928"/>
-          </a:xfrm>
-          <a:prstGeom prst="rect">
-            <a:avLst/>
-          </a:prstGeom>
-          <a:noFill/>
-          <a:ln/>
-        </p:spPr>
-        <p:txBody>
-          <a:bodyPr wrap="square" lIns="0" tIns="0" rIns="0" bIns="0" rtlCol="0" anchor="t"/>
-          <a:lstStyle/>
-          <a:p>
-            <a:pPr indent="0" marL="0">
-              <a:lnSpc>
-                <a:spcPts val="1700"/>
-              </a:lnSpc>
-              <a:buNone/>
-            </a:pPr>
-            <a:r>
-              <a:rPr lang="en-US" sz="1250" dirty="0">
-                <a:solidFill>
-                  <a:srgbClr val="2E2A28"/>
-                </a:solidFill>
-                <a:latin typeface="Calibri" pitchFamily="34" charset="0"/>
-                <a:ea typeface="Calibri" pitchFamily="34" charset="-122"/>
-                <a:cs typeface="Calibri" pitchFamily="34" charset="-120"/>
-              </a:rPr>
-              <a:t>SpanSet Australia, OmniSuit; Exxovantage, back exoskeletons. [URLs, accessed date.]</a:t>
-            </a:r>
-            <a:endParaRPr lang="en-US" sz="1250" dirty="0"/>
-          </a:p>
-        </p:txBody>
-      </p:sp>
-      <p:sp>
-        <p:nvSpPr>
-          <p:cNvPr id="13" name="Text 11"/>
-          <p:cNvSpPr/>
-          <p:nvPr/>
-        </p:nvSpPr>
-        <p:spPr>
-          <a:xfrm>
-            <a:off x="640080" y="5047488"/>
-            <a:ext cx="3108960" cy="320040"/>
-          </a:xfrm>
-          <a:prstGeom prst="rect">
-            <a:avLst/>
-          </a:prstGeom>
-          <a:noFill/>
-          <a:ln/>
-        </p:spPr>
-        <p:txBody>
-          <a:bodyPr wrap="square" lIns="0" tIns="0" rIns="0" bIns="0" rtlCol="0" anchor="t"/>
-          <a:lstStyle/>
-          <a:p>
-            <a:pPr indent="0" marL="0">
-              <a:buNone/>
-            </a:pPr>
-            <a:r>
-              <a:rPr lang="en-US" sz="1450" b="1" dirty="0">
-                <a:solidFill>
-                  <a:srgbClr val="B85042"/>
-                </a:solidFill>
-                <a:latin typeface="Cambria" pitchFamily="34" charset="0"/>
-                <a:ea typeface="Cambria" pitchFamily="34" charset="-122"/>
-                <a:cs typeface="Cambria" pitchFamily="34" charset="-120"/>
-              </a:rPr>
-              <a:t>Exoskeleton evidence</a:t>
-            </a:r>
-            <a:endParaRPr lang="en-US" sz="1450" dirty="0"/>
-          </a:p>
-        </p:txBody>
-      </p:sp>
-      <p:sp>
-        <p:nvSpPr>
-          <p:cNvPr id="14" name="Text 12"/>
-          <p:cNvSpPr/>
-          <p:nvPr/>
-        </p:nvSpPr>
-        <p:spPr>
-          <a:xfrm>
-            <a:off x="3840480" y="5047488"/>
-            <a:ext cx="7680960" cy="566928"/>
-          </a:xfrm>
-          <a:prstGeom prst="rect">
-            <a:avLst/>
-          </a:prstGeom>
-          <a:noFill/>
-          <a:ln/>
-        </p:spPr>
-        <p:txBody>
-          <a:bodyPr wrap="square" lIns="0" tIns="0" rIns="0" bIns="0" rtlCol="0" anchor="t"/>
-          <a:lstStyle/>
-          <a:p>
-            <a:pPr indent="0" marL="0">
-              <a:lnSpc>
-                <a:spcPts val="1700"/>
-              </a:lnSpc>
-              <a:buNone/>
-            </a:pPr>
-            <a:r>
-              <a:rPr lang="en-US" sz="1250" dirty="0">
-                <a:solidFill>
-                  <a:srgbClr val="2E2A28"/>
-                </a:solidFill>
-                <a:latin typeface="Calibri" pitchFamily="34" charset="0"/>
-                <a:ea typeface="Calibri" pitchFamily="34" charset="-122"/>
-                <a:cs typeface="Calibri" pitchFamily="34" charset="-120"/>
-              </a:rPr>
-              <a:t>[EMG studies traced from the Prompt 4 output — author, year, journal, URL, and whether the link resolved.]</a:t>
-            </a:r>
-            <a:endParaRPr lang="en-US" sz="1250" dirty="0"/>
-          </a:p>
-        </p:txBody>
-      </p:sp>
-      <p:sp>
-        <p:nvSpPr>
-          <p:cNvPr id="15" name="Text 13"/>
-          <p:cNvSpPr/>
-          <p:nvPr/>
-        </p:nvSpPr>
-        <p:spPr>
-          <a:xfrm>
-            <a:off x="640080" y="5742432"/>
-            <a:ext cx="3108960" cy="320040"/>
-          </a:xfrm>
-          <a:prstGeom prst="rect">
-            <a:avLst/>
-          </a:prstGeom>
-          <a:noFill/>
-          <a:ln/>
-        </p:spPr>
-        <p:txBody>
-          <a:bodyPr wrap="square" lIns="0" tIns="0" rIns="0" bIns="0" rtlCol="0" anchor="t"/>
-          <a:lstStyle/>
-          <a:p>
-            <a:pPr indent="0" marL="0">
-              <a:buNone/>
-            </a:pPr>
-            <a:r>
-              <a:rPr lang="en-US" sz="1450" b="1" dirty="0">
-                <a:solidFill>
-                  <a:srgbClr val="B85042"/>
-                </a:solidFill>
-                <a:latin typeface="Cambria" pitchFamily="34" charset="0"/>
-                <a:ea typeface="Cambria" pitchFamily="34" charset="-122"/>
-                <a:cs typeface="Cambria" pitchFamily="34" charset="-120"/>
-              </a:rPr>
-              <a:t>GenAI acknowledgement</a:t>
-            </a:r>
-            <a:endParaRPr lang="en-US" sz="1450" dirty="0"/>
-          </a:p>
-        </p:txBody>
-      </p:sp>
-      <p:sp>
-        <p:nvSpPr>
-          <p:cNvPr id="16" name="Text 14"/>
-          <p:cNvSpPr/>
-          <p:nvPr/>
-        </p:nvSpPr>
-        <p:spPr>
-          <a:xfrm>
-            <a:off x="3840480" y="5742432"/>
-            <a:ext cx="7680960" cy="566928"/>
-          </a:xfrm>
-          <a:prstGeom prst="rect">
-            <a:avLst/>
-          </a:prstGeom>
-          <a:noFill/>
-          <a:ln/>
-        </p:spPr>
-        <p:txBody>
-          <a:bodyPr wrap="square" lIns="0" tIns="0" rIns="0" bIns="0" rtlCol="0" anchor="t"/>
-          <a:lstStyle/>
-          <a:p>
-            <a:pPr indent="0" marL="0">
-              <a:lnSpc>
-                <a:spcPts val="1700"/>
-              </a:lnSpc>
-              <a:buNone/>
-            </a:pPr>
-            <a:r>
-              <a:rPr lang="en-US" sz="1250" dirty="0">
-                <a:solidFill>
-                  <a:srgbClr val="2E2A28"/>
-                </a:solidFill>
-                <a:latin typeface="Calibri" pitchFamily="34" charset="0"/>
-                <a:ea typeface="Calibri" pitchFamily="34" charset="-122"/>
-                <a:cs typeface="Calibri" pitchFamily="34" charset="-120"/>
-              </a:rPr>
-              <a:t>[Tool and version] used to generate all AI content in a single conversation, [date]. Full transcript submitted with this assessment.</a:t>
-            </a:r>
-            <a:endParaRPr lang="en-US" sz="1250" dirty="0"/>
-          </a:p>
-        </p:txBody>
-      </p:sp>
-      <p:sp>
-        <p:nvSpPr>
-          <p:cNvPr id="17" name="Text 15"/>
-          <p:cNvSpPr/>
-          <p:nvPr/>
-        </p:nvSpPr>
-        <p:spPr>
-          <a:xfrm>
-            <a:off x="640080" y="6419088"/>
+            <a:off x="640080" y="6355080"/>
             <a:ext cx="10881360" cy="274320"/>
           </a:xfrm>
           <a:prstGeom prst="rect">
@@ -4977,7 +4823,7 @@
                 <a:ea typeface="Calibri" pitchFamily="34" charset="-122"/>
                 <a:cs typeface="Calibri" pitchFamily="34" charset="-120"/>
               </a:rPr>
-              <a:t>Square brackets mark the details to complete before recording.</a:t>
+              <a:t>All URLs accessed 17 August 2026.</a:t>
             </a:r>
             <a:endParaRPr lang="en-US" sz="1100" dirty="0"/>
           </a:p>

</xml_diff>

<commit_message>
Recolour deck to Followmont navy and white
Replaces the terracotta and sand scheme with a navy palette: deep navy
title and conclusion grounds, brand blue for numerals and CRAAP labels,
pale blue result cards, and a brighter blue accent for text and marks
sitting on dark backgrounds. Verdict colours on the validation table stay
semantic (green, olive, red) rather than brand-tinted.

Co-Authored-By: Claude Opus 5 <noreply@anthropic.com>
Claude-Session: https://claude.ai/code/session_01QGa9ZiBbTVxLmBFpqCsLHX
</commit_message>
<xml_diff>
--- a/Followmont-Prompt-Chain.pptx
+++ b/Followmont-Prompt-Chain.pptx
@@ -1925,7 +1925,7 @@
     <p:bg>
       <p:bgPr>
         <a:solidFill>
-          <a:srgbClr val="2E2A28"/>
+          <a:srgbClr val="0E2338"/>
         </a:solidFill>
       </p:bgPr>
     </p:bg>
@@ -1970,7 +1970,7 @@
             <a:r>
               <a:rPr lang="en-US" sz="1300" b="1" spc="250" kern="0" dirty="0">
                 <a:solidFill>
-                  <a:srgbClr val="B85042"/>
+                  <a:srgbClr val="5B9BD5"/>
                 </a:solidFill>
                 <a:latin typeface="Calibri" pitchFamily="34" charset="0"/>
                 <a:ea typeface="Calibri" pitchFamily="34" charset="-122"/>
@@ -2071,7 +2071,7 @@
             <a:r>
               <a:rPr lang="en-US" sz="1700" dirty="0">
                 <a:solidFill>
-                  <a:srgbClr val="A7BEAE"/>
+                  <a:srgbClr val="A9C4DC"/>
                 </a:solidFill>
                 <a:latin typeface="Calibri" pitchFamily="34" charset="0"/>
                 <a:ea typeface="Calibri" pitchFamily="34" charset="-122"/>
@@ -2110,7 +2110,7 @@
             <a:r>
               <a:rPr lang="en-US" sz="1400" b="1" dirty="0">
                 <a:solidFill>
-                  <a:srgbClr val="C6BEB8"/>
+                  <a:srgbClr val="B9C6D4"/>
                 </a:solidFill>
                 <a:latin typeface="Calibri" pitchFamily="34" charset="0"/>
                 <a:ea typeface="Calibri" pitchFamily="34" charset="-122"/>
@@ -2149,7 +2149,7 @@
             <a:r>
               <a:rPr lang="en-US" sz="1300" dirty="0">
                 <a:solidFill>
-                  <a:srgbClr val="9A928C"/>
+                  <a:srgbClr val="8496A8"/>
                 </a:solidFill>
                 <a:latin typeface="Calibri" pitchFamily="34" charset="0"/>
                 <a:ea typeface="Calibri" pitchFamily="34" charset="-122"/>
@@ -2220,7 +2220,7 @@
             <a:r>
               <a:rPr lang="en-US" sz="4000" b="1" dirty="0">
                 <a:solidFill>
-                  <a:srgbClr val="2E2A28"/>
+                  <a:srgbClr val="16212E"/>
                 </a:solidFill>
                 <a:latin typeface="Cambria" pitchFamily="34" charset="0"/>
                 <a:ea typeface="Cambria" pitchFamily="34" charset="-122"/>
@@ -2259,7 +2259,7 @@
             <a:r>
               <a:rPr lang="en-US" sz="1600" dirty="0">
                 <a:solidFill>
-                  <a:srgbClr val="7A736E"/>
+                  <a:srgbClr val="6B7787"/>
                 </a:solidFill>
                 <a:latin typeface="Calibri" pitchFamily="34" charset="0"/>
                 <a:ea typeface="Calibri" pitchFamily="34" charset="-122"/>
@@ -2298,7 +2298,7 @@
             <a:r>
               <a:rPr lang="en-US" sz="1150" b="1" spc="200" kern="0" dirty="0">
                 <a:solidFill>
-                  <a:srgbClr val="7A736E"/>
+                  <a:srgbClr val="6B7787"/>
                 </a:solidFill>
                 <a:latin typeface="Calibri" pitchFamily="34" charset="0"/>
                 <a:ea typeface="Calibri" pitchFamily="34" charset="-122"/>
@@ -2337,7 +2337,7 @@
             <a:r>
               <a:rPr lang="en-US" sz="1150" b="1" spc="200" kern="0" dirty="0">
                 <a:solidFill>
-                  <a:srgbClr val="7A736E"/>
+                  <a:srgbClr val="6B7787"/>
                 </a:solidFill>
                 <a:latin typeface="Calibri" pitchFamily="34" charset="0"/>
                 <a:ea typeface="Calibri" pitchFamily="34" charset="-122"/>
@@ -2376,7 +2376,7 @@
             <a:r>
               <a:rPr lang="en-US" sz="1150" b="1" spc="200" kern="0" dirty="0">
                 <a:solidFill>
-                  <a:srgbClr val="7A736E"/>
+                  <a:srgbClr val="6B7787"/>
                 </a:solidFill>
                 <a:latin typeface="Calibri" pitchFamily="34" charset="0"/>
                 <a:ea typeface="Calibri" pitchFamily="34" charset="-122"/>
@@ -2405,11 +2405,11 @@
             </a:avLst>
           </a:prstGeom>
           <a:solidFill>
-            <a:srgbClr val="F4F1EE"/>
+            <a:srgbClr val="F2F5F8"/>
           </a:solidFill>
           <a:ln w="12700">
             <a:solidFill>
-              <a:srgbClr val="EFE9E5"/>
+              <a:srgbClr val="E7EDF3"/>
             </a:solidFill>
             <a:prstDash val="solid"/>
           </a:ln>
@@ -2445,7 +2445,7 @@
             <a:r>
               <a:rPr lang="en-US" sz="1300" b="1" dirty="0">
                 <a:solidFill>
-                  <a:srgbClr val="2E2A28"/>
+                  <a:srgbClr val="16212E"/>
                 </a:solidFill>
                 <a:latin typeface="Calibri" pitchFamily="34" charset="0"/>
                 <a:ea typeface="Calibri" pitchFamily="34" charset="-122"/>
@@ -2487,7 +2487,7 @@
             <a:r>
               <a:rPr lang="en-US" sz="1200" dirty="0">
                 <a:solidFill>
-                  <a:srgbClr val="7A736E"/>
+                  <a:srgbClr val="6B7787"/>
                 </a:solidFill>
                 <a:latin typeface="Calibri" pitchFamily="34" charset="0"/>
                 <a:ea typeface="Calibri" pitchFamily="34" charset="-122"/>
@@ -2558,11 +2558,11 @@
             </a:avLst>
           </a:prstGeom>
           <a:solidFill>
-            <a:srgbClr val="FBF9F8"/>
+            <a:srgbClr val="FAFCFE"/>
           </a:solidFill>
           <a:ln w="12700">
             <a:solidFill>
-              <a:srgbClr val="EFE9E5"/>
+              <a:srgbClr val="E7EDF3"/>
             </a:solidFill>
             <a:prstDash val="solid"/>
           </a:ln>
@@ -2598,7 +2598,7 @@
             <a:r>
               <a:rPr lang="en-US" sz="1300" b="1" dirty="0">
                 <a:solidFill>
-                  <a:srgbClr val="2E2A28"/>
+                  <a:srgbClr val="16212E"/>
                 </a:solidFill>
                 <a:latin typeface="Calibri" pitchFamily="34" charset="0"/>
                 <a:ea typeface="Calibri" pitchFamily="34" charset="-122"/>
@@ -2640,7 +2640,7 @@
             <a:r>
               <a:rPr lang="en-US" sz="1200" dirty="0">
                 <a:solidFill>
-                  <a:srgbClr val="7A736E"/>
+                  <a:srgbClr val="6B7787"/>
                 </a:solidFill>
                 <a:latin typeface="Calibri" pitchFamily="34" charset="0"/>
                 <a:ea typeface="Calibri" pitchFamily="34" charset="-122"/>
@@ -2711,11 +2711,11 @@
             </a:avLst>
           </a:prstGeom>
           <a:solidFill>
-            <a:srgbClr val="F4F1EE"/>
+            <a:srgbClr val="F2F5F8"/>
           </a:solidFill>
           <a:ln w="12700">
             <a:solidFill>
-              <a:srgbClr val="EFE9E5"/>
+              <a:srgbClr val="E7EDF3"/>
             </a:solidFill>
             <a:prstDash val="solid"/>
           </a:ln>
@@ -2751,7 +2751,7 @@
             <a:r>
               <a:rPr lang="en-US" sz="1300" b="1" dirty="0">
                 <a:solidFill>
-                  <a:srgbClr val="2E2A28"/>
+                  <a:srgbClr val="16212E"/>
                 </a:solidFill>
                 <a:latin typeface="Calibri" pitchFamily="34" charset="0"/>
                 <a:ea typeface="Calibri" pitchFamily="34" charset="-122"/>
@@ -2793,7 +2793,7 @@
             <a:r>
               <a:rPr lang="en-US" sz="1200" dirty="0">
                 <a:solidFill>
-                  <a:srgbClr val="7A736E"/>
+                  <a:srgbClr val="6B7787"/>
                 </a:solidFill>
                 <a:latin typeface="Calibri" pitchFamily="34" charset="0"/>
                 <a:ea typeface="Calibri" pitchFamily="34" charset="-122"/>
@@ -2864,11 +2864,11 @@
             </a:avLst>
           </a:prstGeom>
           <a:solidFill>
-            <a:srgbClr val="FBF9F8"/>
+            <a:srgbClr val="FAFCFE"/>
           </a:solidFill>
           <a:ln w="12700">
             <a:solidFill>
-              <a:srgbClr val="EFE9E5"/>
+              <a:srgbClr val="E7EDF3"/>
             </a:solidFill>
             <a:prstDash val="solid"/>
           </a:ln>
@@ -2904,7 +2904,7 @@
             <a:r>
               <a:rPr lang="en-US" sz="1300" b="1" dirty="0">
                 <a:solidFill>
-                  <a:srgbClr val="2E2A28"/>
+                  <a:srgbClr val="16212E"/>
                 </a:solidFill>
                 <a:latin typeface="Calibri" pitchFamily="34" charset="0"/>
                 <a:ea typeface="Calibri" pitchFamily="34" charset="-122"/>
@@ -2946,7 +2946,7 @@
             <a:r>
               <a:rPr lang="en-US" sz="1200" dirty="0">
                 <a:solidFill>
-                  <a:srgbClr val="7A736E"/>
+                  <a:srgbClr val="6B7787"/>
                 </a:solidFill>
                 <a:latin typeface="Calibri" pitchFamily="34" charset="0"/>
                 <a:ea typeface="Calibri" pitchFamily="34" charset="-122"/>
@@ -3027,7 +3027,7 @@
             <a:r>
               <a:rPr lang="en-US" sz="1050" dirty="0">
                 <a:solidFill>
-                  <a:srgbClr val="7A736E"/>
+                  <a:srgbClr val="6B7787"/>
                 </a:solidFill>
                 <a:latin typeface="Calibri" pitchFamily="34" charset="0"/>
                 <a:ea typeface="Calibri" pitchFamily="34" charset="-122"/>
@@ -3098,7 +3098,7 @@
             <a:r>
               <a:rPr lang="en-US" sz="3800" b="1" dirty="0">
                 <a:solidFill>
-                  <a:srgbClr val="2E2A28"/>
+                  <a:srgbClr val="16212E"/>
                 </a:solidFill>
                 <a:latin typeface="Cambria" pitchFamily="34" charset="0"/>
                 <a:ea typeface="Cambria" pitchFamily="34" charset="-122"/>
@@ -3137,7 +3137,7 @@
             <a:r>
               <a:rPr lang="en-US" sz="1550" dirty="0">
                 <a:solidFill>
-                  <a:srgbClr val="7A736E"/>
+                  <a:srgbClr val="6B7787"/>
                 </a:solidFill>
                 <a:latin typeface="Calibri" pitchFamily="34" charset="0"/>
                 <a:ea typeface="Calibri" pitchFamily="34" charset="-122"/>
@@ -3166,11 +3166,11 @@
             </a:avLst>
           </a:prstGeom>
           <a:solidFill>
-            <a:srgbClr val="F4F1EE"/>
+            <a:srgbClr val="F2F5F8"/>
           </a:solidFill>
           <a:ln w="12700">
             <a:solidFill>
-              <a:srgbClr val="EFE9E5"/>
+              <a:srgbClr val="E7EDF3"/>
             </a:solidFill>
             <a:prstDash val="solid"/>
           </a:ln>
@@ -3203,7 +3203,7 @@
             <a:r>
               <a:rPr lang="en-US" sz="1800" b="1" dirty="0">
                 <a:solidFill>
-                  <a:srgbClr val="B85042"/>
+                  <a:srgbClr val="1D5C9B"/>
                 </a:solidFill>
                 <a:latin typeface="Cambria" pitchFamily="34" charset="0"/>
                 <a:ea typeface="Cambria" pitchFamily="34" charset="-122"/>
@@ -3245,7 +3245,7 @@
             <a:r>
               <a:rPr lang="en-US" sz="1350" dirty="0">
                 <a:solidFill>
-                  <a:srgbClr val="2E2A28"/>
+                  <a:srgbClr val="16212E"/>
                 </a:solidFill>
                 <a:latin typeface="Calibri" pitchFamily="34" charset="0"/>
                 <a:ea typeface="Calibri" pitchFamily="34" charset="-122"/>
@@ -3274,11 +3274,11 @@
             </a:avLst>
           </a:prstGeom>
           <a:solidFill>
-            <a:srgbClr val="FBF9F8"/>
+            <a:srgbClr val="FAFCFE"/>
           </a:solidFill>
           <a:ln w="12700">
             <a:solidFill>
-              <a:srgbClr val="EFE9E5"/>
+              <a:srgbClr val="E7EDF3"/>
             </a:solidFill>
             <a:prstDash val="solid"/>
           </a:ln>
@@ -3311,7 +3311,7 @@
             <a:r>
               <a:rPr lang="en-US" sz="1800" b="1" dirty="0">
                 <a:solidFill>
-                  <a:srgbClr val="B85042"/>
+                  <a:srgbClr val="1D5C9B"/>
                 </a:solidFill>
                 <a:latin typeface="Cambria" pitchFamily="34" charset="0"/>
                 <a:ea typeface="Cambria" pitchFamily="34" charset="-122"/>
@@ -3353,7 +3353,7 @@
             <a:r>
               <a:rPr lang="en-US" sz="1350" dirty="0">
                 <a:solidFill>
-                  <a:srgbClr val="2E2A28"/>
+                  <a:srgbClr val="16212E"/>
                 </a:solidFill>
                 <a:latin typeface="Calibri" pitchFamily="34" charset="0"/>
                 <a:ea typeface="Calibri" pitchFamily="34" charset="-122"/>
@@ -3382,11 +3382,11 @@
             </a:avLst>
           </a:prstGeom>
           <a:solidFill>
-            <a:srgbClr val="F4F1EE"/>
+            <a:srgbClr val="F2F5F8"/>
           </a:solidFill>
           <a:ln w="12700">
             <a:solidFill>
-              <a:srgbClr val="EFE9E5"/>
+              <a:srgbClr val="E7EDF3"/>
             </a:solidFill>
             <a:prstDash val="solid"/>
           </a:ln>
@@ -3419,7 +3419,7 @@
             <a:r>
               <a:rPr lang="en-US" sz="1800" b="1" dirty="0">
                 <a:solidFill>
-                  <a:srgbClr val="B85042"/>
+                  <a:srgbClr val="1D5C9B"/>
                 </a:solidFill>
                 <a:latin typeface="Cambria" pitchFamily="34" charset="0"/>
                 <a:ea typeface="Cambria" pitchFamily="34" charset="-122"/>
@@ -3461,7 +3461,7 @@
             <a:r>
               <a:rPr lang="en-US" sz="1350" dirty="0">
                 <a:solidFill>
-                  <a:srgbClr val="2E2A28"/>
+                  <a:srgbClr val="16212E"/>
                 </a:solidFill>
                 <a:latin typeface="Calibri" pitchFamily="34" charset="0"/>
                 <a:ea typeface="Calibri" pitchFamily="34" charset="-122"/>
@@ -3490,11 +3490,11 @@
             </a:avLst>
           </a:prstGeom>
           <a:solidFill>
-            <a:srgbClr val="FBF9F8"/>
+            <a:srgbClr val="FAFCFE"/>
           </a:solidFill>
           <a:ln w="12700">
             <a:solidFill>
-              <a:srgbClr val="EFE9E5"/>
+              <a:srgbClr val="E7EDF3"/>
             </a:solidFill>
             <a:prstDash val="solid"/>
           </a:ln>
@@ -3527,7 +3527,7 @@
             <a:r>
               <a:rPr lang="en-US" sz="1800" b="1" dirty="0">
                 <a:solidFill>
-                  <a:srgbClr val="B85042"/>
+                  <a:srgbClr val="1D5C9B"/>
                 </a:solidFill>
                 <a:latin typeface="Cambria" pitchFamily="34" charset="0"/>
                 <a:ea typeface="Cambria" pitchFamily="34" charset="-122"/>
@@ -3569,7 +3569,7 @@
             <a:r>
               <a:rPr lang="en-US" sz="1350" dirty="0">
                 <a:solidFill>
-                  <a:srgbClr val="2E2A28"/>
+                  <a:srgbClr val="16212E"/>
                 </a:solidFill>
                 <a:latin typeface="Calibri" pitchFamily="34" charset="0"/>
                 <a:ea typeface="Calibri" pitchFamily="34" charset="-122"/>
@@ -3598,11 +3598,11 @@
             </a:avLst>
           </a:prstGeom>
           <a:solidFill>
-            <a:srgbClr val="F4F1EE"/>
+            <a:srgbClr val="F2F5F8"/>
           </a:solidFill>
           <a:ln w="12700">
             <a:solidFill>
-              <a:srgbClr val="EFE9E5"/>
+              <a:srgbClr val="E7EDF3"/>
             </a:solidFill>
             <a:prstDash val="solid"/>
           </a:ln>
@@ -3635,7 +3635,7 @@
             <a:r>
               <a:rPr lang="en-US" sz="1800" b="1" dirty="0">
                 <a:solidFill>
-                  <a:srgbClr val="B85042"/>
+                  <a:srgbClr val="1D5C9B"/>
                 </a:solidFill>
                 <a:latin typeface="Cambria" pitchFamily="34" charset="0"/>
                 <a:ea typeface="Cambria" pitchFamily="34" charset="-122"/>
@@ -3677,7 +3677,7 @@
             <a:r>
               <a:rPr lang="en-US" sz="1350" dirty="0">
                 <a:solidFill>
-                  <a:srgbClr val="2E2A28"/>
+                  <a:srgbClr val="16212E"/>
                 </a:solidFill>
                 <a:latin typeface="Calibri" pitchFamily="34" charset="0"/>
                 <a:ea typeface="Calibri" pitchFamily="34" charset="-122"/>
@@ -3716,7 +3716,7 @@
             <a:r>
               <a:rPr lang="en-US" sz="1050" dirty="0">
                 <a:solidFill>
-                  <a:srgbClr val="7A736E"/>
+                  <a:srgbClr val="6B7787"/>
                 </a:solidFill>
                 <a:latin typeface="Calibri" pitchFamily="34" charset="0"/>
                 <a:ea typeface="Calibri" pitchFamily="34" charset="-122"/>
@@ -3742,7 +3742,7 @@
     <p:bg>
       <p:bgPr>
         <a:solidFill>
-          <a:srgbClr val="2E2A28"/>
+          <a:srgbClr val="0E2338"/>
         </a:solidFill>
       </p:bgPr>
     </p:bg>
@@ -3787,7 +3787,7 @@
             <a:r>
               <a:rPr lang="en-US" sz="1300" b="1" spc="250" kern="0" dirty="0">
                 <a:solidFill>
-                  <a:srgbClr val="B85042"/>
+                  <a:srgbClr val="5B9BD5"/>
                 </a:solidFill>
                 <a:latin typeface="Calibri" pitchFamily="34" charset="0"/>
                 <a:ea typeface="Calibri" pitchFamily="34" charset="-122"/>
@@ -3876,7 +3876,7 @@
             <a:avLst/>
           </a:prstGeom>
           <a:solidFill>
-            <a:srgbClr val="B85042"/>
+            <a:srgbClr val="5B9BD5"/>
           </a:solidFill>
           <a:ln/>
         </p:spPr>
@@ -3908,7 +3908,7 @@
             <a:r>
               <a:rPr lang="en-US" sz="1550" b="1" dirty="0">
                 <a:solidFill>
-                  <a:srgbClr val="A7BEAE"/>
+                  <a:srgbClr val="A9C4DC"/>
                 </a:solidFill>
                 <a:latin typeface="Cambria" pitchFamily="34" charset="0"/>
                 <a:ea typeface="Cambria" pitchFamily="34" charset="-122"/>
@@ -3950,7 +3950,7 @@
             <a:r>
               <a:rPr lang="en-US" sz="1400" dirty="0">
                 <a:solidFill>
-                  <a:srgbClr val="CFC7C1"/>
+                  <a:srgbClr val="C3CEDA"/>
                 </a:solidFill>
                 <a:latin typeface="Calibri" pitchFamily="34" charset="0"/>
                 <a:ea typeface="Calibri" pitchFamily="34" charset="-122"/>
@@ -3977,7 +3977,7 @@
             <a:avLst/>
           </a:prstGeom>
           <a:solidFill>
-            <a:srgbClr val="B85042"/>
+            <a:srgbClr val="5B9BD5"/>
           </a:solidFill>
           <a:ln/>
         </p:spPr>
@@ -4009,7 +4009,7 @@
             <a:r>
               <a:rPr lang="en-US" sz="1550" b="1" dirty="0">
                 <a:solidFill>
-                  <a:srgbClr val="A7BEAE"/>
+                  <a:srgbClr val="A9C4DC"/>
                 </a:solidFill>
                 <a:latin typeface="Cambria" pitchFamily="34" charset="0"/>
                 <a:ea typeface="Cambria" pitchFamily="34" charset="-122"/>
@@ -4051,7 +4051,7 @@
             <a:r>
               <a:rPr lang="en-US" sz="1400" dirty="0">
                 <a:solidFill>
-                  <a:srgbClr val="CFC7C1"/>
+                  <a:srgbClr val="C3CEDA"/>
                 </a:solidFill>
                 <a:latin typeface="Calibri" pitchFamily="34" charset="0"/>
                 <a:ea typeface="Calibri" pitchFamily="34" charset="-122"/>
@@ -4078,7 +4078,7 @@
             <a:avLst/>
           </a:prstGeom>
           <a:solidFill>
-            <a:srgbClr val="B85042"/>
+            <a:srgbClr val="5B9BD5"/>
           </a:solidFill>
           <a:ln/>
         </p:spPr>
@@ -4110,7 +4110,7 @@
             <a:r>
               <a:rPr lang="en-US" sz="1550" b="1" dirty="0">
                 <a:solidFill>
-                  <a:srgbClr val="A7BEAE"/>
+                  <a:srgbClr val="A9C4DC"/>
                 </a:solidFill>
                 <a:latin typeface="Cambria" pitchFamily="34" charset="0"/>
                 <a:ea typeface="Cambria" pitchFamily="34" charset="-122"/>
@@ -4152,7 +4152,7 @@
             <a:r>
               <a:rPr lang="en-US" sz="1400" dirty="0">
                 <a:solidFill>
-                  <a:srgbClr val="CFC7C1"/>
+                  <a:srgbClr val="C3CEDA"/>
                 </a:solidFill>
                 <a:latin typeface="Calibri" pitchFamily="34" charset="0"/>
                 <a:ea typeface="Calibri" pitchFamily="34" charset="-122"/>
@@ -4181,7 +4181,7 @@
             </a:avLst>
           </a:prstGeom>
           <a:solidFill>
-            <a:srgbClr val="B85042"/>
+            <a:srgbClr val="1F6BAE"/>
           </a:solidFill>
           <a:ln/>
         </p:spPr>
@@ -4213,7 +4213,7 @@
             <a:r>
               <a:rPr lang="en-US" sz="1150" b="1" spc="200" kern="0" dirty="0">
                 <a:solidFill>
-                  <a:srgbClr val="F6DED9"/>
+                  <a:srgbClr val="D6E4F2"/>
                 </a:solidFill>
                 <a:latin typeface="Calibri" pitchFamily="34" charset="0"/>
                 <a:ea typeface="Calibri" pitchFamily="34" charset="-122"/>
@@ -4294,7 +4294,7 @@
             <a:r>
               <a:rPr lang="en-US" sz="1350" dirty="0">
                 <a:solidFill>
-                  <a:srgbClr val="FCEFEC"/>
+                  <a:srgbClr val="EAF2F9"/>
                 </a:solidFill>
                 <a:latin typeface="Calibri" pitchFamily="34" charset="0"/>
                 <a:ea typeface="Calibri" pitchFamily="34" charset="-122"/>
@@ -4365,7 +4365,7 @@
             <a:r>
               <a:rPr lang="en-US" sz="4000" b="1" dirty="0">
                 <a:solidFill>
-                  <a:srgbClr val="2E2A28"/>
+                  <a:srgbClr val="16212E"/>
                 </a:solidFill>
                 <a:latin typeface="Cambria" pitchFamily="34" charset="0"/>
                 <a:ea typeface="Cambria" pitchFamily="34" charset="-122"/>
@@ -4407,7 +4407,7 @@
             <a:r>
               <a:rPr lang="en-US" sz="1150" b="1" dirty="0">
                 <a:solidFill>
-                  <a:srgbClr val="B85042"/>
+                  <a:srgbClr val="1D5C9B"/>
                 </a:solidFill>
                 <a:latin typeface="Calibri" pitchFamily="34" charset="0"/>
                 <a:ea typeface="Calibri" pitchFamily="34" charset="-122"/>
@@ -4424,7 +4424,7 @@
             <a:r>
               <a:rPr lang="en-US" sz="1150" dirty="0">
                 <a:solidFill>
-                  <a:srgbClr val="2E2A28"/>
+                  <a:srgbClr val="16212E"/>
                 </a:solidFill>
                 <a:latin typeface="Calibri" pitchFamily="34" charset="0"/>
                 <a:ea typeface="Calibri" pitchFamily="34" charset="-122"/>
@@ -4466,7 +4466,7 @@
             <a:r>
               <a:rPr lang="en-US" sz="1150" b="1" dirty="0">
                 <a:solidFill>
-                  <a:srgbClr val="B85042"/>
+                  <a:srgbClr val="1D5C9B"/>
                 </a:solidFill>
                 <a:latin typeface="Calibri" pitchFamily="34" charset="0"/>
                 <a:ea typeface="Calibri" pitchFamily="34" charset="-122"/>
@@ -4483,7 +4483,7 @@
             <a:r>
               <a:rPr lang="en-US" sz="1150" dirty="0">
                 <a:solidFill>
-                  <a:srgbClr val="2E2A28"/>
+                  <a:srgbClr val="16212E"/>
                 </a:solidFill>
                 <a:latin typeface="Calibri" pitchFamily="34" charset="0"/>
                 <a:ea typeface="Calibri" pitchFamily="34" charset="-122"/>
@@ -4525,7 +4525,7 @@
             <a:r>
               <a:rPr lang="en-US" sz="1150" b="1" dirty="0">
                 <a:solidFill>
-                  <a:srgbClr val="B85042"/>
+                  <a:srgbClr val="1D5C9B"/>
                 </a:solidFill>
                 <a:latin typeface="Calibri" pitchFamily="34" charset="0"/>
                 <a:ea typeface="Calibri" pitchFamily="34" charset="-122"/>
@@ -4542,7 +4542,7 @@
             <a:r>
               <a:rPr lang="en-US" sz="1150" dirty="0">
                 <a:solidFill>
-                  <a:srgbClr val="2E2A28"/>
+                  <a:srgbClr val="16212E"/>
                 </a:solidFill>
                 <a:latin typeface="Calibri" pitchFamily="34" charset="0"/>
                 <a:ea typeface="Calibri" pitchFamily="34" charset="-122"/>
@@ -4584,7 +4584,7 @@
             <a:r>
               <a:rPr lang="en-US" sz="1150" b="1" dirty="0">
                 <a:solidFill>
-                  <a:srgbClr val="B85042"/>
+                  <a:srgbClr val="1D5C9B"/>
                 </a:solidFill>
                 <a:latin typeface="Calibri" pitchFamily="34" charset="0"/>
                 <a:ea typeface="Calibri" pitchFamily="34" charset="-122"/>
@@ -4601,7 +4601,7 @@
             <a:r>
               <a:rPr lang="en-US" sz="1150" dirty="0">
                 <a:solidFill>
-                  <a:srgbClr val="2E2A28"/>
+                  <a:srgbClr val="16212E"/>
                 </a:solidFill>
                 <a:latin typeface="Calibri" pitchFamily="34" charset="0"/>
                 <a:ea typeface="Calibri" pitchFamily="34" charset="-122"/>
@@ -4643,7 +4643,7 @@
             <a:r>
               <a:rPr lang="en-US" sz="1150" b="1" dirty="0">
                 <a:solidFill>
-                  <a:srgbClr val="B85042"/>
+                  <a:srgbClr val="1D5C9B"/>
                 </a:solidFill>
                 <a:latin typeface="Calibri" pitchFamily="34" charset="0"/>
                 <a:ea typeface="Calibri" pitchFamily="34" charset="-122"/>
@@ -4660,7 +4660,7 @@
             <a:r>
               <a:rPr lang="en-US" sz="1150" dirty="0">
                 <a:solidFill>
-                  <a:srgbClr val="2E2A28"/>
+                  <a:srgbClr val="16212E"/>
                 </a:solidFill>
                 <a:latin typeface="Calibri" pitchFamily="34" charset="0"/>
                 <a:ea typeface="Calibri" pitchFamily="34" charset="-122"/>
@@ -4702,7 +4702,7 @@
             <a:r>
               <a:rPr lang="en-US" sz="1150" b="1" dirty="0">
                 <a:solidFill>
-                  <a:srgbClr val="B85042"/>
+                  <a:srgbClr val="1D5C9B"/>
                 </a:solidFill>
                 <a:latin typeface="Calibri" pitchFamily="34" charset="0"/>
                 <a:ea typeface="Calibri" pitchFamily="34" charset="-122"/>
@@ -4719,7 +4719,7 @@
             <a:r>
               <a:rPr lang="en-US" sz="1150" dirty="0">
                 <a:solidFill>
-                  <a:srgbClr val="2E2A28"/>
+                  <a:srgbClr val="16212E"/>
                 </a:solidFill>
                 <a:latin typeface="Calibri" pitchFamily="34" charset="0"/>
                 <a:ea typeface="Calibri" pitchFamily="34" charset="-122"/>
@@ -4761,7 +4761,7 @@
             <a:r>
               <a:rPr lang="en-US" sz="1150" b="1" dirty="0">
                 <a:solidFill>
-                  <a:srgbClr val="B85042"/>
+                  <a:srgbClr val="1D5C9B"/>
                 </a:solidFill>
                 <a:latin typeface="Calibri" pitchFamily="34" charset="0"/>
                 <a:ea typeface="Calibri" pitchFamily="34" charset="-122"/>
@@ -4778,7 +4778,7 @@
             <a:r>
               <a:rPr lang="en-US" sz="1150" dirty="0">
                 <a:solidFill>
-                  <a:srgbClr val="2E2A28"/>
+                  <a:srgbClr val="16212E"/>
                 </a:solidFill>
                 <a:latin typeface="Calibri" pitchFamily="34" charset="0"/>
                 <a:ea typeface="Calibri" pitchFamily="34" charset="-122"/>
@@ -4817,7 +4817,7 @@
             <a:r>
               <a:rPr lang="en-US" sz="1100" i="1" dirty="0">
                 <a:solidFill>
-                  <a:srgbClr val="7A736E"/>
+                  <a:srgbClr val="6B7787"/>
                 </a:solidFill>
                 <a:latin typeface="Calibri" pitchFamily="34" charset="0"/>
                 <a:ea typeface="Calibri" pitchFamily="34" charset="-122"/>
@@ -4888,7 +4888,7 @@
             <a:r>
               <a:rPr lang="en-US" sz="4000" b="1" dirty="0">
                 <a:solidFill>
-                  <a:srgbClr val="2E2A28"/>
+                  <a:srgbClr val="16212E"/>
                 </a:solidFill>
                 <a:latin typeface="Cambria" pitchFamily="34" charset="0"/>
                 <a:ea typeface="Cambria" pitchFamily="34" charset="-122"/>
@@ -4915,11 +4915,11 @@
             <a:avLst/>
           </a:prstGeom>
           <a:solidFill>
-            <a:srgbClr val="F4F1EE"/>
+            <a:srgbClr val="F2F5F8"/>
           </a:solidFill>
           <a:ln w="15875">
             <a:solidFill>
-              <a:srgbClr val="B85042"/>
+              <a:srgbClr val="1D5C9B"/>
             </a:solidFill>
             <a:prstDash val="solid"/>
           </a:ln>
@@ -4952,7 +4952,7 @@
             <a:r>
               <a:rPr lang="en-US" sz="1900" b="1" dirty="0">
                 <a:solidFill>
-                  <a:srgbClr val="B85042"/>
+                  <a:srgbClr val="1D5C9B"/>
                 </a:solidFill>
                 <a:latin typeface="Cambria" pitchFamily="34" charset="0"/>
                 <a:ea typeface="Cambria" pitchFamily="34" charset="-122"/>
@@ -4991,7 +4991,7 @@
             <a:r>
               <a:rPr lang="en-US" sz="2100" b="1" dirty="0">
                 <a:solidFill>
-                  <a:srgbClr val="2E2A28"/>
+                  <a:srgbClr val="16212E"/>
                 </a:solidFill>
                 <a:latin typeface="Cambria" pitchFamily="34" charset="0"/>
                 <a:ea typeface="Cambria" pitchFamily="34" charset="-122"/>
@@ -5033,7 +5033,7 @@
             <a:r>
               <a:rPr lang="en-US" sz="1550" dirty="0">
                 <a:solidFill>
-                  <a:srgbClr val="7A736E"/>
+                  <a:srgbClr val="6B7787"/>
                 </a:solidFill>
                 <a:latin typeface="Calibri" pitchFamily="34" charset="0"/>
                 <a:ea typeface="Calibri" pitchFamily="34" charset="-122"/>
@@ -5060,11 +5060,11 @@
             <a:avLst/>
           </a:prstGeom>
           <a:solidFill>
-            <a:srgbClr val="F4F1EE"/>
+            <a:srgbClr val="F2F5F8"/>
           </a:solidFill>
           <a:ln w="15875">
             <a:solidFill>
-              <a:srgbClr val="B85042"/>
+              <a:srgbClr val="1D5C9B"/>
             </a:solidFill>
             <a:prstDash val="solid"/>
           </a:ln>
@@ -5097,7 +5097,7 @@
             <a:r>
               <a:rPr lang="en-US" sz="1900" b="1" dirty="0">
                 <a:solidFill>
-                  <a:srgbClr val="B85042"/>
+                  <a:srgbClr val="1D5C9B"/>
                 </a:solidFill>
                 <a:latin typeface="Cambria" pitchFamily="34" charset="0"/>
                 <a:ea typeface="Cambria" pitchFamily="34" charset="-122"/>
@@ -5136,7 +5136,7 @@
             <a:r>
               <a:rPr lang="en-US" sz="2100" b="1" dirty="0">
                 <a:solidFill>
-                  <a:srgbClr val="2E2A28"/>
+                  <a:srgbClr val="16212E"/>
                 </a:solidFill>
                 <a:latin typeface="Cambria" pitchFamily="34" charset="0"/>
                 <a:ea typeface="Cambria" pitchFamily="34" charset="-122"/>
@@ -5178,7 +5178,7 @@
             <a:r>
               <a:rPr lang="en-US" sz="1550" dirty="0">
                 <a:solidFill>
-                  <a:srgbClr val="7A736E"/>
+                  <a:srgbClr val="6B7787"/>
                 </a:solidFill>
                 <a:latin typeface="Calibri" pitchFamily="34" charset="0"/>
                 <a:ea typeface="Calibri" pitchFamily="34" charset="-122"/>
@@ -5205,11 +5205,11 @@
             <a:avLst/>
           </a:prstGeom>
           <a:solidFill>
-            <a:srgbClr val="B85042"/>
+            <a:srgbClr val="1D5C9B"/>
           </a:solidFill>
           <a:ln w="15875">
             <a:solidFill>
-              <a:srgbClr val="B85042"/>
+              <a:srgbClr val="1D5C9B"/>
             </a:solidFill>
             <a:prstDash val="solid"/>
           </a:ln>
@@ -5281,7 +5281,7 @@
             <a:r>
               <a:rPr lang="en-US" sz="2100" b="1" dirty="0">
                 <a:solidFill>
-                  <a:srgbClr val="2E2A28"/>
+                  <a:srgbClr val="16212E"/>
                 </a:solidFill>
                 <a:latin typeface="Cambria" pitchFamily="34" charset="0"/>
                 <a:ea typeface="Cambria" pitchFamily="34" charset="-122"/>
@@ -5323,7 +5323,7 @@
             <a:r>
               <a:rPr lang="en-US" sz="1550" dirty="0">
                 <a:solidFill>
-                  <a:srgbClr val="7A736E"/>
+                  <a:srgbClr val="6B7787"/>
                 </a:solidFill>
                 <a:latin typeface="Calibri" pitchFamily="34" charset="0"/>
                 <a:ea typeface="Calibri" pitchFamily="34" charset="-122"/>
@@ -5350,11 +5350,11 @@
             <a:avLst/>
           </a:prstGeom>
           <a:solidFill>
-            <a:srgbClr val="F4F1EE"/>
+            <a:srgbClr val="F2F5F8"/>
           </a:solidFill>
           <a:ln w="15875">
             <a:solidFill>
-              <a:srgbClr val="B85042"/>
+              <a:srgbClr val="1D5C9B"/>
             </a:solidFill>
             <a:prstDash val="solid"/>
           </a:ln>
@@ -5387,7 +5387,7 @@
             <a:r>
               <a:rPr lang="en-US" sz="1900" b="1" dirty="0">
                 <a:solidFill>
-                  <a:srgbClr val="B85042"/>
+                  <a:srgbClr val="1D5C9B"/>
                 </a:solidFill>
                 <a:latin typeface="Cambria" pitchFamily="34" charset="0"/>
                 <a:ea typeface="Cambria" pitchFamily="34" charset="-122"/>
@@ -5426,7 +5426,7 @@
             <a:r>
               <a:rPr lang="en-US" sz="2100" b="1" dirty="0">
                 <a:solidFill>
-                  <a:srgbClr val="2E2A28"/>
+                  <a:srgbClr val="16212E"/>
                 </a:solidFill>
                 <a:latin typeface="Cambria" pitchFamily="34" charset="0"/>
                 <a:ea typeface="Cambria" pitchFamily="34" charset="-122"/>
@@ -5468,7 +5468,7 @@
             <a:r>
               <a:rPr lang="en-US" sz="1550" dirty="0">
                 <a:solidFill>
-                  <a:srgbClr val="7A736E"/>
+                  <a:srgbClr val="6B7787"/>
                 </a:solidFill>
                 <a:latin typeface="Calibri" pitchFamily="34" charset="0"/>
                 <a:ea typeface="Calibri" pitchFamily="34" charset="-122"/>
@@ -5539,7 +5539,7 @@
             <a:r>
               <a:rPr lang="en-US" sz="4000" b="1" dirty="0">
                 <a:solidFill>
-                  <a:srgbClr val="2E2A28"/>
+                  <a:srgbClr val="16212E"/>
                 </a:solidFill>
                 <a:latin typeface="Cambria" pitchFamily="34" charset="0"/>
                 <a:ea typeface="Cambria" pitchFamily="34" charset="-122"/>
@@ -5581,7 +5581,7 @@
             <a:r>
               <a:rPr lang="en-US" sz="1700" dirty="0">
                 <a:solidFill>
-                  <a:srgbClr val="2E2A28"/>
+                  <a:srgbClr val="16212E"/>
                 </a:solidFill>
                 <a:latin typeface="Calibri" pitchFamily="34" charset="0"/>
                 <a:ea typeface="Calibri" pitchFamily="34" charset="-122"/>
@@ -5610,7 +5610,7 @@
             <a:r>
               <a:rPr lang="en-US" sz="1700" dirty="0">
                 <a:solidFill>
-                  <a:srgbClr val="2E2A28"/>
+                  <a:srgbClr val="16212E"/>
                 </a:solidFill>
                 <a:latin typeface="Calibri" pitchFamily="34" charset="0"/>
                 <a:ea typeface="Calibri" pitchFamily="34" charset="-122"/>
@@ -5639,11 +5639,11 @@
             </a:avLst>
           </a:prstGeom>
           <a:solidFill>
-            <a:srgbClr val="F4F1EE"/>
+            <a:srgbClr val="F2F5F8"/>
           </a:solidFill>
           <a:ln w="12700">
             <a:solidFill>
-              <a:srgbClr val="E6E0DA"/>
+              <a:srgbClr val="E1E8EF"/>
             </a:solidFill>
             <a:prstDash val="solid"/>
           </a:ln>
@@ -5683,7 +5683,7 @@
             <a:r>
               <a:rPr lang="en-US" sz="3400" b="1" dirty="0">
                 <a:solidFill>
-                  <a:srgbClr val="B85042"/>
+                  <a:srgbClr val="1D5C9B"/>
                 </a:solidFill>
                 <a:latin typeface="Cambria" pitchFamily="34" charset="0"/>
                 <a:ea typeface="Cambria" pitchFamily="34" charset="-122"/>
@@ -5722,7 +5722,7 @@
             <a:r>
               <a:rPr lang="en-US" sz="1400" dirty="0">
                 <a:solidFill>
-                  <a:srgbClr val="7A736E"/>
+                  <a:srgbClr val="6B7787"/>
                 </a:solidFill>
                 <a:latin typeface="Calibri" pitchFamily="34" charset="0"/>
                 <a:ea typeface="Calibri" pitchFamily="34" charset="-122"/>
@@ -5751,11 +5751,11 @@
             </a:avLst>
           </a:prstGeom>
           <a:solidFill>
-            <a:srgbClr val="F4F1EE"/>
+            <a:srgbClr val="F2F5F8"/>
           </a:solidFill>
           <a:ln w="12700">
             <a:solidFill>
-              <a:srgbClr val="E6E0DA"/>
+              <a:srgbClr val="E1E8EF"/>
             </a:solidFill>
             <a:prstDash val="solid"/>
           </a:ln>
@@ -5795,7 +5795,7 @@
             <a:r>
               <a:rPr lang="en-US" sz="3400" b="1" dirty="0">
                 <a:solidFill>
-                  <a:srgbClr val="B85042"/>
+                  <a:srgbClr val="1D5C9B"/>
                 </a:solidFill>
                 <a:latin typeface="Cambria" pitchFamily="34" charset="0"/>
                 <a:ea typeface="Cambria" pitchFamily="34" charset="-122"/>
@@ -5834,7 +5834,7 @@
             <a:r>
               <a:rPr lang="en-US" sz="1400" dirty="0">
                 <a:solidFill>
-                  <a:srgbClr val="7A736E"/>
+                  <a:srgbClr val="6B7787"/>
                 </a:solidFill>
                 <a:latin typeface="Calibri" pitchFamily="34" charset="0"/>
                 <a:ea typeface="Calibri" pitchFamily="34" charset="-122"/>
@@ -5863,11 +5863,11 @@
             </a:avLst>
           </a:prstGeom>
           <a:solidFill>
-            <a:srgbClr val="B85042"/>
+            <a:srgbClr val="1D5C9B"/>
           </a:solidFill>
           <a:ln w="12700">
             <a:solidFill>
-              <a:srgbClr val="B85042"/>
+              <a:srgbClr val="1D5C9B"/>
             </a:solidFill>
             <a:prstDash val="solid"/>
           </a:ln>
@@ -5975,7 +5975,7 @@
             </a:avLst>
           </a:prstGeom>
           <a:solidFill>
-            <a:srgbClr val="E7E8D1"/>
+            <a:srgbClr val="DCE6F0"/>
           </a:solidFill>
           <a:ln/>
         </p:spPr>
@@ -6010,7 +6010,7 @@
             <a:r>
               <a:rPr lang="en-US" sz="1600" b="1" i="1" dirty="0">
                 <a:solidFill>
-                  <a:srgbClr val="5C4A2E"/>
+                  <a:srgbClr val="1C3D5C"/>
                 </a:solidFill>
                 <a:latin typeface="Calibri" pitchFamily="34" charset="0"/>
                 <a:ea typeface="Calibri" pitchFamily="34" charset="-122"/>
@@ -6049,7 +6049,7 @@
             <a:r>
               <a:rPr lang="en-US" sz="1150" dirty="0">
                 <a:solidFill>
-                  <a:srgbClr val="7C7460"/>
+                  <a:srgbClr val="5A748E"/>
                 </a:solidFill>
                 <a:latin typeface="Calibri" pitchFamily="34" charset="0"/>
                 <a:ea typeface="Calibri" pitchFamily="34" charset="-122"/>
@@ -6120,7 +6120,7 @@
             <a:r>
               <a:rPr lang="en-US" sz="4000" b="1" dirty="0">
                 <a:solidFill>
-                  <a:srgbClr val="2E2A28"/>
+                  <a:srgbClr val="16212E"/>
                 </a:solidFill>
                 <a:latin typeface="Cambria" pitchFamily="34" charset="0"/>
                 <a:ea typeface="Cambria" pitchFamily="34" charset="-122"/>
@@ -6159,7 +6159,7 @@
             <a:r>
               <a:rPr lang="en-US" sz="1700" dirty="0">
                 <a:solidFill>
-                  <a:srgbClr val="7A736E"/>
+                  <a:srgbClr val="6B7787"/>
                 </a:solidFill>
                 <a:latin typeface="Calibri" pitchFamily="34" charset="0"/>
                 <a:ea typeface="Calibri" pitchFamily="34" charset="-122"/>
@@ -6186,7 +6186,7 @@
             <a:avLst/>
           </a:prstGeom>
           <a:solidFill>
-            <a:srgbClr val="DDD6D0"/>
+            <a:srgbClr val="D2DDE7"/>
           </a:solidFill>
           <a:ln/>
         </p:spPr>
@@ -6206,11 +6206,11 @@
             <a:avLst/>
           </a:prstGeom>
           <a:solidFill>
-            <a:srgbClr val="B85042"/>
+            <a:srgbClr val="1D5C9B"/>
           </a:solidFill>
           <a:ln w="15875">
             <a:solidFill>
-              <a:srgbClr val="B85042"/>
+              <a:srgbClr val="1D5C9B"/>
             </a:solidFill>
             <a:prstDash val="solid"/>
           </a:ln>
@@ -6282,7 +6282,7 @@
             <a:r>
               <a:rPr lang="en-US" sz="1700" b="1" dirty="0">
                 <a:solidFill>
-                  <a:srgbClr val="2E2A28"/>
+                  <a:srgbClr val="16212E"/>
                 </a:solidFill>
                 <a:latin typeface="Cambria" pitchFamily="34" charset="0"/>
                 <a:ea typeface="Cambria" pitchFamily="34" charset="-122"/>
@@ -6324,7 +6324,7 @@
             <a:r>
               <a:rPr lang="en-US" sz="1350" dirty="0">
                 <a:solidFill>
-                  <a:srgbClr val="7A736E"/>
+                  <a:srgbClr val="6B7787"/>
                 </a:solidFill>
                 <a:latin typeface="Calibri" pitchFamily="34" charset="0"/>
                 <a:ea typeface="Calibri" pitchFamily="34" charset="-122"/>
@@ -6351,7 +6351,7 @@
             <a:avLst/>
           </a:prstGeom>
           <a:solidFill>
-            <a:srgbClr val="DDD6D0"/>
+            <a:srgbClr val="D2DDE7"/>
           </a:solidFill>
           <a:ln/>
         </p:spPr>
@@ -6371,11 +6371,11 @@
             <a:avLst/>
           </a:prstGeom>
           <a:solidFill>
-            <a:srgbClr val="F4F1EE"/>
+            <a:srgbClr val="F2F5F8"/>
           </a:solidFill>
           <a:ln w="15875">
             <a:solidFill>
-              <a:srgbClr val="B85042"/>
+              <a:srgbClr val="1D5C9B"/>
             </a:solidFill>
             <a:prstDash val="solid"/>
           </a:ln>
@@ -6408,7 +6408,7 @@
             <a:r>
               <a:rPr lang="en-US" sz="1900" b="1" dirty="0">
                 <a:solidFill>
-                  <a:srgbClr val="B85042"/>
+                  <a:srgbClr val="1D5C9B"/>
                 </a:solidFill>
                 <a:latin typeface="Cambria" pitchFamily="34" charset="0"/>
                 <a:ea typeface="Cambria" pitchFamily="34" charset="-122"/>
@@ -6447,7 +6447,7 @@
             <a:r>
               <a:rPr lang="en-US" sz="1700" b="1" dirty="0">
                 <a:solidFill>
-                  <a:srgbClr val="2E2A28"/>
+                  <a:srgbClr val="16212E"/>
                 </a:solidFill>
                 <a:latin typeface="Cambria" pitchFamily="34" charset="0"/>
                 <a:ea typeface="Cambria" pitchFamily="34" charset="-122"/>
@@ -6489,7 +6489,7 @@
             <a:r>
               <a:rPr lang="en-US" sz="1350" dirty="0">
                 <a:solidFill>
-                  <a:srgbClr val="7A736E"/>
+                  <a:srgbClr val="6B7787"/>
                 </a:solidFill>
                 <a:latin typeface="Calibri" pitchFamily="34" charset="0"/>
                 <a:ea typeface="Calibri" pitchFamily="34" charset="-122"/>
@@ -6516,7 +6516,7 @@
             <a:avLst/>
           </a:prstGeom>
           <a:solidFill>
-            <a:srgbClr val="DDD6D0"/>
+            <a:srgbClr val="D2DDE7"/>
           </a:solidFill>
           <a:ln/>
         </p:spPr>
@@ -6536,11 +6536,11 @@
             <a:avLst/>
           </a:prstGeom>
           <a:solidFill>
-            <a:srgbClr val="F4F1EE"/>
+            <a:srgbClr val="F2F5F8"/>
           </a:solidFill>
           <a:ln w="15875">
             <a:solidFill>
-              <a:srgbClr val="B85042"/>
+              <a:srgbClr val="1D5C9B"/>
             </a:solidFill>
             <a:prstDash val="solid"/>
           </a:ln>
@@ -6573,7 +6573,7 @@
             <a:r>
               <a:rPr lang="en-US" sz="1900" b="1" dirty="0">
                 <a:solidFill>
-                  <a:srgbClr val="B85042"/>
+                  <a:srgbClr val="1D5C9B"/>
                 </a:solidFill>
                 <a:latin typeface="Cambria" pitchFamily="34" charset="0"/>
                 <a:ea typeface="Cambria" pitchFamily="34" charset="-122"/>
@@ -6612,7 +6612,7 @@
             <a:r>
               <a:rPr lang="en-US" sz="1700" b="1" dirty="0">
                 <a:solidFill>
-                  <a:srgbClr val="2E2A28"/>
+                  <a:srgbClr val="16212E"/>
                 </a:solidFill>
                 <a:latin typeface="Cambria" pitchFamily="34" charset="0"/>
                 <a:ea typeface="Cambria" pitchFamily="34" charset="-122"/>
@@ -6654,7 +6654,7 @@
             <a:r>
               <a:rPr lang="en-US" sz="1350" dirty="0">
                 <a:solidFill>
-                  <a:srgbClr val="7A736E"/>
+                  <a:srgbClr val="6B7787"/>
                 </a:solidFill>
                 <a:latin typeface="Calibri" pitchFamily="34" charset="0"/>
                 <a:ea typeface="Calibri" pitchFamily="34" charset="-122"/>
@@ -6681,7 +6681,7 @@
             <a:avLst/>
           </a:prstGeom>
           <a:solidFill>
-            <a:srgbClr val="DDD6D0"/>
+            <a:srgbClr val="D2DDE7"/>
           </a:solidFill>
           <a:ln/>
         </p:spPr>
@@ -6701,11 +6701,11 @@
             <a:avLst/>
           </a:prstGeom>
           <a:solidFill>
-            <a:srgbClr val="F4F1EE"/>
+            <a:srgbClr val="F2F5F8"/>
           </a:solidFill>
           <a:ln w="15875">
             <a:solidFill>
-              <a:srgbClr val="B85042"/>
+              <a:srgbClr val="1D5C9B"/>
             </a:solidFill>
             <a:prstDash val="solid"/>
           </a:ln>
@@ -6738,7 +6738,7 @@
             <a:r>
               <a:rPr lang="en-US" sz="1900" b="1" dirty="0">
                 <a:solidFill>
-                  <a:srgbClr val="B85042"/>
+                  <a:srgbClr val="1D5C9B"/>
                 </a:solidFill>
                 <a:latin typeface="Cambria" pitchFamily="34" charset="0"/>
                 <a:ea typeface="Cambria" pitchFamily="34" charset="-122"/>
@@ -6777,7 +6777,7 @@
             <a:r>
               <a:rPr lang="en-US" sz="1700" b="1" dirty="0">
                 <a:solidFill>
-                  <a:srgbClr val="2E2A28"/>
+                  <a:srgbClr val="16212E"/>
                 </a:solidFill>
                 <a:latin typeface="Cambria" pitchFamily="34" charset="0"/>
                 <a:ea typeface="Cambria" pitchFamily="34" charset="-122"/>
@@ -6819,7 +6819,7 @@
             <a:r>
               <a:rPr lang="en-US" sz="1350" dirty="0">
                 <a:solidFill>
-                  <a:srgbClr val="7A736E"/>
+                  <a:srgbClr val="6B7787"/>
                 </a:solidFill>
                 <a:latin typeface="Calibri" pitchFamily="34" charset="0"/>
                 <a:ea typeface="Calibri" pitchFamily="34" charset="-122"/>
@@ -6846,11 +6846,11 @@
             <a:avLst/>
           </a:prstGeom>
           <a:solidFill>
-            <a:srgbClr val="F4F1EE"/>
+            <a:srgbClr val="F2F5F8"/>
           </a:solidFill>
           <a:ln w="15875">
             <a:solidFill>
-              <a:srgbClr val="B85042"/>
+              <a:srgbClr val="1D5C9B"/>
             </a:solidFill>
             <a:prstDash val="solid"/>
           </a:ln>
@@ -6883,7 +6883,7 @@
             <a:r>
               <a:rPr lang="en-US" sz="1900" b="1" dirty="0">
                 <a:solidFill>
-                  <a:srgbClr val="B85042"/>
+                  <a:srgbClr val="1D5C9B"/>
                 </a:solidFill>
                 <a:latin typeface="Cambria" pitchFamily="34" charset="0"/>
                 <a:ea typeface="Cambria" pitchFamily="34" charset="-122"/>
@@ -6922,7 +6922,7 @@
             <a:r>
               <a:rPr lang="en-US" sz="1700" b="1" dirty="0">
                 <a:solidFill>
-                  <a:srgbClr val="2E2A28"/>
+                  <a:srgbClr val="16212E"/>
                 </a:solidFill>
                 <a:latin typeface="Cambria" pitchFamily="34" charset="0"/>
                 <a:ea typeface="Cambria" pitchFamily="34" charset="-122"/>
@@ -6964,7 +6964,7 @@
             <a:r>
               <a:rPr lang="en-US" sz="1350" dirty="0">
                 <a:solidFill>
-                  <a:srgbClr val="7A736E"/>
+                  <a:srgbClr val="6B7787"/>
                 </a:solidFill>
                 <a:latin typeface="Calibri" pitchFamily="34" charset="0"/>
                 <a:ea typeface="Calibri" pitchFamily="34" charset="-122"/>
@@ -6993,7 +6993,7 @@
             </a:avLst>
           </a:prstGeom>
           <a:solidFill>
-            <a:srgbClr val="E7E8D1"/>
+            <a:srgbClr val="DCE6F0"/>
           </a:solidFill>
           <a:ln/>
         </p:spPr>
@@ -7025,7 +7025,7 @@
             <a:r>
               <a:rPr lang="en-US" sz="1550" dirty="0">
                 <a:solidFill>
-                  <a:srgbClr val="2E2A28"/>
+                  <a:srgbClr val="16212E"/>
                 </a:solidFill>
                 <a:latin typeface="Calibri" pitchFamily="34" charset="0"/>
                 <a:ea typeface="Calibri" pitchFamily="34" charset="-122"/>
@@ -7096,7 +7096,7 @@
             <a:r>
               <a:rPr lang="en-US" sz="5000" b="1" dirty="0">
                 <a:solidFill>
-                  <a:srgbClr val="B85042"/>
+                  <a:srgbClr val="1D5C9B"/>
                 </a:solidFill>
                 <a:latin typeface="Cambria" pitchFamily="34" charset="0"/>
                 <a:ea typeface="Cambria" pitchFamily="34" charset="-122"/>
@@ -7135,7 +7135,7 @@
             <a:r>
               <a:rPr lang="en-US" sz="3600" b="1" dirty="0">
                 <a:solidFill>
-                  <a:srgbClr val="2E2A28"/>
+                  <a:srgbClr val="16212E"/>
                 </a:solidFill>
                 <a:latin typeface="Cambria" pitchFamily="34" charset="0"/>
                 <a:ea typeface="Cambria" pitchFamily="34" charset="-122"/>
@@ -7164,11 +7164,11 @@
             </a:avLst>
           </a:prstGeom>
           <a:solidFill>
-            <a:srgbClr val="F4F1EE"/>
+            <a:srgbClr val="F2F5F8"/>
           </a:solidFill>
           <a:ln w="12700">
             <a:solidFill>
-              <a:srgbClr val="E6E0DA"/>
+              <a:srgbClr val="E1E8EF"/>
             </a:solidFill>
             <a:prstDash val="solid"/>
           </a:ln>
@@ -7208,7 +7208,7 @@
             <a:r>
               <a:rPr lang="en-US" sz="1150" b="1" spc="200" kern="0" dirty="0">
                 <a:solidFill>
-                  <a:srgbClr val="7A736E"/>
+                  <a:srgbClr val="6B7787"/>
                 </a:solidFill>
                 <a:latin typeface="Calibri" pitchFamily="34" charset="0"/>
                 <a:ea typeface="Calibri" pitchFamily="34" charset="-122"/>
@@ -7250,7 +7250,7 @@
             <a:r>
               <a:rPr lang="en-US" sz="1450" dirty="0">
                 <a:solidFill>
-                  <a:srgbClr val="2E2A28"/>
+                  <a:srgbClr val="16212E"/>
                 </a:solidFill>
                 <a:latin typeface="Calibri" pitchFamily="34" charset="0"/>
                 <a:ea typeface="Calibri" pitchFamily="34" charset="-122"/>
@@ -7292,7 +7292,7 @@
             <a:r>
               <a:rPr lang="en-US" sz="1350" b="1" i="1" dirty="0">
                 <a:solidFill>
-                  <a:srgbClr val="B85042"/>
+                  <a:srgbClr val="1D5C9B"/>
                 </a:solidFill>
                 <a:latin typeface="Calibri" pitchFamily="34" charset="0"/>
                 <a:ea typeface="Calibri" pitchFamily="34" charset="-122"/>
@@ -7321,11 +7321,11 @@
             </a:avLst>
           </a:prstGeom>
           <a:solidFill>
-            <a:srgbClr val="E7E8D1"/>
+            <a:srgbClr val="DCE6F0"/>
           </a:solidFill>
           <a:ln w="12700">
             <a:solidFill>
-              <a:srgbClr val="D8DAC0"/>
+              <a:srgbClr val="C3D3E3"/>
             </a:solidFill>
             <a:prstDash val="solid"/>
           </a:ln>
@@ -7365,7 +7365,7 @@
             <a:r>
               <a:rPr lang="en-US" sz="1150" b="1" spc="200" kern="0" dirty="0">
                 <a:solidFill>
-                  <a:srgbClr val="6E7A5E"/>
+                  <a:srgbClr val="3E6488"/>
                 </a:solidFill>
                 <a:latin typeface="Calibri" pitchFamily="34" charset="0"/>
                 <a:ea typeface="Calibri" pitchFamily="34" charset="-122"/>
@@ -7407,7 +7407,7 @@
             <a:r>
               <a:rPr lang="en-US" sz="1450" dirty="0">
                 <a:solidFill>
-                  <a:srgbClr val="2E2A28"/>
+                  <a:srgbClr val="16212E"/>
                 </a:solidFill>
                 <a:latin typeface="Calibri" pitchFamily="34" charset="0"/>
                 <a:ea typeface="Calibri" pitchFamily="34" charset="-122"/>
@@ -7446,7 +7446,7 @@
             <a:r>
               <a:rPr lang="en-US" sz="1150" b="1" spc="200" kern="0" dirty="0">
                 <a:solidFill>
-                  <a:srgbClr val="B85042"/>
+                  <a:srgbClr val="1D5C9B"/>
                 </a:solidFill>
                 <a:latin typeface="Calibri" pitchFamily="34" charset="0"/>
                 <a:ea typeface="Calibri" pitchFamily="34" charset="-122"/>
@@ -7475,11 +7475,11 @@
             </a:avLst>
           </a:prstGeom>
           <a:solidFill>
-            <a:srgbClr val="FAF8F6"/>
+            <a:srgbClr val="F8FAFC"/>
           </a:solidFill>
           <a:ln w="12700">
             <a:solidFill>
-              <a:srgbClr val="E0D6D2"/>
+              <a:srgbClr val="DCE4EC"/>
             </a:solidFill>
             <a:prstDash val="solid"/>
           </a:ln>
@@ -7512,7 +7512,7 @@
             <a:r>
               <a:rPr lang="en-US" sz="1500" b="1" dirty="0">
                 <a:solidFill>
-                  <a:srgbClr val="B85042"/>
+                  <a:srgbClr val="1D5C9B"/>
                 </a:solidFill>
                 <a:latin typeface="Cambria" pitchFamily="34" charset="0"/>
                 <a:ea typeface="Cambria" pitchFamily="34" charset="-122"/>
@@ -7554,7 +7554,7 @@
             <a:r>
               <a:rPr lang="en-US" sz="1250" dirty="0">
                 <a:solidFill>
-                  <a:srgbClr val="2E2A28"/>
+                  <a:srgbClr val="16212E"/>
                 </a:solidFill>
                 <a:latin typeface="Calibri" pitchFamily="34" charset="0"/>
                 <a:ea typeface="Calibri" pitchFamily="34" charset="-122"/>
@@ -7583,11 +7583,11 @@
             </a:avLst>
           </a:prstGeom>
           <a:solidFill>
-            <a:srgbClr val="FAF8F6"/>
+            <a:srgbClr val="F8FAFC"/>
           </a:solidFill>
           <a:ln w="12700">
             <a:solidFill>
-              <a:srgbClr val="E0D6D2"/>
+              <a:srgbClr val="DCE4EC"/>
             </a:solidFill>
             <a:prstDash val="solid"/>
           </a:ln>
@@ -7620,7 +7620,7 @@
             <a:r>
               <a:rPr lang="en-US" sz="1500" b="1" dirty="0">
                 <a:solidFill>
-                  <a:srgbClr val="B85042"/>
+                  <a:srgbClr val="1D5C9B"/>
                 </a:solidFill>
                 <a:latin typeface="Cambria" pitchFamily="34" charset="0"/>
                 <a:ea typeface="Cambria" pitchFamily="34" charset="-122"/>
@@ -7662,7 +7662,7 @@
             <a:r>
               <a:rPr lang="en-US" sz="1250" dirty="0">
                 <a:solidFill>
-                  <a:srgbClr val="2E2A28"/>
+                  <a:srgbClr val="16212E"/>
                 </a:solidFill>
                 <a:latin typeface="Calibri" pitchFamily="34" charset="0"/>
                 <a:ea typeface="Calibri" pitchFamily="34" charset="-122"/>
@@ -7691,11 +7691,11 @@
             </a:avLst>
           </a:prstGeom>
           <a:solidFill>
-            <a:srgbClr val="FAF8F6"/>
+            <a:srgbClr val="F8FAFC"/>
           </a:solidFill>
           <a:ln w="12700">
             <a:solidFill>
-              <a:srgbClr val="E0D6D2"/>
+              <a:srgbClr val="DCE4EC"/>
             </a:solidFill>
             <a:prstDash val="solid"/>
           </a:ln>
@@ -7728,7 +7728,7 @@
             <a:r>
               <a:rPr lang="en-US" sz="1500" b="1" dirty="0">
                 <a:solidFill>
-                  <a:srgbClr val="B85042"/>
+                  <a:srgbClr val="1D5C9B"/>
                 </a:solidFill>
                 <a:latin typeface="Cambria" pitchFamily="34" charset="0"/>
                 <a:ea typeface="Cambria" pitchFamily="34" charset="-122"/>
@@ -7770,7 +7770,7 @@
             <a:r>
               <a:rPr lang="en-US" sz="1250" dirty="0">
                 <a:solidFill>
-                  <a:srgbClr val="2E2A28"/>
+                  <a:srgbClr val="16212E"/>
                 </a:solidFill>
                 <a:latin typeface="Calibri" pitchFamily="34" charset="0"/>
                 <a:ea typeface="Calibri" pitchFamily="34" charset="-122"/>
@@ -7841,7 +7841,7 @@
             <a:r>
               <a:rPr lang="en-US" sz="5000" b="1" dirty="0">
                 <a:solidFill>
-                  <a:srgbClr val="B85042"/>
+                  <a:srgbClr val="1D5C9B"/>
                 </a:solidFill>
                 <a:latin typeface="Cambria" pitchFamily="34" charset="0"/>
                 <a:ea typeface="Cambria" pitchFamily="34" charset="-122"/>
@@ -7880,7 +7880,7 @@
             <a:r>
               <a:rPr lang="en-US" sz="3600" b="1" dirty="0">
                 <a:solidFill>
-                  <a:srgbClr val="2E2A28"/>
+                  <a:srgbClr val="16212E"/>
                 </a:solidFill>
                 <a:latin typeface="Cambria" pitchFamily="34" charset="0"/>
                 <a:ea typeface="Cambria" pitchFamily="34" charset="-122"/>
@@ -7909,11 +7909,11 @@
             </a:avLst>
           </a:prstGeom>
           <a:solidFill>
-            <a:srgbClr val="F4F1EE"/>
+            <a:srgbClr val="F2F5F8"/>
           </a:solidFill>
           <a:ln w="12700">
             <a:solidFill>
-              <a:srgbClr val="E6E0DA"/>
+              <a:srgbClr val="E1E8EF"/>
             </a:solidFill>
             <a:prstDash val="solid"/>
           </a:ln>
@@ -7953,7 +7953,7 @@
             <a:r>
               <a:rPr lang="en-US" sz="1150" b="1" spc="200" kern="0" dirty="0">
                 <a:solidFill>
-                  <a:srgbClr val="7A736E"/>
+                  <a:srgbClr val="6B7787"/>
                 </a:solidFill>
                 <a:latin typeface="Calibri" pitchFamily="34" charset="0"/>
                 <a:ea typeface="Calibri" pitchFamily="34" charset="-122"/>
@@ -7995,7 +7995,7 @@
             <a:r>
               <a:rPr lang="en-US" sz="1450" dirty="0">
                 <a:solidFill>
-                  <a:srgbClr val="2E2A28"/>
+                  <a:srgbClr val="16212E"/>
                 </a:solidFill>
                 <a:latin typeface="Calibri" pitchFamily="34" charset="0"/>
                 <a:ea typeface="Calibri" pitchFamily="34" charset="-122"/>
@@ -8037,7 +8037,7 @@
             <a:r>
               <a:rPr lang="en-US" sz="1350" b="1" i="1" dirty="0">
                 <a:solidFill>
-                  <a:srgbClr val="B85042"/>
+                  <a:srgbClr val="1D5C9B"/>
                 </a:solidFill>
                 <a:latin typeface="Calibri" pitchFamily="34" charset="0"/>
                 <a:ea typeface="Calibri" pitchFamily="34" charset="-122"/>
@@ -8066,11 +8066,11 @@
             </a:avLst>
           </a:prstGeom>
           <a:solidFill>
-            <a:srgbClr val="E7E8D1"/>
+            <a:srgbClr val="DCE6F0"/>
           </a:solidFill>
           <a:ln w="12700">
             <a:solidFill>
-              <a:srgbClr val="D8DAC0"/>
+              <a:srgbClr val="C3D3E3"/>
             </a:solidFill>
             <a:prstDash val="solid"/>
           </a:ln>
@@ -8110,7 +8110,7 @@
             <a:r>
               <a:rPr lang="en-US" sz="1150" b="1" spc="200" kern="0" dirty="0">
                 <a:solidFill>
-                  <a:srgbClr val="6E7A5E"/>
+                  <a:srgbClr val="3E6488"/>
                 </a:solidFill>
                 <a:latin typeface="Calibri" pitchFamily="34" charset="0"/>
                 <a:ea typeface="Calibri" pitchFamily="34" charset="-122"/>
@@ -8152,7 +8152,7 @@
             <a:r>
               <a:rPr lang="en-US" sz="1450" dirty="0">
                 <a:solidFill>
-                  <a:srgbClr val="2E2A28"/>
+                  <a:srgbClr val="16212E"/>
                 </a:solidFill>
                 <a:latin typeface="Calibri" pitchFamily="34" charset="0"/>
                 <a:ea typeface="Calibri" pitchFamily="34" charset="-122"/>
@@ -8191,7 +8191,7 @@
             <a:r>
               <a:rPr lang="en-US" sz="1150" b="1" spc="200" kern="0" dirty="0">
                 <a:solidFill>
-                  <a:srgbClr val="B85042"/>
+                  <a:srgbClr val="1D5C9B"/>
                 </a:solidFill>
                 <a:latin typeface="Calibri" pitchFamily="34" charset="0"/>
                 <a:ea typeface="Calibri" pitchFamily="34" charset="-122"/>
@@ -8220,11 +8220,11 @@
             </a:avLst>
           </a:prstGeom>
           <a:solidFill>
-            <a:srgbClr val="FAF8F6"/>
+            <a:srgbClr val="F8FAFC"/>
           </a:solidFill>
           <a:ln w="12700">
             <a:solidFill>
-              <a:srgbClr val="E0D6D2"/>
+              <a:srgbClr val="DCE4EC"/>
             </a:solidFill>
             <a:prstDash val="solid"/>
           </a:ln>
@@ -8257,7 +8257,7 @@
             <a:r>
               <a:rPr lang="en-US" sz="1500" b="1" dirty="0">
                 <a:solidFill>
-                  <a:srgbClr val="B85042"/>
+                  <a:srgbClr val="1D5C9B"/>
                 </a:solidFill>
                 <a:latin typeface="Cambria" pitchFamily="34" charset="0"/>
                 <a:ea typeface="Cambria" pitchFamily="34" charset="-122"/>
@@ -8299,7 +8299,7 @@
             <a:r>
               <a:rPr lang="en-US" sz="1250" dirty="0">
                 <a:solidFill>
-                  <a:srgbClr val="2E2A28"/>
+                  <a:srgbClr val="16212E"/>
                 </a:solidFill>
                 <a:latin typeface="Calibri" pitchFamily="34" charset="0"/>
                 <a:ea typeface="Calibri" pitchFamily="34" charset="-122"/>
@@ -8328,11 +8328,11 @@
             </a:avLst>
           </a:prstGeom>
           <a:solidFill>
-            <a:srgbClr val="FAF8F6"/>
+            <a:srgbClr val="F8FAFC"/>
           </a:solidFill>
           <a:ln w="12700">
             <a:solidFill>
-              <a:srgbClr val="E0D6D2"/>
+              <a:srgbClr val="DCE4EC"/>
             </a:solidFill>
             <a:prstDash val="solid"/>
           </a:ln>
@@ -8365,7 +8365,7 @@
             <a:r>
               <a:rPr lang="en-US" sz="1500" b="1" dirty="0">
                 <a:solidFill>
-                  <a:srgbClr val="B85042"/>
+                  <a:srgbClr val="1D5C9B"/>
                 </a:solidFill>
                 <a:latin typeface="Cambria" pitchFamily="34" charset="0"/>
                 <a:ea typeface="Cambria" pitchFamily="34" charset="-122"/>
@@ -8407,7 +8407,7 @@
             <a:r>
               <a:rPr lang="en-US" sz="1250" dirty="0">
                 <a:solidFill>
-                  <a:srgbClr val="2E2A28"/>
+                  <a:srgbClr val="16212E"/>
                 </a:solidFill>
                 <a:latin typeface="Calibri" pitchFamily="34" charset="0"/>
                 <a:ea typeface="Calibri" pitchFamily="34" charset="-122"/>
@@ -8436,11 +8436,11 @@
             </a:avLst>
           </a:prstGeom>
           <a:solidFill>
-            <a:srgbClr val="FAF8F6"/>
+            <a:srgbClr val="F8FAFC"/>
           </a:solidFill>
           <a:ln w="12700">
             <a:solidFill>
-              <a:srgbClr val="E0D6D2"/>
+              <a:srgbClr val="DCE4EC"/>
             </a:solidFill>
             <a:prstDash val="solid"/>
           </a:ln>
@@ -8473,7 +8473,7 @@
             <a:r>
               <a:rPr lang="en-US" sz="1500" b="1" dirty="0">
                 <a:solidFill>
-                  <a:srgbClr val="B85042"/>
+                  <a:srgbClr val="1D5C9B"/>
                 </a:solidFill>
                 <a:latin typeface="Cambria" pitchFamily="34" charset="0"/>
                 <a:ea typeface="Cambria" pitchFamily="34" charset="-122"/>
@@ -8515,7 +8515,7 @@
             <a:r>
               <a:rPr lang="en-US" sz="1250" dirty="0">
                 <a:solidFill>
-                  <a:srgbClr val="2E2A28"/>
+                  <a:srgbClr val="16212E"/>
                 </a:solidFill>
                 <a:latin typeface="Calibri" pitchFamily="34" charset="0"/>
                 <a:ea typeface="Calibri" pitchFamily="34" charset="-122"/>
@@ -8586,7 +8586,7 @@
             <a:r>
               <a:rPr lang="en-US" sz="5000" b="1" dirty="0">
                 <a:solidFill>
-                  <a:srgbClr val="B85042"/>
+                  <a:srgbClr val="1D5C9B"/>
                 </a:solidFill>
                 <a:latin typeface="Cambria" pitchFamily="34" charset="0"/>
                 <a:ea typeface="Cambria" pitchFamily="34" charset="-122"/>
@@ -8625,7 +8625,7 @@
             <a:r>
               <a:rPr lang="en-US" sz="3600" b="1" dirty="0">
                 <a:solidFill>
-                  <a:srgbClr val="2E2A28"/>
+                  <a:srgbClr val="16212E"/>
                 </a:solidFill>
                 <a:latin typeface="Cambria" pitchFamily="34" charset="0"/>
                 <a:ea typeface="Cambria" pitchFamily="34" charset="-122"/>
@@ -8654,11 +8654,11 @@
             </a:avLst>
           </a:prstGeom>
           <a:solidFill>
-            <a:srgbClr val="F4F1EE"/>
+            <a:srgbClr val="F2F5F8"/>
           </a:solidFill>
           <a:ln w="12700">
             <a:solidFill>
-              <a:srgbClr val="E6E0DA"/>
+              <a:srgbClr val="E1E8EF"/>
             </a:solidFill>
             <a:prstDash val="solid"/>
           </a:ln>
@@ -8698,7 +8698,7 @@
             <a:r>
               <a:rPr lang="en-US" sz="1150" b="1" spc="200" kern="0" dirty="0">
                 <a:solidFill>
-                  <a:srgbClr val="7A736E"/>
+                  <a:srgbClr val="6B7787"/>
                 </a:solidFill>
                 <a:latin typeface="Calibri" pitchFamily="34" charset="0"/>
                 <a:ea typeface="Calibri" pitchFamily="34" charset="-122"/>
@@ -8740,7 +8740,7 @@
             <a:r>
               <a:rPr lang="en-US" sz="1450" dirty="0">
                 <a:solidFill>
-                  <a:srgbClr val="2E2A28"/>
+                  <a:srgbClr val="16212E"/>
                 </a:solidFill>
                 <a:latin typeface="Calibri" pitchFamily="34" charset="0"/>
                 <a:ea typeface="Calibri" pitchFamily="34" charset="-122"/>
@@ -8782,7 +8782,7 @@
             <a:r>
               <a:rPr lang="en-US" sz="1350" b="1" i="1" dirty="0">
                 <a:solidFill>
-                  <a:srgbClr val="B85042"/>
+                  <a:srgbClr val="1D5C9B"/>
                 </a:solidFill>
                 <a:latin typeface="Calibri" pitchFamily="34" charset="0"/>
                 <a:ea typeface="Calibri" pitchFamily="34" charset="-122"/>
@@ -8811,11 +8811,11 @@
             </a:avLst>
           </a:prstGeom>
           <a:solidFill>
-            <a:srgbClr val="E7E8D1"/>
+            <a:srgbClr val="DCE6F0"/>
           </a:solidFill>
           <a:ln w="12700">
             <a:solidFill>
-              <a:srgbClr val="D8DAC0"/>
+              <a:srgbClr val="C3D3E3"/>
             </a:solidFill>
             <a:prstDash val="solid"/>
           </a:ln>
@@ -8855,7 +8855,7 @@
             <a:r>
               <a:rPr lang="en-US" sz="1150" b="1" spc="200" kern="0" dirty="0">
                 <a:solidFill>
-                  <a:srgbClr val="6E7A5E"/>
+                  <a:srgbClr val="3E6488"/>
                 </a:solidFill>
                 <a:latin typeface="Calibri" pitchFamily="34" charset="0"/>
                 <a:ea typeface="Calibri" pitchFamily="34" charset="-122"/>
@@ -8897,7 +8897,7 @@
             <a:r>
               <a:rPr lang="en-US" sz="1450" dirty="0">
                 <a:solidFill>
-                  <a:srgbClr val="2E2A28"/>
+                  <a:srgbClr val="16212E"/>
                 </a:solidFill>
                 <a:latin typeface="Calibri" pitchFamily="34" charset="0"/>
                 <a:ea typeface="Calibri" pitchFamily="34" charset="-122"/>
@@ -8936,7 +8936,7 @@
             <a:r>
               <a:rPr lang="en-US" sz="1150" b="1" spc="200" kern="0" dirty="0">
                 <a:solidFill>
-                  <a:srgbClr val="B85042"/>
+                  <a:srgbClr val="1D5C9B"/>
                 </a:solidFill>
                 <a:latin typeface="Calibri" pitchFamily="34" charset="0"/>
                 <a:ea typeface="Calibri" pitchFamily="34" charset="-122"/>
@@ -8965,11 +8965,11 @@
             </a:avLst>
           </a:prstGeom>
           <a:solidFill>
-            <a:srgbClr val="FAF8F6"/>
+            <a:srgbClr val="F8FAFC"/>
           </a:solidFill>
           <a:ln w="12700">
             <a:solidFill>
-              <a:srgbClr val="E0D6D2"/>
+              <a:srgbClr val="DCE4EC"/>
             </a:solidFill>
             <a:prstDash val="solid"/>
           </a:ln>
@@ -9002,7 +9002,7 @@
             <a:r>
               <a:rPr lang="en-US" sz="1500" b="1" dirty="0">
                 <a:solidFill>
-                  <a:srgbClr val="B85042"/>
+                  <a:srgbClr val="1D5C9B"/>
                 </a:solidFill>
                 <a:latin typeface="Cambria" pitchFamily="34" charset="0"/>
                 <a:ea typeface="Cambria" pitchFamily="34" charset="-122"/>
@@ -9044,7 +9044,7 @@
             <a:r>
               <a:rPr lang="en-US" sz="1250" dirty="0">
                 <a:solidFill>
-                  <a:srgbClr val="2E2A28"/>
+                  <a:srgbClr val="16212E"/>
                 </a:solidFill>
                 <a:latin typeface="Calibri" pitchFamily="34" charset="0"/>
                 <a:ea typeface="Calibri" pitchFamily="34" charset="-122"/>
@@ -9073,11 +9073,11 @@
             </a:avLst>
           </a:prstGeom>
           <a:solidFill>
-            <a:srgbClr val="FAF8F6"/>
+            <a:srgbClr val="F8FAFC"/>
           </a:solidFill>
           <a:ln w="12700">
             <a:solidFill>
-              <a:srgbClr val="E0D6D2"/>
+              <a:srgbClr val="DCE4EC"/>
             </a:solidFill>
             <a:prstDash val="solid"/>
           </a:ln>
@@ -9110,7 +9110,7 @@
             <a:r>
               <a:rPr lang="en-US" sz="1500" b="1" dirty="0">
                 <a:solidFill>
-                  <a:srgbClr val="B85042"/>
+                  <a:srgbClr val="1D5C9B"/>
                 </a:solidFill>
                 <a:latin typeface="Cambria" pitchFamily="34" charset="0"/>
                 <a:ea typeface="Cambria" pitchFamily="34" charset="-122"/>
@@ -9152,7 +9152,7 @@
             <a:r>
               <a:rPr lang="en-US" sz="1250" dirty="0">
                 <a:solidFill>
-                  <a:srgbClr val="2E2A28"/>
+                  <a:srgbClr val="16212E"/>
                 </a:solidFill>
                 <a:latin typeface="Calibri" pitchFamily="34" charset="0"/>
                 <a:ea typeface="Calibri" pitchFamily="34" charset="-122"/>
@@ -9181,11 +9181,11 @@
             </a:avLst>
           </a:prstGeom>
           <a:solidFill>
-            <a:srgbClr val="FAF8F6"/>
+            <a:srgbClr val="F8FAFC"/>
           </a:solidFill>
           <a:ln w="12700">
             <a:solidFill>
-              <a:srgbClr val="E0D6D2"/>
+              <a:srgbClr val="DCE4EC"/>
             </a:solidFill>
             <a:prstDash val="solid"/>
           </a:ln>
@@ -9218,7 +9218,7 @@
             <a:r>
               <a:rPr lang="en-US" sz="1500" b="1" dirty="0">
                 <a:solidFill>
-                  <a:srgbClr val="B85042"/>
+                  <a:srgbClr val="1D5C9B"/>
                 </a:solidFill>
                 <a:latin typeface="Cambria" pitchFamily="34" charset="0"/>
                 <a:ea typeface="Cambria" pitchFamily="34" charset="-122"/>
@@ -9260,7 +9260,7 @@
             <a:r>
               <a:rPr lang="en-US" sz="1250" dirty="0">
                 <a:solidFill>
-                  <a:srgbClr val="2E2A28"/>
+                  <a:srgbClr val="16212E"/>
                 </a:solidFill>
                 <a:latin typeface="Calibri" pitchFamily="34" charset="0"/>
                 <a:ea typeface="Calibri" pitchFamily="34" charset="-122"/>
@@ -9331,7 +9331,7 @@
             <a:r>
               <a:rPr lang="en-US" sz="5000" b="1" dirty="0">
                 <a:solidFill>
-                  <a:srgbClr val="B85042"/>
+                  <a:srgbClr val="1D5C9B"/>
                 </a:solidFill>
                 <a:latin typeface="Cambria" pitchFamily="34" charset="0"/>
                 <a:ea typeface="Cambria" pitchFamily="34" charset="-122"/>
@@ -9370,7 +9370,7 @@
             <a:r>
               <a:rPr lang="en-US" sz="3600" b="1" dirty="0">
                 <a:solidFill>
-                  <a:srgbClr val="2E2A28"/>
+                  <a:srgbClr val="16212E"/>
                 </a:solidFill>
                 <a:latin typeface="Cambria" pitchFamily="34" charset="0"/>
                 <a:ea typeface="Cambria" pitchFamily="34" charset="-122"/>
@@ -9399,11 +9399,11 @@
             </a:avLst>
           </a:prstGeom>
           <a:solidFill>
-            <a:srgbClr val="F4F1EE"/>
+            <a:srgbClr val="F2F5F8"/>
           </a:solidFill>
           <a:ln w="12700">
             <a:solidFill>
-              <a:srgbClr val="E6E0DA"/>
+              <a:srgbClr val="E1E8EF"/>
             </a:solidFill>
             <a:prstDash val="solid"/>
           </a:ln>
@@ -9443,7 +9443,7 @@
             <a:r>
               <a:rPr lang="en-US" sz="1150" b="1" spc="200" kern="0" dirty="0">
                 <a:solidFill>
-                  <a:srgbClr val="7A736E"/>
+                  <a:srgbClr val="6B7787"/>
                 </a:solidFill>
                 <a:latin typeface="Calibri" pitchFamily="34" charset="0"/>
                 <a:ea typeface="Calibri" pitchFamily="34" charset="-122"/>
@@ -9485,7 +9485,7 @@
             <a:r>
               <a:rPr lang="en-US" sz="1450" dirty="0">
                 <a:solidFill>
-                  <a:srgbClr val="2E2A28"/>
+                  <a:srgbClr val="16212E"/>
                 </a:solidFill>
                 <a:latin typeface="Calibri" pitchFamily="34" charset="0"/>
                 <a:ea typeface="Calibri" pitchFamily="34" charset="-122"/>
@@ -9527,7 +9527,7 @@
             <a:r>
               <a:rPr lang="en-US" sz="1350" b="1" i="1" dirty="0">
                 <a:solidFill>
-                  <a:srgbClr val="B85042"/>
+                  <a:srgbClr val="1D5C9B"/>
                 </a:solidFill>
                 <a:latin typeface="Calibri" pitchFamily="34" charset="0"/>
                 <a:ea typeface="Calibri" pitchFamily="34" charset="-122"/>
@@ -9556,11 +9556,11 @@
             </a:avLst>
           </a:prstGeom>
           <a:solidFill>
-            <a:srgbClr val="E7E8D1"/>
+            <a:srgbClr val="DCE6F0"/>
           </a:solidFill>
           <a:ln w="12700">
             <a:solidFill>
-              <a:srgbClr val="D8DAC0"/>
+              <a:srgbClr val="C3D3E3"/>
             </a:solidFill>
             <a:prstDash val="solid"/>
           </a:ln>
@@ -9600,7 +9600,7 @@
             <a:r>
               <a:rPr lang="en-US" sz="1150" b="1" spc="200" kern="0" dirty="0">
                 <a:solidFill>
-                  <a:srgbClr val="6E7A5E"/>
+                  <a:srgbClr val="3E6488"/>
                 </a:solidFill>
                 <a:latin typeface="Calibri" pitchFamily="34" charset="0"/>
                 <a:ea typeface="Calibri" pitchFamily="34" charset="-122"/>
@@ -9642,7 +9642,7 @@
             <a:r>
               <a:rPr lang="en-US" sz="1450" dirty="0">
                 <a:solidFill>
-                  <a:srgbClr val="2E2A28"/>
+                  <a:srgbClr val="16212E"/>
                 </a:solidFill>
                 <a:latin typeface="Calibri" pitchFamily="34" charset="0"/>
                 <a:ea typeface="Calibri" pitchFamily="34" charset="-122"/>
@@ -9681,7 +9681,7 @@
             <a:r>
               <a:rPr lang="en-US" sz="1150" b="1" spc="200" kern="0" dirty="0">
                 <a:solidFill>
-                  <a:srgbClr val="B85042"/>
+                  <a:srgbClr val="1D5C9B"/>
                 </a:solidFill>
                 <a:latin typeface="Calibri" pitchFamily="34" charset="0"/>
                 <a:ea typeface="Calibri" pitchFamily="34" charset="-122"/>
@@ -9710,11 +9710,11 @@
             </a:avLst>
           </a:prstGeom>
           <a:solidFill>
-            <a:srgbClr val="FAF8F6"/>
+            <a:srgbClr val="F8FAFC"/>
           </a:solidFill>
           <a:ln w="12700">
             <a:solidFill>
-              <a:srgbClr val="E0D6D2"/>
+              <a:srgbClr val="DCE4EC"/>
             </a:solidFill>
             <a:prstDash val="solid"/>
           </a:ln>
@@ -9747,7 +9747,7 @@
             <a:r>
               <a:rPr lang="en-US" sz="1500" b="1" dirty="0">
                 <a:solidFill>
-                  <a:srgbClr val="B85042"/>
+                  <a:srgbClr val="1D5C9B"/>
                 </a:solidFill>
                 <a:latin typeface="Cambria" pitchFamily="34" charset="0"/>
                 <a:ea typeface="Cambria" pitchFamily="34" charset="-122"/>
@@ -9789,7 +9789,7 @@
             <a:r>
               <a:rPr lang="en-US" sz="1250" dirty="0">
                 <a:solidFill>
-                  <a:srgbClr val="2E2A28"/>
+                  <a:srgbClr val="16212E"/>
                 </a:solidFill>
                 <a:latin typeface="Calibri" pitchFamily="34" charset="0"/>
                 <a:ea typeface="Calibri" pitchFamily="34" charset="-122"/>
@@ -9818,11 +9818,11 @@
             </a:avLst>
           </a:prstGeom>
           <a:solidFill>
-            <a:srgbClr val="FAF8F6"/>
+            <a:srgbClr val="F8FAFC"/>
           </a:solidFill>
           <a:ln w="12700">
             <a:solidFill>
-              <a:srgbClr val="E0D6D2"/>
+              <a:srgbClr val="DCE4EC"/>
             </a:solidFill>
             <a:prstDash val="solid"/>
           </a:ln>
@@ -9855,7 +9855,7 @@
             <a:r>
               <a:rPr lang="en-US" sz="1500" b="1" dirty="0">
                 <a:solidFill>
-                  <a:srgbClr val="B85042"/>
+                  <a:srgbClr val="1D5C9B"/>
                 </a:solidFill>
                 <a:latin typeface="Cambria" pitchFamily="34" charset="0"/>
                 <a:ea typeface="Cambria" pitchFamily="34" charset="-122"/>
@@ -9897,7 +9897,7 @@
             <a:r>
               <a:rPr lang="en-US" sz="1250" dirty="0">
                 <a:solidFill>
-                  <a:srgbClr val="2E2A28"/>
+                  <a:srgbClr val="16212E"/>
                 </a:solidFill>
                 <a:latin typeface="Calibri" pitchFamily="34" charset="0"/>
                 <a:ea typeface="Calibri" pitchFamily="34" charset="-122"/>
@@ -9926,11 +9926,11 @@
             </a:avLst>
           </a:prstGeom>
           <a:solidFill>
-            <a:srgbClr val="FAF8F6"/>
+            <a:srgbClr val="F8FAFC"/>
           </a:solidFill>
           <a:ln w="12700">
             <a:solidFill>
-              <a:srgbClr val="E0D6D2"/>
+              <a:srgbClr val="DCE4EC"/>
             </a:solidFill>
             <a:prstDash val="solid"/>
           </a:ln>
@@ -9963,7 +9963,7 @@
             <a:r>
               <a:rPr lang="en-US" sz="1500" b="1" dirty="0">
                 <a:solidFill>
-                  <a:srgbClr val="B85042"/>
+                  <a:srgbClr val="1D5C9B"/>
                 </a:solidFill>
                 <a:latin typeface="Cambria" pitchFamily="34" charset="0"/>
                 <a:ea typeface="Cambria" pitchFamily="34" charset="-122"/>
@@ -10005,7 +10005,7 @@
             <a:r>
               <a:rPr lang="en-US" sz="1250" dirty="0">
                 <a:solidFill>
-                  <a:srgbClr val="2E2A28"/>
+                  <a:srgbClr val="16212E"/>
                 </a:solidFill>
                 <a:latin typeface="Calibri" pitchFamily="34" charset="0"/>
                 <a:ea typeface="Calibri" pitchFamily="34" charset="-122"/>
@@ -10076,7 +10076,7 @@
             <a:r>
               <a:rPr lang="en-US" sz="5000" b="1" dirty="0">
                 <a:solidFill>
-                  <a:srgbClr val="B85042"/>
+                  <a:srgbClr val="1D5C9B"/>
                 </a:solidFill>
                 <a:latin typeface="Cambria" pitchFamily="34" charset="0"/>
                 <a:ea typeface="Cambria" pitchFamily="34" charset="-122"/>
@@ -10115,7 +10115,7 @@
             <a:r>
               <a:rPr lang="en-US" sz="3600" b="1" dirty="0">
                 <a:solidFill>
-                  <a:srgbClr val="2E2A28"/>
+                  <a:srgbClr val="16212E"/>
                 </a:solidFill>
                 <a:latin typeface="Cambria" pitchFamily="34" charset="0"/>
                 <a:ea typeface="Cambria" pitchFamily="34" charset="-122"/>
@@ -10144,11 +10144,11 @@
             </a:avLst>
           </a:prstGeom>
           <a:solidFill>
-            <a:srgbClr val="F4F1EE"/>
+            <a:srgbClr val="F2F5F8"/>
           </a:solidFill>
           <a:ln w="12700">
             <a:solidFill>
-              <a:srgbClr val="E6E0DA"/>
+              <a:srgbClr val="E1E8EF"/>
             </a:solidFill>
             <a:prstDash val="solid"/>
           </a:ln>
@@ -10188,7 +10188,7 @@
             <a:r>
               <a:rPr lang="en-US" sz="1150" b="1" spc="200" kern="0" dirty="0">
                 <a:solidFill>
-                  <a:srgbClr val="7A736E"/>
+                  <a:srgbClr val="6B7787"/>
                 </a:solidFill>
                 <a:latin typeface="Calibri" pitchFamily="34" charset="0"/>
                 <a:ea typeface="Calibri" pitchFamily="34" charset="-122"/>
@@ -10230,7 +10230,7 @@
             <a:r>
               <a:rPr lang="en-US" sz="1450" dirty="0">
                 <a:solidFill>
-                  <a:srgbClr val="2E2A28"/>
+                  <a:srgbClr val="16212E"/>
                 </a:solidFill>
                 <a:latin typeface="Calibri" pitchFamily="34" charset="0"/>
                 <a:ea typeface="Calibri" pitchFamily="34" charset="-122"/>
@@ -10272,7 +10272,7 @@
             <a:r>
               <a:rPr lang="en-US" sz="1350" b="1" i="1" dirty="0">
                 <a:solidFill>
-                  <a:srgbClr val="B85042"/>
+                  <a:srgbClr val="1D5C9B"/>
                 </a:solidFill>
                 <a:latin typeface="Calibri" pitchFamily="34" charset="0"/>
                 <a:ea typeface="Calibri" pitchFamily="34" charset="-122"/>
@@ -10301,11 +10301,11 @@
             </a:avLst>
           </a:prstGeom>
           <a:solidFill>
-            <a:srgbClr val="E7E8D1"/>
+            <a:srgbClr val="DCE6F0"/>
           </a:solidFill>
           <a:ln w="12700">
             <a:solidFill>
-              <a:srgbClr val="D8DAC0"/>
+              <a:srgbClr val="C3D3E3"/>
             </a:solidFill>
             <a:prstDash val="solid"/>
           </a:ln>
@@ -10345,7 +10345,7 @@
             <a:r>
               <a:rPr lang="en-US" sz="1150" b="1" spc="200" kern="0" dirty="0">
                 <a:solidFill>
-                  <a:srgbClr val="6E7A5E"/>
+                  <a:srgbClr val="3E6488"/>
                 </a:solidFill>
                 <a:latin typeface="Calibri" pitchFamily="34" charset="0"/>
                 <a:ea typeface="Calibri" pitchFamily="34" charset="-122"/>
@@ -10387,7 +10387,7 @@
             <a:r>
               <a:rPr lang="en-US" sz="1450" dirty="0">
                 <a:solidFill>
-                  <a:srgbClr val="2E2A28"/>
+                  <a:srgbClr val="16212E"/>
                 </a:solidFill>
                 <a:latin typeface="Calibri" pitchFamily="34" charset="0"/>
                 <a:ea typeface="Calibri" pitchFamily="34" charset="-122"/>
@@ -10426,7 +10426,7 @@
             <a:r>
               <a:rPr lang="en-US" sz="1150" b="1" spc="200" kern="0" dirty="0">
                 <a:solidFill>
-                  <a:srgbClr val="B85042"/>
+                  <a:srgbClr val="1D5C9B"/>
                 </a:solidFill>
                 <a:latin typeface="Calibri" pitchFamily="34" charset="0"/>
                 <a:ea typeface="Calibri" pitchFamily="34" charset="-122"/>
@@ -10455,11 +10455,11 @@
             </a:avLst>
           </a:prstGeom>
           <a:solidFill>
-            <a:srgbClr val="FAF8F6"/>
+            <a:srgbClr val="F8FAFC"/>
           </a:solidFill>
           <a:ln w="12700">
             <a:solidFill>
-              <a:srgbClr val="E0D6D2"/>
+              <a:srgbClr val="DCE4EC"/>
             </a:solidFill>
             <a:prstDash val="solid"/>
           </a:ln>
@@ -10492,7 +10492,7 @@
             <a:r>
               <a:rPr lang="en-US" sz="1500" b="1" dirty="0">
                 <a:solidFill>
-                  <a:srgbClr val="B85042"/>
+                  <a:srgbClr val="1D5C9B"/>
                 </a:solidFill>
                 <a:latin typeface="Cambria" pitchFamily="34" charset="0"/>
                 <a:ea typeface="Cambria" pitchFamily="34" charset="-122"/>
@@ -10534,7 +10534,7 @@
             <a:r>
               <a:rPr lang="en-US" sz="1250" dirty="0">
                 <a:solidFill>
-                  <a:srgbClr val="2E2A28"/>
+                  <a:srgbClr val="16212E"/>
                 </a:solidFill>
                 <a:latin typeface="Calibri" pitchFamily="34" charset="0"/>
                 <a:ea typeface="Calibri" pitchFamily="34" charset="-122"/>
@@ -10563,11 +10563,11 @@
             </a:avLst>
           </a:prstGeom>
           <a:solidFill>
-            <a:srgbClr val="FAF8F6"/>
+            <a:srgbClr val="F8FAFC"/>
           </a:solidFill>
           <a:ln w="12700">
             <a:solidFill>
-              <a:srgbClr val="E0D6D2"/>
+              <a:srgbClr val="DCE4EC"/>
             </a:solidFill>
             <a:prstDash val="solid"/>
           </a:ln>
@@ -10600,7 +10600,7 @@
             <a:r>
               <a:rPr lang="en-US" sz="1500" b="1" dirty="0">
                 <a:solidFill>
-                  <a:srgbClr val="B85042"/>
+                  <a:srgbClr val="1D5C9B"/>
                 </a:solidFill>
                 <a:latin typeface="Cambria" pitchFamily="34" charset="0"/>
                 <a:ea typeface="Cambria" pitchFamily="34" charset="-122"/>
@@ -10642,7 +10642,7 @@
             <a:r>
               <a:rPr lang="en-US" sz="1250" dirty="0">
                 <a:solidFill>
-                  <a:srgbClr val="2E2A28"/>
+                  <a:srgbClr val="16212E"/>
                 </a:solidFill>
                 <a:latin typeface="Calibri" pitchFamily="34" charset="0"/>
                 <a:ea typeface="Calibri" pitchFamily="34" charset="-122"/>
@@ -10671,11 +10671,11 @@
             </a:avLst>
           </a:prstGeom>
           <a:solidFill>
-            <a:srgbClr val="FAF8F6"/>
+            <a:srgbClr val="F8FAFC"/>
           </a:solidFill>
           <a:ln w="12700">
             <a:solidFill>
-              <a:srgbClr val="E0D6D2"/>
+              <a:srgbClr val="DCE4EC"/>
             </a:solidFill>
             <a:prstDash val="solid"/>
           </a:ln>
@@ -10708,7 +10708,7 @@
             <a:r>
               <a:rPr lang="en-US" sz="1500" b="1" dirty="0">
                 <a:solidFill>
-                  <a:srgbClr val="B85042"/>
+                  <a:srgbClr val="1D5C9B"/>
                 </a:solidFill>
                 <a:latin typeface="Cambria" pitchFamily="34" charset="0"/>
                 <a:ea typeface="Cambria" pitchFamily="34" charset="-122"/>
@@ -10750,7 +10750,7 @@
             <a:r>
               <a:rPr lang="en-US" sz="1250" dirty="0">
                 <a:solidFill>
-                  <a:srgbClr val="2E2A28"/>
+                  <a:srgbClr val="16212E"/>
                 </a:solidFill>
                 <a:latin typeface="Calibri" pitchFamily="34" charset="0"/>
                 <a:ea typeface="Calibri" pitchFamily="34" charset="-122"/>

</xml_diff>

<commit_message>
Tighten wording across all slides
Plainer phrasing throughout the CRAAP strips, output cards and closing
slides. Two substantive changes carried through: the muscle-activity
verdict is now Overstated rather than Qualified (12-27% against the
claimed 15-30%), and the final CRAAP Currency row cites only the single
2023 study actually traced.

Co-Authored-By: Claude Opus 5 <noreply@anthropic.com>
Claude-Session: https://claude.ai/code/session_01QGa9ZiBbTVxLmBFpqCsLHX
</commit_message>
<xml_diff>
--- a/Followmont-Prompt-Chain.pptx
+++ b/Followmont-Prompt-Chain.pptx
@@ -2688,7 +2688,7 @@
                 <a:ea typeface="Calibri" pitchFamily="34" charset="-122"/>
                 <a:cs typeface="Calibri" pitchFamily="34" charset="-120"/>
               </a:rPr>
-              <a:t>Qualified — passive devices cut muscle activity 12–27%, but in a French laboratory, not a depot, and results varied widely between individuals</a:t>
+              <a:t>Overstated — passive devices cut muscle activity 12–27%, not 15–30%. French lab, not a depot, and results varied a lot between individuals</a:t>
             </a:r>
             <a:endParaRPr lang="en-US" sz="1200" dirty="0"/>
           </a:p>
@@ -2841,7 +2841,7 @@
                 <a:ea typeface="Calibri" pitchFamily="34" charset="-122"/>
                 <a:cs typeface="Calibri" pitchFamily="34" charset="-120"/>
               </a:rPr>
-              <a:t>Not supported — neither publishes a unit price; SpanSet quotes only through a rental credited to purchase</a:t>
+              <a:t>Not supported — neither publishes a price. SpanSet only quotes through a rental that credits toward purchase.</a:t>
             </a:r>
             <a:endParaRPr lang="en-US" sz="1200" dirty="0"/>
           </a:p>
@@ -3251,7 +3251,7 @@
                 <a:ea typeface="Calibri" pitchFamily="34" charset="-122"/>
                 <a:cs typeface="Calibri" pitchFamily="34" charset="-120"/>
               </a:rPr>
-              <a:t>The briefing carries no date of its own, and years appeared only where I forced them. The exoskeleton studies I could trace run 2021–2025, straddling the post-2022 line I set.</a:t>
+              <a:t>The briefing has no date of its own, and years only appeared when I pushed. The one study I could trace is from 2023.</a:t>
             </a:r>
             <a:endParaRPr lang="en-US" sz="1350" dirty="0"/>
           </a:p>
@@ -3359,7 +3359,7 @@
                 <a:ea typeface="Calibri" pitchFamily="34" charset="-122"/>
                 <a:cs typeface="Calibri" pitchFamily="34" charset="-120"/>
               </a:rPr>
-              <a:t>It assumes the depot conditions I supplied; it verified none of them. It does answer the decision in front of the leadership team, at the length they would read.</a:t>
+              <a:t>It assumes the depot conditions I supplied; it verified none of them. It does answer the decision the leadership team faces, at a length they'd read.</a:t>
             </a:r>
             <a:endParaRPr lang="en-US" sz="1350" dirty="0"/>
           </a:p>
@@ -3467,7 +3467,7 @@
                 <a:ea typeface="Calibri" pitchFamily="34" charset="-122"/>
                 <a:cs typeface="Calibri" pitchFamily="34" charset="-120"/>
               </a:rPr>
-              <a:t>Rests on vendor material and overseas trials. No NHVR, no Safe Work Australia, no Australian regulator appears unless I name one.</a:t>
+              <a:t>Built on vendor material and overseas trials. No NHVR, no Safe Work Australia — no Australian regulator appears unless I name one.</a:t>
             </a:r>
             <a:endParaRPr lang="en-US" sz="1350" dirty="0"/>
           </a:p>
@@ -3575,7 +3575,7 @@
                 <a:ea typeface="Calibri" pitchFamily="34" charset="-122"/>
                 <a:cs typeface="Calibri" pitchFamily="34" charset="-120"/>
               </a:rPr>
-              <a:t>Checked independently, the muscle-activity range broadly holds but the costing does not — no Australian supplier publishes a price in that band. Unsupported figures stayed in, labelled.</a:t>
+              <a:t>When I checked, the muscle-activity range was overstated — 12–27%, not 15–30%. The costing failed completely: no Australian supplier publishes a price in that band.</a:t>
             </a:r>
             <a:endParaRPr lang="en-US" sz="1350" dirty="0"/>
           </a:p>
@@ -3683,7 +3683,7 @@
                 <a:ea typeface="Calibri" pitchFamily="34" charset="-122"/>
                 <a:cs typeface="Calibri" pitchFamily="34" charset="-120"/>
               </a:rPr>
-              <a:t>Written to persuade a board to fund a trial. That is the real risk in it — a confident register applied to evidence that does not yet earn it.</a:t>
+              <a:t>Written to persuade a board to fund a trial. That's the real risk: it sounds certain about evidence that isn't strong enough yet.</a:t>
             </a:r>
             <a:endParaRPr lang="en-US" sz="1350" dirty="0"/>
           </a:p>
@@ -4300,7 +4300,7 @@
                 <a:ea typeface="Calibri" pitchFamily="34" charset="-122"/>
                 <a:cs typeface="Calibri" pitchFamily="34" charset="-120"/>
               </a:rPr>
-              <a:t>The barrier is real and independently confirmed. The technology is not yet proven for Australian road freight — laboratory evidence from overseas, and a price range no Australian supplier supports. Trial it at one depot for six months against two measures baselined before the start: body-stressing claims and time-loss days. That turns an unproven recommendation into something Followmont can actually test.</a:t>
+              <a:t>The barrier is real — I confirmed that myself. The technology is not yet proven for Australian road freight — the evidence comes from overseas labs, and no Australian supplier supports the price range. Trial it at one depot for six months against two measures recorded before it starts: body-stressing claims and time-loss days. That turns an unproven recommendation into something Followmont can actually test.</a:t>
             </a:r>
             <a:endParaRPr lang="en-US" sz="1350" dirty="0"/>
           </a:p>
@@ -5474,7 +5474,7 @@
                 <a:ea typeface="Calibri" pitchFamily="34" charset="-122"/>
                 <a:cs typeface="Calibri" pitchFamily="34" charset="-120"/>
               </a:rPr>
-              <a:t>What I validated independently, and what I recommend to Followmont</a:t>
+              <a:t>What I checked myself, and what I recommend to Followmont</a:t>
             </a:r>
             <a:endParaRPr lang="en-US" sz="1550" dirty="0"/>
           </a:p>
@@ -5616,7 +5616,7 @@
                 <a:ea typeface="Calibri" pitchFamily="34" charset="-122"/>
                 <a:cs typeface="Calibri" pitchFamily="34" charset="-120"/>
               </a:rPr>
-              <a:t>Its drivers and dock staff are ageing. The physical side of the job — lifting freight, climbing in and out of the cab — pushes experienced people out of operational roles before they would otherwise choose to leave.</a:t>
+              <a:t>Its drivers and dock staff are ageing. The physical side of the job — lifting freight, climbing in and out of the cab — pushes experienced people out of the job before they're ready to go.</a:t>
             </a:r>
             <a:endParaRPr lang="en-US" sz="1700" dirty="0"/>
           </a:p>
@@ -7031,7 +7031,7 @@
                 <a:ea typeface="Calibri" pitchFamily="34" charset="-122"/>
                 <a:cs typeface="Calibri" pitchFamily="34" charset="-120"/>
               </a:rPr>
-              <a:t>The point of the chain is the gap between the steps — what changes when you add detail, and what only changes when you ask for evidence.</a:t>
+              <a:t>What matters is what changed between steps — what detail fixed, and what only pressure fixed.</a:t>
             </a:r>
             <a:endParaRPr lang="en-US" sz="1550" dirty="0"/>
           </a:p>
@@ -7413,7 +7413,7 @@
                 <a:ea typeface="Calibri" pitchFamily="34" charset="-122"/>
                 <a:cs typeface="Calibri" pitchFamily="34" charset="-120"/>
               </a:rPr>
-              <a:t>A usable method, and one admission worth keeping: it can produce citations that look right and aren't. Most of what it offered came from vendor prompt-engineering guides and from describing its own behaviour.</a:t>
+              <a:t>A usable method, and one useful admission: it can produce citations that look right and aren't. Most of its advice came from vendor guides and from describing itself.</a:t>
             </a:r>
             <a:endParaRPr lang="en-US" sz="1450" dirty="0"/>
           </a:p>
@@ -7560,7 +7560,7 @@
                 <a:ea typeface="Calibri" pitchFamily="34" charset="-122"/>
                 <a:cs typeface="Calibri" pitchFamily="34" charset="-120"/>
               </a:rPr>
-              <a:t>Leans on vendor documentation and self-description, not independent research.</a:t>
+              <a:t>Based on vendor guides and its own self-description — not independent research.</a:t>
             </a:r>
             <a:endParaRPr lang="en-US" sz="1250" dirty="0"/>
           </a:p>
@@ -7668,7 +7668,7 @@
                 <a:ea typeface="Calibri" pitchFamily="34" charset="-122"/>
                 <a:cs typeface="Calibri" pitchFamily="34" charset="-120"/>
               </a:rPr>
-              <a:t>Vendor guides exist to promote the tool — useful, but not neutral.</a:t>
+              <a:t>Vendor guides exist to sell the tool. Useful, but not neutral.</a:t>
             </a:r>
             <a:endParaRPr lang="en-US" sz="1250" dirty="0"/>
           </a:p>
@@ -7776,7 +7776,7 @@
                 <a:ea typeface="Calibri" pitchFamily="34" charset="-122"/>
                 <a:cs typeface="Calibri" pitchFamily="34" charset="-120"/>
               </a:rPr>
-              <a:t>Prompt-design guidance shifts with every model release; undated advice ages fast.</a:t>
+              <a:t>Advice about prompting changes with every new model. Undated advice goes stale fast.</a:t>
             </a:r>
             <a:endParaRPr lang="en-US" sz="1250" dirty="0"/>
           </a:p>
@@ -8158,7 +8158,7 @@
                 <a:ea typeface="Calibri" pitchFamily="34" charset="-122"/>
                 <a:cs typeface="Calibri" pitchFamily="34" charset="-120"/>
               </a:rPr>
-              <a:t>Six interventions: ergonomic wearables, predictive fatigue management, workforce analytics, knowledge capture, adaptive interfaces and phased retirement. None tied to a country, an employer or a product, and not one figure, date or source to check.</a:t>
+              <a:t>Six interventions: ergonomic wearables, predictive fatigue management, workforce analytics, knowledge capture, adaptive interfaces and phased retirement. None tied to a country, a company or a product, and not one figure, date or source to check.</a:t>
             </a:r>
             <a:endParaRPr lang="en-US" sz="1450" dirty="0"/>
           </a:p>
@@ -8413,7 +8413,7 @@
                 <a:ea typeface="Calibri" pitchFamily="34" charset="-122"/>
                 <a:cs typeface="Calibri" pitchFamily="34" charset="-120"/>
               </a:rPr>
-              <a:t>No figures and no sources — the claims cannot be verified either way.</a:t>
+              <a:t>No figures and no sources. There's nothing to check.</a:t>
             </a:r>
             <a:endParaRPr lang="en-US" sz="1250" dirty="0"/>
           </a:p>
@@ -8521,7 +8521,7 @@
                 <a:ea typeface="Calibri" pitchFamily="34" charset="-122"/>
                 <a:cs typeface="Calibri" pitchFamily="34" charset="-120"/>
               </a:rPr>
-              <a:t>Undated throughout; the same list would read the same in 2015.</a:t>
+              <a:t>No dates anywhere. The same list would have read the same in 2015.</a:t>
             </a:r>
             <a:endParaRPr lang="en-US" sz="1250" dirty="0"/>
           </a:p>
@@ -8903,7 +8903,7 @@
                 <a:ea typeface="Calibri" pitchFamily="34" charset="-122"/>
                 <a:cs typeface="Calibri" pitchFamily="34" charset="-120"/>
               </a:rPr>
-              <a:t>Exoskeletons for manual freight handling — five commercial vendors named, a price range attached, and the case argued across evidence, barriers, enablers and business case. Still not one source, and still no Australian regulation.</a:t>
+              <a:t>Exoskeletons for manual freight handling — five commercial vendors named, a price range attached, and a full case covering evidence, barriers, enablers and cost. Still not one source, and still no Australian regulation.</a:t>
             </a:r>
             <a:endParaRPr lang="en-US" sz="1450" dirty="0"/>
           </a:p>
@@ -9050,7 +9050,7 @@
                 <a:ea typeface="Calibri" pitchFamily="34" charset="-122"/>
                 <a:cs typeface="Calibri" pitchFamily="34" charset="-120"/>
               </a:rPr>
-              <a:t>The operation is now right; the evidence behind it stayed generic.</a:t>
+              <a:t>It got the company right. The evidence stayed generic.</a:t>
             </a:r>
             <a:endParaRPr lang="en-US" sz="1250" dirty="0"/>
           </a:p>
@@ -9158,7 +9158,7 @@
                 <a:ea typeface="Calibri" pitchFamily="34" charset="-122"/>
                 <a:cs typeface="Calibri" pitchFamily="34" charset="-120"/>
               </a:rPr>
-              <a:t>Precise figures appeared — 15–30% muscle activity, A$1,500–5,000 — with nothing behind them.</a:t>
+              <a:t>Exact figures appeared — 15–30% muscle activity, A$1,500–5,000 — with nothing behind them.</a:t>
             </a:r>
             <a:endParaRPr lang="en-US" sz="1250" dirty="0"/>
           </a:p>
@@ -9266,7 +9266,7 @@
                 <a:ea typeface="Calibri" pitchFamily="34" charset="-122"/>
                 <a:cs typeface="Calibri" pitchFamily="34" charset="-120"/>
               </a:rPr>
-              <a:t>Five commercial vendors named and none independently verified — it reads like a product recommendation.</a:t>
+              <a:t>Five vendors named, none checked. It reads like a product recommendation.</a:t>
             </a:r>
             <a:endParaRPr lang="en-US" sz="1250" dirty="0"/>
           </a:p>
@@ -9648,7 +9648,7 @@
                 <a:ea typeface="Calibri" pitchFamily="34" charset="-122"/>
                 <a:cs typeface="Calibri" pitchFamily="34" charset="-120"/>
               </a:rPr>
-              <a:t>Some claims came back with a study and a year attached. Others came back with an admission that no source existed. It also conceded it had ignored the Australian regulatory setting entirely.</a:t>
+              <a:t>Some claims came back with a study and a year attached. Others came back with an admission that no source existed. It also admitted it had ignored Australian regulation completely.</a:t>
             </a:r>
             <a:endParaRPr lang="en-US" sz="1450" dirty="0"/>
           </a:p>
@@ -9795,7 +9795,7 @@
                 <a:ea typeface="Calibri" pitchFamily="34" charset="-122"/>
                 <a:cs typeface="Calibri" pitchFamily="34" charset="-120"/>
               </a:rPr>
-              <a:t>Sourcing only appeared under pressure; some numbers could not be supported at all.</a:t>
+              <a:t>It only gave sources when I pushed. Some numbers had none at all.</a:t>
             </a:r>
             <a:endParaRPr lang="en-US" sz="1250" dirty="0"/>
           </a:p>
@@ -9903,7 +9903,7 @@
                 <a:ea typeface="Calibri" pitchFamily="34" charset="-122"/>
                 <a:cs typeface="Calibri" pitchFamily="34" charset="-120"/>
               </a:rPr>
-              <a:t>What did arrive skewed to vendors and overseas studies, not Australian regulators.</a:t>
+              <a:t>The sources it gave were mostly vendors and overseas studies. No Australian regulators.</a:t>
             </a:r>
             <a:endParaRPr lang="en-US" sz="1250" dirty="0"/>
           </a:p>
@@ -10011,7 +10011,7 @@
                 <a:ea typeface="Calibri" pitchFamily="34" charset="-122"/>
                 <a:cs typeface="Calibri" pitchFamily="34" charset="-120"/>
               </a:rPr>
-              <a:t>Publication years surfaced only once I demanded them explicitly.</a:t>
+              <a:t>Years only appeared when I asked for them directly.</a:t>
             </a:r>
             <a:endParaRPr lang="en-US" sz="1250" dirty="0"/>
           </a:p>
@@ -10393,7 +10393,7 @@
                 <a:ea typeface="Calibri" pitchFamily="34" charset="-122"/>
                 <a:cs typeface="Calibri" pitchFamily="34" charset="-120"/>
               </a:rPr>
-              <a:t>A one-page briefing a manager could act on — recommendation, indicative cost, risks and a measurement plan — with the weak evidence still labelled weak rather than quietly dropped.</a:t>
+              <a:t>A one-page briefing a manager could act on — recommendation, rough cost, risks and a measurement plan — with the weak evidence still labelled weak, not quietly dropped.</a:t>
             </a:r>
             <a:endParaRPr lang="en-US" sz="1450" dirty="0"/>
           </a:p>
@@ -10540,7 +10540,7 @@
                 <a:ea typeface="Calibri" pitchFamily="34" charset="-122"/>
                 <a:cs typeface="Calibri" pitchFamily="34" charset="-120"/>
               </a:rPr>
-              <a:t>Written to persuade a board to fund a trial; the tone runs ahead of the evidence.</a:t>
+              <a:t>Written to sell a trial to a board. It sounds more certain than the evidence allows.</a:t>
             </a:r>
             <a:endParaRPr lang="en-US" sz="1250" dirty="0"/>
           </a:p>
@@ -10648,7 +10648,7 @@
                 <a:ea typeface="Calibri" pitchFamily="34" charset="-122"/>
                 <a:cs typeface="Calibri" pitchFamily="34" charset="-120"/>
               </a:rPr>
-              <a:t>Fits the decision Followmont actually faces, at the length they would actually read.</a:t>
+              <a:t>It fits the decision Followmont actually faces, at a length they'd actually read.</a:t>
             </a:r>
             <a:endParaRPr lang="en-US" sz="1250" dirty="0"/>
           </a:p>
@@ -10756,7 +10756,7 @@
                 <a:ea typeface="Calibri" pitchFamily="34" charset="-122"/>
                 <a:cs typeface="Calibri" pitchFamily="34" charset="-120"/>
               </a:rPr>
-              <a:t>Gaps stayed visible — but only because I instructed it to keep them.</a:t>
+              <a:t>The gaps stayed in — but only because I told it to.</a:t>
             </a:r>
             <a:endParaRPr lang="en-US" sz="1250" dirty="0"/>
           </a:p>

</xml_diff>

<commit_message>
Add teleprompter speaker notes to every slide
Each slide's notes now carry a running time window, a one-line statement
of what the slide has to accomplish, a near-verbatim script marked with
curly quotes, and a delivery cue. Scripts are paced at roughly 140 words
per minute for a total runtime of about eight minutes; slide 13 is
scripted as silence.

Co-Authored-By: Claude Opus 5 <noreply@anthropic.com>
Claude-Session: https://claude.ai/code/session_01QGa9ZiBbTVxLmBFpqCsLHX
</commit_message>
<xml_diff>
--- a/Followmont-Prompt-Chain.pptx
+++ b/Followmont-Prompt-Chain.pptx
@@ -514,7 +514,9 @@
           <a:p>
             <a:r>
               <a:rPr lang="en-US" dirty="0"/>
-              <a:t>Open here. One sentence on what the assessment asked for, then move on.</a:t>
+              <a:t>[0:00-0:10]  TITLE - identify yourself, then move.
+“Hi, I'm Daniel Franco Gomez, student number n12854468. This is Assignment 1 for BSB105, The Future Enterprise - an oral critique of AI-generated content, built around a real client problem from Followmont Transport.”
+CUE: Do not explain the deck or preview your argument. Name it and go.</a:t>
             </a:r>
             <a:endParaRPr lang="en-US" dirty="0"/>
           </a:p>
@@ -602,7 +604,12 @@
           <a:p>
             <a:r>
               <a:rPr lang="en-US" dirty="0"/>
-              <a:t>This is the validation slide. Land row 3 and row 4 hardest — the price range is not supported by either Australian supplier, and the 55+ block collapses two very different participation rates.</a:t>
+              <a:t>[5:10-6:10]  CHECKING IT MYSELF - your work, not the AI's. Rows 3 and 4 in full.
+“Everything so far is the AI admitting things. That's its work, not mine. So I checked four of its claims myself.
+The first two quickly. Manual handling: confirmed - Safe Work Australia puts body stressing at thirty-four and a half percent of serious claims. The muscle-activity figure: overstated - the study says twelve to twenty-seven percent, not fifteen to thirty, and it's a French laboratory, not a depot.
+Row three, the price. Fifteen hundred to five thousand dollars. I checked both Australian suppliers, SpanSet and Exxovantage. Neither publishes a price at all - SpanSet only quotes through a rental that credits toward purchase. So that number isn't just unsourced. It's unsupported.
+And row four. The AI treated fifty-five plus as one group. The Australian data doesn't. Participation is sixty-nine point six percent at fifty-five to sixty-four - and sixteen point three percent at sixty-five plus. One label. Two completely different problems.”
+CUE: This slide is your HD evidence. Rows 1-2 gestured at, 3-4 spoken in full. End on 'two different problems' and stop.</a:t>
             </a:r>
             <a:endParaRPr lang="en-US" dirty="0"/>
           </a:p>
@@ -690,7 +697,14 @@
           <a:p>
             <a:r>
               <a:rPr lang="en-US" dirty="0"/>
-              <a:t>Tutorial 3 asks for the full five elements on the final output. This is that slide — take it slowly, one element at a time.</a:t>
+              <a:t>[6:10-7:10]  CRAAP ON THE FINAL BRIEFING - all five named. Slow on Authority and Purpose.
+“Now all five elements, applied to the final briefing - the document Followmont would actually read.
+Currency: it has no date of its own, and years only appeared when I pushed. The one study I could trace is from 2023.
+Relevance: it assumes the depot conditions I gave it, and verified none of them.
+Authority - this is the important one. It's built on vendor material and overseas trials. No NHVR. No Safe Work Australia. No Australian regulator appears anywhere unless I name it first. For a question about Australian road freight, that's a serious gap.
+Accuracy: the muscle-activity range was overstated, and the costing failed completely.
+And Purpose. This is written to persuade a board to fund a trial. That's the real risk in it - it sounds certain about evidence that isn't strong enough yet. Fluency is not reliability.”
+CUE: Name each element before its finding. Slow deliberately on Authority and Purpose.</a:t>
             </a:r>
             <a:endParaRPr lang="en-US" dirty="0"/>
           </a:p>
@@ -778,7 +792,12 @@
           <a:p>
             <a:r>
               <a:rPr lang="en-US" dirty="0"/>
-              <a:t>This answers the assignment's actual question: can Followmont move ahead? Yes — conditionally, and the conditions come from the CRAAP findings.</a:t>
+              <a:t>[7:10-7:55]  CONCLUSION - the two-line finding, then the recommendation and its conditions.
+“So: detail changed how the answer sounded. Pressure changed what it could prove.
+The generic answer was fluent and unusable. The specific answer was confident and still unsourced. Only the direct challenge separated evidence from filler.
+My recommendation to Followmont: proceed - but to a trial, not a rollout. The barrier is real; I confirmed that myself. The technology isn't proven here - the evidence comes from overseas labs, and no Australian supplier supports the price range.
+So: one depot, six months, and two measures recorded before it starts - body-stressing claims and time-loss days. That turns an unproven recommendation into something Followmont can actually test.”
+CUE: This is your last spoken slide. Land the recommendation and the two measures, then stop.</a:t>
             </a:r>
             <a:endParaRPr lang="en-US" dirty="0"/>
           </a:p>
@@ -866,7 +885,9 @@
           <a:p>
             <a:r>
               <a:rPr lang="en-US" dirty="0"/>
-              <a:t>Do not read this slide aloud. Leave it on screen while you close. If asked, the AI transcript is retained and can be provided.</a:t>
+              <a:t>[7:55-end]  REFERENCES - silence.
+Say nothing. Leave the slide up for three to five seconds and end the recording.
+CUE: Do not read references aloud. Do not add a thank-you or a sign-off ramble - the recommendation on slide 12 is your ending. If asked, the AI transcript is retained and available on request.</a:t>
             </a:r>
             <a:endParaRPr lang="en-US" dirty="0"/>
           </a:p>
@@ -954,7 +975,10 @@
           <a:p>
             <a:r>
               <a:rPr lang="en-US" dirty="0"/>
-              <a:t>Fifteen seconds. Point at item 3 — the CRAAP evaluation runs through every prompt slide, not just at the end.</a:t>
+              <a:t>[0:10-0:25]  AGENDA - four words, then one flag.
+“Four parts. Purpose, prompts, CRAAP, conclusion.
+One thing to flag up front: CRAAP isn't a section at the end. It runs through every single prompt slide - Currency, Relevance, Authority, Accuracy and Purpose, applied at every step of the chain.”
+CUE: Gesture at item 3 as you say it. Don't read the four descriptions aloud.</a:t>
             </a:r>
             <a:endParaRPr lang="en-US" dirty="0"/>
           </a:p>
@@ -1042,7 +1066,13 @@
           <a:p>
             <a:r>
               <a:rPr lang="en-US" dirty="0"/>
-              <a:t>Read the provocation aloud, word for word. It is the client's wording, not mine — note that it says participation, which is broader than retention.</a:t>
+              <a:t>[0:25-1:25]  CLIENT - one sentence, the provocation verbatim, then the participation point.
+“Followmont Transport is a family-owned Australian road freight operator - around a thousand people, twenty-six depots, line-haul and local delivery across regional Queensland and northern New South Wales.
+Their workforce is ageing, and the physical side of the job - lifting freight, climbing in and out of the cab - pushes experienced people out before they're ready to go.
+Here is their provocation, word for word:
+'How might we harness data and technology to improve the workforce participation of transport and logistics workers aged fifty-five and over?'
+Notice the word participation. That's wider than retention. Retention is keeping the people you already have. Participation also covers who can get in, who can stay, and who can come back. Hold onto that - it becomes one of my findings later, because the AI quietly narrowed it.”
+CUE: Slow down for the quote. It is the client's wording, not yours - that's the point.</a:t>
             </a:r>
             <a:endParaRPr lang="en-US" dirty="0"/>
           </a:p>
@@ -1130,7 +1160,11 @@
           <a:p>
             <a:r>
               <a:rPr lang="en-US" dirty="0"/>
-              <a:t>This is the map slide. Everything after it is one step of this row.</a:t>
+              <a:t>[1:25-1:45]  THE CHAIN - this is a map. Do not explain any step yet.
+“This is the map. Five prompts, one conversation, nothing restarted.
+Set the method. Ask it badly. Add the client. Ask for receipts. Make it useful.
+I'm not going to explain them yet - because the interesting part isn't any single prompt. It's what changed between them.”
+CUE: Name the five fast, in rhythm. Resist the urge to elaborate - every step gets its own slide.</a:t>
             </a:r>
             <a:endParaRPr lang="en-US" dirty="0"/>
           </a:p>
@@ -1218,7 +1252,11 @@
           <a:p>
             <a:r>
               <a:rPr lang="en-US" dirty="0"/>
-              <a:t>Explain why the first prompt is not about the client at all. The forced disclosure in the quote is what makes the Authority finding possible.</a:t>
+              <a:t>[1:45-2:25]  PROMPT 01 - why the first prompt isn't about the client. CRAAP point: AUTHORITY.
+“Prompt one isn't about Followmont at all. Before I gave it a client, I wanted to know what I was working with - what makes a prompt well designed, what it does badly when I ask for research with citations, and how to sequence prompts so each builds on the last.
+The line that did the work is on screen. I made it disclose where its answer came from. And it told me: most of its advice came from vendor guides, and from describing itself.
+That's my Authority finding. It isn't independent research. It's the companies that sell these tools, plus the tool talking about its own behaviour.”
+CUE: Read the blue quote aloud. Say Authority out loud - name the element.</a:t>
             </a:r>
             <a:endParaRPr lang="en-US" dirty="0"/>
           </a:p>
@@ -1306,7 +1344,13 @@
           <a:p>
             <a:r>
               <a:rPr lang="en-US" dirty="0"/>
-              <a:t>Stress that this was deliberate. It is the control, not a mistake — without it there is nothing to compare Prompt 3 against.</a:t>
+              <a:t>[2:25-3:05]  PROMPT 02 - this was deliberate. It's the control. CRAAP point: RELEVANCE.
+“This one looks lazy. It isn't.
+This is the client's question asked cold - no country, no company, no constraints, no source demand. That was deliberate. This is my control.
+Six interventions came back: ergonomic wearables, predictive fatigue management, workforce analytics, knowledge capture, adaptive interfaces, phased retirement.
+Relevance: none of it is specific to Australia, to road freight, or to Followmont. It's a perfectly reasonable answer to nobody's question.
+But without this slide I have nothing to compare the next one against.”
+CUE: Land 'that was deliberate' clearly - a marker must not read this as a weak prompt.</a:t>
             </a:r>
             <a:endParaRPr lang="en-US" dirty="0"/>
           </a:p>
@@ -1394,7 +1438,14 @@
           <a:p>
             <a:r>
               <a:rPr lang="en-US" dirty="0"/>
-              <a:t>The key move: blocking the tech they already run forces new reasoning. Read the two quoted constraints aloud — they are the reason the answer is checkable at all.</a:t>
+              <a:t>[3:05-3:50]  PROMPT 03 - the key move is blocking their existing tech. CRAAP point: ACCURACY.
+“Now I give it the real client - and here's the move that matters. I named the technology Followmont already runs and blocked it. It can't recommend what they've already bought, so it has to actually reason about this operation.
+Two constraints, and I'll read them both:
+'Name something specific enough that I could search for vendors.'
+'Where your evidence comes from outside Australia, say so.'
+It came back with exoskeletons. Five vendors. A price range. A full case.
+Accuracy: exact figures - fifteen to thirty percent muscle activity, fifteen hundred to five thousand dollars - with nothing behind them. The detail went up. The evidence didn't.”
+CUE: Both quotes aloud, they demonstrate prompt craft. Land the last sentence hard.</a:t>
             </a:r>
             <a:endParaRPr lang="en-US" dirty="0"/>
           </a:p>
@@ -1482,7 +1533,13 @@
           <a:p>
             <a:r>
               <a:rPr lang="en-US" dirty="0"/>
-              <a:t>This is the slide that carries the argument. Slow down. The permission to fail — 'just say so' — is what produced the honest answer.</a:t>
+              <a:t>[3:50-4:35]  PROMPT 04 - the turn. Permission to fail is what produced honesty. CRAAP point: ACCURACY.
+“This is the turn in the whole chain.
+I asked for a source behind every number. And critically, I gave it permission to fail:
+'If you can't find a source for something, just say so. Don't give me a source that's close enough.'
+That line is what produced honesty. Some claims came back with a study and a year attached. Others came back with an admission that no source existed at all. And it conceded it had ignored Australian regulation completely.
+Accuracy again: it only gave sources when I pushed. Adding detail in prompt three didn't do it. Pressure did.”
+CUE: Slowest slide in the deck. This is the argument - give it room.</a:t>
             </a:r>
             <a:endParaRPr lang="en-US" dirty="0"/>
           </a:p>
@@ -1570,7 +1627,11 @@
           <a:p>
             <a:r>
               <a:rPr lang="en-US" dirty="0"/>
-              <a:t>Close the chain. Note that honesty had to be requested; it was never volunteered.</a:t>
+              <a:t>[4:35-5:10]  PROMPT 05 - close the chain. Honesty had to be asked for.
+“Last prompt: make it usable. One page for Followmont's leadership - recommendation, rough cost, risks, and what they'd measure.
+And I told it not to smooth over the gaps it had just admitted to me. It didn't. The weak evidence stayed labelled weak.
+But notice what that means. I had to ask. Across all five prompts, honesty was never volunteered - every single time, it had to be requested.”
+CUE: 'I had to ask' is the line. Pause after it before moving on.</a:t>
             </a:r>
             <a:endParaRPr lang="en-US" dirty="0"/>
           </a:p>

</xml_diff>